<commit_message>
Automaton models, executions, reachability.
</commit_message>
<xml_diff>
--- a/Slides/2025/L2_ModelingComputation.pptx
+++ b/Slides/2025/L2_ModelingComputation.pptx
@@ -5,7 +5,7 @@
     <p:sldMasterId id="2147483648" r:id="rId1"/>
   </p:sldMasterIdLst>
   <p:notesMasterIdLst>
-    <p:notesMasterId r:id="rId34"/>
+    <p:notesMasterId r:id="rId35"/>
   </p:notesMasterIdLst>
   <p:sldIdLst>
     <p:sldId id="324" r:id="rId2"/>
@@ -21,25 +21,26 @@
     <p:sldId id="312" r:id="rId12"/>
     <p:sldId id="344" r:id="rId13"/>
     <p:sldId id="313" r:id="rId14"/>
-    <p:sldId id="331" r:id="rId15"/>
-    <p:sldId id="332" r:id="rId16"/>
-    <p:sldId id="333" r:id="rId17"/>
-    <p:sldId id="342" r:id="rId18"/>
-    <p:sldId id="314" r:id="rId19"/>
+    <p:sldId id="314" r:id="rId15"/>
+    <p:sldId id="331" r:id="rId16"/>
+    <p:sldId id="332" r:id="rId17"/>
+    <p:sldId id="333" r:id="rId18"/>
+    <p:sldId id="342" r:id="rId19"/>
     <p:sldId id="318" r:id="rId20"/>
     <p:sldId id="315" r:id="rId21"/>
     <p:sldId id="319" r:id="rId22"/>
     <p:sldId id="320" r:id="rId23"/>
-    <p:sldId id="321" r:id="rId24"/>
-    <p:sldId id="335" r:id="rId25"/>
-    <p:sldId id="307" r:id="rId26"/>
-    <p:sldId id="322" r:id="rId27"/>
-    <p:sldId id="338" r:id="rId28"/>
-    <p:sldId id="337" r:id="rId29"/>
-    <p:sldId id="339" r:id="rId30"/>
-    <p:sldId id="340" r:id="rId31"/>
-    <p:sldId id="323" r:id="rId32"/>
-    <p:sldId id="293" r:id="rId33"/>
+    <p:sldId id="345" r:id="rId24"/>
+    <p:sldId id="321" r:id="rId25"/>
+    <p:sldId id="335" r:id="rId26"/>
+    <p:sldId id="307" r:id="rId27"/>
+    <p:sldId id="322" r:id="rId28"/>
+    <p:sldId id="338" r:id="rId29"/>
+    <p:sldId id="337" r:id="rId30"/>
+    <p:sldId id="339" r:id="rId31"/>
+    <p:sldId id="340" r:id="rId32"/>
+    <p:sldId id="323" r:id="rId33"/>
+    <p:sldId id="293" r:id="rId34"/>
   </p:sldIdLst>
   <p:sldSz cx="12192000" cy="6858000"/>
   <p:notesSz cx="6858000" cy="9144000"/>
@@ -1221,7 +1222,7 @@
             <a:fld id="{478875BD-0904-456D-BF1F-B156B76088E4}" type="slidenum">
               <a:rPr lang="en-US" sz="1200" smtClean="0"/>
               <a:pPr/>
-              <a:t>25</a:t>
+              <a:t>26</a:t>
             </a:fld>
             <a:endParaRPr lang="en-US" sz="1200"/>
           </a:p>
@@ -7091,1866 +7092,6 @@
       </p:grpSpPr>
       <p:sp>
         <p:nvSpPr>
-          <p:cNvPr id="4" name="Rectangle 3">
-            <a:extLst>
-              <a:ext uri="{FF2B5EF4-FFF2-40B4-BE49-F238E27FC236}">
-                <a16:creationId xmlns:a16="http://schemas.microsoft.com/office/drawing/2014/main" id="{3629A366-D322-A64E-9916-889C92B67AC1}"/>
-              </a:ext>
-            </a:extLst>
-          </p:cNvPr>
-          <p:cNvSpPr/>
-          <p:nvPr/>
-        </p:nvSpPr>
-        <p:spPr>
-          <a:xfrm>
-            <a:off x="838200" y="2131346"/>
-            <a:ext cx="4445000" cy="764254"/>
-          </a:xfrm>
-          <a:prstGeom prst="rect">
-            <a:avLst/>
-          </a:prstGeom>
-          <a:ln>
-            <a:noFill/>
-          </a:ln>
-        </p:spPr>
-        <p:style>
-          <a:lnRef idx="2">
-            <a:schemeClr val="accent4">
-              <a:shade val="50000"/>
-            </a:schemeClr>
-          </a:lnRef>
-          <a:fillRef idx="1">
-            <a:schemeClr val="accent4"/>
-          </a:fillRef>
-          <a:effectRef idx="0">
-            <a:schemeClr val="accent4"/>
-          </a:effectRef>
-          <a:fontRef idx="minor">
-            <a:schemeClr val="lt1"/>
-          </a:fontRef>
-        </p:style>
-        <p:txBody>
-          <a:bodyPr rtlCol="0" anchor="ctr"/>
-          <a:lstStyle/>
-          <a:p>
-            <a:pPr algn="ctr"/>
-            <a:endParaRPr lang="en-US"/>
-          </a:p>
-        </p:txBody>
-      </p:sp>
-      <p:sp>
-        <p:nvSpPr>
-          <p:cNvPr id="3" name="Title 2"/>
-          <p:cNvSpPr>
-            <a:spLocks noGrp="1"/>
-          </p:cNvSpPr>
-          <p:nvPr>
-            <p:ph type="title"/>
-          </p:nvPr>
-        </p:nvSpPr>
-        <p:spPr>
-          <a:xfrm>
-            <a:off x="838200" y="0"/>
-            <a:ext cx="10515600" cy="1325563"/>
-          </a:xfrm>
-        </p:spPr>
-        <p:txBody>
-          <a:bodyPr>
-            <a:normAutofit/>
-          </a:bodyPr>
-          <a:lstStyle/>
-          <a:p>
-            <a:r>
-              <a:rPr lang="en-US" dirty="0"/>
-              <a:t>A language for specifying automata</a:t>
-            </a:r>
-          </a:p>
-        </p:txBody>
-      </p:sp>
-      <p:sp>
-        <p:nvSpPr>
-          <p:cNvPr id="2" name="TextBox 1">
-            <a:extLst>
-              <a:ext uri="{FF2B5EF4-FFF2-40B4-BE49-F238E27FC236}">
-                <a16:creationId xmlns:a16="http://schemas.microsoft.com/office/drawing/2014/main" id="{1417CDEB-59C2-494C-B916-ABA6EEECE1D0}"/>
-              </a:ext>
-            </a:extLst>
-          </p:cNvPr>
-          <p:cNvSpPr txBox="1"/>
-          <p:nvPr/>
-        </p:nvSpPr>
-        <p:spPr>
-          <a:xfrm>
-            <a:off x="926544" y="1022489"/>
-            <a:ext cx="6352701" cy="5632311"/>
-          </a:xfrm>
-          <a:prstGeom prst="rect">
-            <a:avLst/>
-          </a:prstGeom>
-          <a:noFill/>
-        </p:spPr>
-        <p:txBody>
-          <a:bodyPr wrap="none" rtlCol="0">
-            <a:spAutoFit/>
-          </a:bodyPr>
-          <a:lstStyle/>
-          <a:p>
-            <a:r>
-              <a:rPr lang="en-US" sz="2400" b="1" dirty="0"/>
-              <a:t>automaton</a:t>
-            </a:r>
-            <a:r>
-              <a:rPr lang="en-US" sz="2400" dirty="0"/>
-              <a:t> </a:t>
-            </a:r>
-            <a:r>
-              <a:rPr lang="en-US" sz="2400" dirty="0" err="1">
-                <a:solidFill>
-                  <a:srgbClr val="0119FF"/>
-                </a:solidFill>
-              </a:rPr>
-              <a:t>DijkstraTR</a:t>
-            </a:r>
-            <a:r>
-              <a:rPr lang="en-US" sz="2400" dirty="0"/>
-              <a:t>(</a:t>
-            </a:r>
-            <a:r>
-              <a:rPr lang="en-US" sz="2400" dirty="0" err="1"/>
-              <a:t>N:</a:t>
-            </a:r>
-            <a:r>
-              <a:rPr lang="en-US" sz="2400" dirty="0" err="1">
-                <a:solidFill>
-                  <a:srgbClr val="00B050"/>
-                </a:solidFill>
-              </a:rPr>
-              <a:t>Nat</a:t>
-            </a:r>
-            <a:r>
-              <a:rPr lang="en-US" sz="2400" dirty="0"/>
-              <a:t>, </a:t>
-            </a:r>
-            <a:r>
-              <a:rPr lang="en-US" sz="2400" dirty="0" err="1"/>
-              <a:t>K:</a:t>
-            </a:r>
-            <a:r>
-              <a:rPr lang="en-US" sz="2400" dirty="0" err="1">
-                <a:solidFill>
-                  <a:srgbClr val="00B050"/>
-                </a:solidFill>
-              </a:rPr>
-              <a:t>Nat</a:t>
-            </a:r>
-            <a:r>
-              <a:rPr lang="en-US" sz="2400" dirty="0"/>
-              <a:t>), </a:t>
-            </a:r>
-            <a:r>
-              <a:rPr lang="en-US" sz="2400" b="1" dirty="0"/>
-              <a:t>where</a:t>
-            </a:r>
-            <a:r>
-              <a:rPr lang="en-US" sz="2400" dirty="0"/>
-              <a:t> K &gt; N</a:t>
-            </a:r>
-          </a:p>
-          <a:p>
-            <a:r>
-              <a:rPr lang="en-US" sz="2400" dirty="0"/>
-              <a:t>  </a:t>
-            </a:r>
-            <a:r>
-              <a:rPr lang="en-US" sz="2400" b="1" dirty="0"/>
-              <a:t>type</a:t>
-            </a:r>
-            <a:r>
-              <a:rPr lang="en-US" sz="2400" dirty="0"/>
-              <a:t> </a:t>
-            </a:r>
-            <a:r>
-              <a:rPr lang="en-US" sz="2400" dirty="0">
-                <a:solidFill>
-                  <a:srgbClr val="0119FF"/>
-                </a:solidFill>
-              </a:rPr>
-              <a:t>ID</a:t>
-            </a:r>
-            <a:r>
-              <a:rPr lang="en-US" sz="2400" dirty="0"/>
-              <a:t>: </a:t>
-            </a:r>
-            <a:r>
-              <a:rPr lang="en-US" sz="2400" b="1" dirty="0"/>
-              <a:t>enumeration</a:t>
-            </a:r>
-            <a:r>
-              <a:rPr lang="en-US" sz="2400" dirty="0"/>
-              <a:t> [0,...,N-1]</a:t>
-            </a:r>
-          </a:p>
-          <a:p>
-            <a:r>
-              <a:rPr lang="en-US" sz="2400" dirty="0"/>
-              <a:t>  </a:t>
-            </a:r>
-            <a:r>
-              <a:rPr lang="en-US" sz="2400" b="1" dirty="0"/>
-              <a:t>type</a:t>
-            </a:r>
-            <a:r>
-              <a:rPr lang="en-US" sz="2400" dirty="0"/>
-              <a:t> </a:t>
-            </a:r>
-            <a:r>
-              <a:rPr lang="en-US" sz="2400" dirty="0">
-                <a:solidFill>
-                  <a:srgbClr val="0119FF"/>
-                </a:solidFill>
-              </a:rPr>
-              <a:t>Val</a:t>
-            </a:r>
-            <a:r>
-              <a:rPr lang="en-US" sz="2400" dirty="0"/>
-              <a:t>: </a:t>
-            </a:r>
-            <a:r>
-              <a:rPr lang="en-US" sz="2400" b="1" dirty="0"/>
-              <a:t>enumeration</a:t>
-            </a:r>
-            <a:r>
-              <a:rPr lang="en-US" sz="2400" dirty="0"/>
-              <a:t> [0,...,K]</a:t>
-            </a:r>
-          </a:p>
-          <a:p>
-            <a:r>
-              <a:rPr lang="en-US" sz="2400" dirty="0"/>
-              <a:t>  </a:t>
-            </a:r>
-            <a:r>
-              <a:rPr lang="en-US" sz="2400" b="1" dirty="0"/>
-              <a:t>actions</a:t>
-            </a:r>
-          </a:p>
-          <a:p>
-            <a:r>
-              <a:rPr lang="en-US" sz="2400" dirty="0"/>
-              <a:t>      </a:t>
-            </a:r>
-            <a:r>
-              <a:rPr lang="en-US" sz="2400" dirty="0">
-                <a:solidFill>
-                  <a:srgbClr val="0119FF"/>
-                </a:solidFill>
-              </a:rPr>
-              <a:t>update</a:t>
-            </a:r>
-            <a:r>
-              <a:rPr lang="en-US" sz="2400" dirty="0"/>
-              <a:t>(</a:t>
-            </a:r>
-            <a:r>
-              <a:rPr lang="en-US" sz="2400" dirty="0" err="1"/>
-              <a:t>i:ID</a:t>
-            </a:r>
-            <a:r>
-              <a:rPr lang="en-US" sz="2400" dirty="0"/>
-              <a:t>)</a:t>
-            </a:r>
-          </a:p>
-          <a:p>
-            <a:r>
-              <a:rPr lang="en-US" sz="2400" dirty="0"/>
-              <a:t>  </a:t>
-            </a:r>
-            <a:r>
-              <a:rPr lang="en-US" sz="2400" b="1" dirty="0"/>
-              <a:t>variables</a:t>
-            </a:r>
-          </a:p>
-          <a:p>
-            <a:r>
-              <a:rPr lang="en-US" sz="2400" dirty="0"/>
-              <a:t>      </a:t>
-            </a:r>
-            <a:r>
-              <a:rPr lang="en-US" sz="2400" dirty="0">
-                <a:solidFill>
-                  <a:srgbClr val="0119FF"/>
-                </a:solidFill>
-              </a:rPr>
-              <a:t>x</a:t>
-            </a:r>
-            <a:r>
-              <a:rPr lang="en-US" sz="2400" dirty="0"/>
-              <a:t>:[ID -&gt; Val]</a:t>
-            </a:r>
-          </a:p>
-          <a:p>
-            <a:r>
-              <a:rPr lang="en-US" sz="2400" dirty="0"/>
-              <a:t>   </a:t>
-            </a:r>
-            <a:r>
-              <a:rPr lang="en-US" sz="2400" b="1" dirty="0"/>
-              <a:t>transitions</a:t>
-            </a:r>
-          </a:p>
-          <a:p>
-            <a:r>
-              <a:rPr lang="en-US" sz="2400" dirty="0"/>
-              <a:t>      </a:t>
-            </a:r>
-            <a:r>
-              <a:rPr lang="en-US" sz="2400" dirty="0">
-                <a:solidFill>
-                  <a:srgbClr val="0119FF"/>
-                </a:solidFill>
-              </a:rPr>
-              <a:t>update</a:t>
-            </a:r>
-            <a:r>
-              <a:rPr lang="en-US" sz="2400" dirty="0"/>
-              <a:t>(</a:t>
-            </a:r>
-            <a:r>
-              <a:rPr lang="en-US" sz="2400" dirty="0" err="1"/>
-              <a:t>i:ID</a:t>
-            </a:r>
-            <a:r>
-              <a:rPr lang="en-US" sz="2400" dirty="0"/>
-              <a:t>) </a:t>
-            </a:r>
-          </a:p>
-          <a:p>
-            <a:r>
-              <a:rPr lang="en-US" sz="2400" dirty="0"/>
-              <a:t>        </a:t>
-            </a:r>
-            <a:r>
-              <a:rPr lang="en-US" sz="2400" b="1" dirty="0"/>
-              <a:t>pre</a:t>
-            </a:r>
-            <a:r>
-              <a:rPr lang="en-US" sz="2400" dirty="0"/>
-              <a:t> </a:t>
-            </a:r>
-            <a:r>
-              <a:rPr lang="en-US" sz="2400" dirty="0" err="1"/>
-              <a:t>i</a:t>
-            </a:r>
-            <a:r>
-              <a:rPr lang="en-US" sz="2400" dirty="0"/>
-              <a:t> = 0 /\ x[</a:t>
-            </a:r>
-            <a:r>
-              <a:rPr lang="en-US" sz="2400" dirty="0" err="1"/>
-              <a:t>i</a:t>
-            </a:r>
-            <a:r>
-              <a:rPr lang="en-US" sz="2400" dirty="0"/>
-              <a:t>] = x[N-1]</a:t>
-            </a:r>
-          </a:p>
-          <a:p>
-            <a:r>
-              <a:rPr lang="en-US" sz="2400" dirty="0"/>
-              <a:t>        </a:t>
-            </a:r>
-            <a:r>
-              <a:rPr lang="en-US" sz="2400" b="1" dirty="0"/>
-              <a:t>eff</a:t>
-            </a:r>
-            <a:r>
-              <a:rPr lang="en-US" sz="2400" dirty="0"/>
-              <a:t> x[</a:t>
-            </a:r>
-            <a:r>
-              <a:rPr lang="en-US" sz="2400" dirty="0" err="1"/>
-              <a:t>i</a:t>
-            </a:r>
-            <a:r>
-              <a:rPr lang="en-US" sz="2400" dirty="0"/>
-              <a:t>] := (x[</a:t>
-            </a:r>
-            <a:r>
-              <a:rPr lang="en-US" sz="2400" dirty="0" err="1"/>
-              <a:t>i</a:t>
-            </a:r>
-            <a:r>
-              <a:rPr lang="en-US" sz="2400" dirty="0"/>
-              <a:t>] + 1) %  K</a:t>
-            </a:r>
-          </a:p>
-          <a:p>
-            <a:r>
-              <a:rPr lang="en-US" sz="2400" dirty="0"/>
-              <a:t>   </a:t>
-            </a:r>
-          </a:p>
-          <a:p>
-            <a:r>
-              <a:rPr lang="en-US" sz="2400" dirty="0"/>
-              <a:t>       </a:t>
-            </a:r>
-            <a:r>
-              <a:rPr lang="en-US" sz="2400" dirty="0">
-                <a:solidFill>
-                  <a:srgbClr val="0119FF"/>
-                </a:solidFill>
-              </a:rPr>
-              <a:t>update</a:t>
-            </a:r>
-            <a:r>
-              <a:rPr lang="en-US" sz="2400" dirty="0"/>
-              <a:t>(</a:t>
-            </a:r>
-            <a:r>
-              <a:rPr lang="en-US" sz="2400" dirty="0" err="1"/>
-              <a:t>i:ID</a:t>
-            </a:r>
-            <a:r>
-              <a:rPr lang="en-US" sz="2400" dirty="0"/>
-              <a:t>)</a:t>
-            </a:r>
-          </a:p>
-          <a:p>
-            <a:r>
-              <a:rPr lang="en-US" sz="2400" dirty="0"/>
-              <a:t>         </a:t>
-            </a:r>
-            <a:r>
-              <a:rPr lang="en-US" sz="2400" b="1" dirty="0"/>
-              <a:t>pre</a:t>
-            </a:r>
-            <a:r>
-              <a:rPr lang="en-US" sz="2400" dirty="0"/>
-              <a:t> </a:t>
-            </a:r>
-            <a:r>
-              <a:rPr lang="en-US" sz="2400" dirty="0" err="1"/>
-              <a:t>i</a:t>
-            </a:r>
-            <a:r>
-              <a:rPr lang="en-US" sz="2400" dirty="0"/>
-              <a:t> &gt;0  /\ x[</a:t>
-            </a:r>
-            <a:r>
-              <a:rPr lang="en-US" sz="2400" dirty="0" err="1"/>
-              <a:t>i</a:t>
-            </a:r>
-            <a:r>
-              <a:rPr lang="en-US" sz="2400" dirty="0"/>
-              <a:t>] ~= x[i-1]</a:t>
-            </a:r>
-          </a:p>
-          <a:p>
-            <a:r>
-              <a:rPr lang="en-US" sz="2400" dirty="0"/>
-              <a:t>         </a:t>
-            </a:r>
-            <a:r>
-              <a:rPr lang="en-US" sz="2400" b="1" dirty="0"/>
-              <a:t>eff</a:t>
-            </a:r>
-            <a:r>
-              <a:rPr lang="en-US" sz="2400" dirty="0"/>
-              <a:t> x[</a:t>
-            </a:r>
-            <a:r>
-              <a:rPr lang="en-US" sz="2400" dirty="0" err="1"/>
-              <a:t>i</a:t>
-            </a:r>
-            <a:r>
-              <a:rPr lang="en-US" sz="2400" dirty="0"/>
-              <a:t>] := x[i-1]</a:t>
-            </a:r>
-          </a:p>
-        </p:txBody>
-      </p:sp>
-      <p:sp>
-        <p:nvSpPr>
-          <p:cNvPr id="5" name="TextBox 4">
-            <a:extLst>
-              <a:ext uri="{FF2B5EF4-FFF2-40B4-BE49-F238E27FC236}">
-                <a16:creationId xmlns:a16="http://schemas.microsoft.com/office/drawing/2014/main" id="{5DC2086B-C1E3-3047-9A02-47CD138A1299}"/>
-              </a:ext>
-            </a:extLst>
-          </p:cNvPr>
-          <p:cNvSpPr txBox="1"/>
-          <p:nvPr/>
-        </p:nvSpPr>
-        <p:spPr>
-          <a:xfrm>
-            <a:off x="8089106" y="1977682"/>
-            <a:ext cx="3645694" cy="2308324"/>
-          </a:xfrm>
-          <a:prstGeom prst="rect">
-            <a:avLst/>
-          </a:prstGeom>
-          <a:noFill/>
-        </p:spPr>
-        <p:txBody>
-          <a:bodyPr wrap="square" rtlCol="0">
-            <a:spAutoFit/>
-          </a:bodyPr>
-          <a:lstStyle/>
-          <a:p>
-            <a:r>
-              <a:rPr lang="en-US" sz="2400" dirty="0">
-                <a:solidFill>
-                  <a:schemeClr val="accent4">
-                    <a:lumMod val="75000"/>
-                  </a:schemeClr>
-                </a:solidFill>
-              </a:rPr>
-              <a:t>declaration of “actions” or transition labels; actions can have parameter; this declares the actions update(0), update(1), …, update(N-1)</a:t>
-            </a:r>
-          </a:p>
-        </p:txBody>
-      </p:sp>
-      <p:sp>
-        <p:nvSpPr>
-          <p:cNvPr id="6" name="TextBox 5">
-            <a:extLst>
-              <a:ext uri="{FF2B5EF4-FFF2-40B4-BE49-F238E27FC236}">
-                <a16:creationId xmlns:a16="http://schemas.microsoft.com/office/drawing/2014/main" id="{AFE56EDA-4014-D04A-9928-4956AA1A4C3A}"/>
-              </a:ext>
-            </a:extLst>
-          </p:cNvPr>
-          <p:cNvSpPr txBox="1"/>
-          <p:nvPr/>
-        </p:nvSpPr>
-        <p:spPr>
-          <a:xfrm>
-            <a:off x="5544742" y="6155266"/>
-            <a:ext cx="6647258" cy="461665"/>
-          </a:xfrm>
-          <a:prstGeom prst="rect">
-            <a:avLst/>
-          </a:prstGeom>
-          <a:noFill/>
-        </p:spPr>
-        <p:txBody>
-          <a:bodyPr wrap="square" rtlCol="0">
-            <a:spAutoFit/>
-          </a:bodyPr>
-          <a:lstStyle/>
-          <a:p>
-            <a:r>
-              <a:rPr lang="en-US" sz="2400" dirty="0">
-                <a:solidFill>
-                  <a:schemeClr val="accent4">
-                    <a:lumMod val="75000"/>
-                  </a:schemeClr>
-                </a:solidFill>
-              </a:rPr>
-              <a:t>symbols -&gt; maps, /\ and, \/ or, ~= not equal, % mod</a:t>
-            </a:r>
-          </a:p>
-        </p:txBody>
-      </p:sp>
-    </p:spTree>
-    <p:extLst>
-      <p:ext uri="{BB962C8B-B14F-4D97-AF65-F5344CB8AC3E}">
-        <p14:creationId xmlns:p14="http://schemas.microsoft.com/office/powerpoint/2010/main" val="1933890637"/>
-      </p:ext>
-    </p:extLst>
-  </p:cSld>
-  <p:clrMapOvr>
-    <a:masterClrMapping/>
-  </p:clrMapOvr>
-</p:sld>
-</file>
-
-<file path=ppt/slides/slide15.xml><?xml version="1.0" encoding="utf-8"?>
-<p:sld xmlns:a="http://schemas.openxmlformats.org/drawingml/2006/main" xmlns:r="http://schemas.openxmlformats.org/officeDocument/2006/relationships" xmlns:p="http://schemas.openxmlformats.org/presentationml/2006/main">
-  <p:cSld>
-    <p:spTree>
-      <p:nvGrpSpPr>
-        <p:cNvPr id="1" name=""/>
-        <p:cNvGrpSpPr/>
-        <p:nvPr/>
-      </p:nvGrpSpPr>
-      <p:grpSpPr>
-        <a:xfrm>
-          <a:off x="0" y="0"/>
-          <a:ext cx="0" cy="0"/>
-          <a:chOff x="0" y="0"/>
-          <a:chExt cx="0" cy="0"/>
-        </a:xfrm>
-      </p:grpSpPr>
-      <p:sp>
-        <p:nvSpPr>
-          <p:cNvPr id="4" name="Rectangle 3">
-            <a:extLst>
-              <a:ext uri="{FF2B5EF4-FFF2-40B4-BE49-F238E27FC236}">
-                <a16:creationId xmlns:a16="http://schemas.microsoft.com/office/drawing/2014/main" id="{3629A366-D322-A64E-9916-889C92B67AC1}"/>
-              </a:ext>
-            </a:extLst>
-          </p:cNvPr>
-          <p:cNvSpPr/>
-          <p:nvPr/>
-        </p:nvSpPr>
-        <p:spPr>
-          <a:xfrm>
-            <a:off x="838200" y="2927212"/>
-            <a:ext cx="4445000" cy="764254"/>
-          </a:xfrm>
-          <a:prstGeom prst="rect">
-            <a:avLst/>
-          </a:prstGeom>
-          <a:ln>
-            <a:noFill/>
-          </a:ln>
-        </p:spPr>
-        <p:style>
-          <a:lnRef idx="2">
-            <a:schemeClr val="accent4">
-              <a:shade val="50000"/>
-            </a:schemeClr>
-          </a:lnRef>
-          <a:fillRef idx="1">
-            <a:schemeClr val="accent4"/>
-          </a:fillRef>
-          <a:effectRef idx="0">
-            <a:schemeClr val="accent4"/>
-          </a:effectRef>
-          <a:fontRef idx="minor">
-            <a:schemeClr val="lt1"/>
-          </a:fontRef>
-        </p:style>
-        <p:txBody>
-          <a:bodyPr rtlCol="0" anchor="ctr"/>
-          <a:lstStyle/>
-          <a:p>
-            <a:pPr algn="ctr"/>
-            <a:endParaRPr lang="en-US"/>
-          </a:p>
-        </p:txBody>
-      </p:sp>
-      <p:sp>
-        <p:nvSpPr>
-          <p:cNvPr id="3" name="Title 2"/>
-          <p:cNvSpPr>
-            <a:spLocks noGrp="1"/>
-          </p:cNvSpPr>
-          <p:nvPr>
-            <p:ph type="title"/>
-          </p:nvPr>
-        </p:nvSpPr>
-        <p:spPr>
-          <a:xfrm>
-            <a:off x="838200" y="0"/>
-            <a:ext cx="10515600" cy="1325563"/>
-          </a:xfrm>
-        </p:spPr>
-        <p:txBody>
-          <a:bodyPr>
-            <a:normAutofit/>
-          </a:bodyPr>
-          <a:lstStyle/>
-          <a:p>
-            <a:r>
-              <a:rPr lang="en-US" dirty="0"/>
-              <a:t>A language for specifying automata</a:t>
-            </a:r>
-          </a:p>
-        </p:txBody>
-      </p:sp>
-      <p:sp>
-        <p:nvSpPr>
-          <p:cNvPr id="2" name="TextBox 1">
-            <a:extLst>
-              <a:ext uri="{FF2B5EF4-FFF2-40B4-BE49-F238E27FC236}">
-                <a16:creationId xmlns:a16="http://schemas.microsoft.com/office/drawing/2014/main" id="{1417CDEB-59C2-494C-B916-ABA6EEECE1D0}"/>
-              </a:ext>
-            </a:extLst>
-          </p:cNvPr>
-          <p:cNvSpPr txBox="1"/>
-          <p:nvPr/>
-        </p:nvSpPr>
-        <p:spPr>
-          <a:xfrm>
-            <a:off x="926544" y="1022489"/>
-            <a:ext cx="6352701" cy="5632311"/>
-          </a:xfrm>
-          <a:prstGeom prst="rect">
-            <a:avLst/>
-          </a:prstGeom>
-          <a:noFill/>
-        </p:spPr>
-        <p:txBody>
-          <a:bodyPr wrap="none" rtlCol="0">
-            <a:spAutoFit/>
-          </a:bodyPr>
-          <a:lstStyle/>
-          <a:p>
-            <a:r>
-              <a:rPr lang="en-US" sz="2400" b="1" dirty="0"/>
-              <a:t>automaton</a:t>
-            </a:r>
-            <a:r>
-              <a:rPr lang="en-US" sz="2400" dirty="0"/>
-              <a:t> </a:t>
-            </a:r>
-            <a:r>
-              <a:rPr lang="en-US" sz="2400" dirty="0" err="1">
-                <a:solidFill>
-                  <a:srgbClr val="0119FF"/>
-                </a:solidFill>
-              </a:rPr>
-              <a:t>DijkstraTR</a:t>
-            </a:r>
-            <a:r>
-              <a:rPr lang="en-US" sz="2400" dirty="0"/>
-              <a:t>(</a:t>
-            </a:r>
-            <a:r>
-              <a:rPr lang="en-US" sz="2400" dirty="0" err="1"/>
-              <a:t>N:</a:t>
-            </a:r>
-            <a:r>
-              <a:rPr lang="en-US" sz="2400" dirty="0" err="1">
-                <a:solidFill>
-                  <a:srgbClr val="00B050"/>
-                </a:solidFill>
-              </a:rPr>
-              <a:t>Nat</a:t>
-            </a:r>
-            <a:r>
-              <a:rPr lang="en-US" sz="2400" dirty="0"/>
-              <a:t>, </a:t>
-            </a:r>
-            <a:r>
-              <a:rPr lang="en-US" sz="2400" dirty="0" err="1"/>
-              <a:t>K:</a:t>
-            </a:r>
-            <a:r>
-              <a:rPr lang="en-US" sz="2400" dirty="0" err="1">
-                <a:solidFill>
-                  <a:srgbClr val="00B050"/>
-                </a:solidFill>
-              </a:rPr>
-              <a:t>Nat</a:t>
-            </a:r>
-            <a:r>
-              <a:rPr lang="en-US" sz="2400" dirty="0"/>
-              <a:t>), </a:t>
-            </a:r>
-            <a:r>
-              <a:rPr lang="en-US" sz="2400" b="1" dirty="0"/>
-              <a:t>where</a:t>
-            </a:r>
-            <a:r>
-              <a:rPr lang="en-US" sz="2400" dirty="0"/>
-              <a:t> K &gt; N</a:t>
-            </a:r>
-          </a:p>
-          <a:p>
-            <a:r>
-              <a:rPr lang="en-US" sz="2400" dirty="0"/>
-              <a:t>  </a:t>
-            </a:r>
-            <a:r>
-              <a:rPr lang="en-US" sz="2400" b="1" dirty="0"/>
-              <a:t>type</a:t>
-            </a:r>
-            <a:r>
-              <a:rPr lang="en-US" sz="2400" dirty="0"/>
-              <a:t> </a:t>
-            </a:r>
-            <a:r>
-              <a:rPr lang="en-US" sz="2400" dirty="0">
-                <a:solidFill>
-                  <a:srgbClr val="0119FF"/>
-                </a:solidFill>
-              </a:rPr>
-              <a:t>ID</a:t>
-            </a:r>
-            <a:r>
-              <a:rPr lang="en-US" sz="2400" dirty="0"/>
-              <a:t>: </a:t>
-            </a:r>
-            <a:r>
-              <a:rPr lang="en-US" sz="2400" b="1" dirty="0"/>
-              <a:t>enumeration</a:t>
-            </a:r>
-            <a:r>
-              <a:rPr lang="en-US" sz="2400" dirty="0"/>
-              <a:t> [0,...,N-1]</a:t>
-            </a:r>
-          </a:p>
-          <a:p>
-            <a:r>
-              <a:rPr lang="en-US" sz="2400" dirty="0"/>
-              <a:t>  </a:t>
-            </a:r>
-            <a:r>
-              <a:rPr lang="en-US" sz="2400" b="1" dirty="0"/>
-              <a:t>type</a:t>
-            </a:r>
-            <a:r>
-              <a:rPr lang="en-US" sz="2400" dirty="0"/>
-              <a:t> </a:t>
-            </a:r>
-            <a:r>
-              <a:rPr lang="en-US" sz="2400" dirty="0">
-                <a:solidFill>
-                  <a:srgbClr val="0119FF"/>
-                </a:solidFill>
-              </a:rPr>
-              <a:t>Val</a:t>
-            </a:r>
-            <a:r>
-              <a:rPr lang="en-US" sz="2400" dirty="0"/>
-              <a:t>: </a:t>
-            </a:r>
-            <a:r>
-              <a:rPr lang="en-US" sz="2400" b="1" dirty="0"/>
-              <a:t>enumeration</a:t>
-            </a:r>
-            <a:r>
-              <a:rPr lang="en-US" sz="2400" dirty="0"/>
-              <a:t> [0,...,K]</a:t>
-            </a:r>
-          </a:p>
-          <a:p>
-            <a:r>
-              <a:rPr lang="en-US" sz="2400" dirty="0"/>
-              <a:t>  </a:t>
-            </a:r>
-            <a:r>
-              <a:rPr lang="en-US" sz="2400" b="1" dirty="0"/>
-              <a:t>actions</a:t>
-            </a:r>
-          </a:p>
-          <a:p>
-            <a:r>
-              <a:rPr lang="en-US" sz="2400" dirty="0"/>
-              <a:t>      </a:t>
-            </a:r>
-            <a:r>
-              <a:rPr lang="en-US" sz="2400" dirty="0">
-                <a:solidFill>
-                  <a:srgbClr val="0119FF"/>
-                </a:solidFill>
-              </a:rPr>
-              <a:t>update</a:t>
-            </a:r>
-            <a:r>
-              <a:rPr lang="en-US" sz="2400" dirty="0"/>
-              <a:t>(</a:t>
-            </a:r>
-            <a:r>
-              <a:rPr lang="en-US" sz="2400" dirty="0" err="1"/>
-              <a:t>i:ID</a:t>
-            </a:r>
-            <a:r>
-              <a:rPr lang="en-US" sz="2400" dirty="0"/>
-              <a:t>)</a:t>
-            </a:r>
-          </a:p>
-          <a:p>
-            <a:r>
-              <a:rPr lang="en-US" sz="2400" dirty="0"/>
-              <a:t>  </a:t>
-            </a:r>
-            <a:r>
-              <a:rPr lang="en-US" sz="2400" b="1" dirty="0"/>
-              <a:t>variables</a:t>
-            </a:r>
-          </a:p>
-          <a:p>
-            <a:r>
-              <a:rPr lang="en-US" sz="2400" dirty="0"/>
-              <a:t>      </a:t>
-            </a:r>
-            <a:r>
-              <a:rPr lang="en-US" sz="2400" dirty="0">
-                <a:solidFill>
-                  <a:srgbClr val="0119FF"/>
-                </a:solidFill>
-              </a:rPr>
-              <a:t>x</a:t>
-            </a:r>
-            <a:r>
-              <a:rPr lang="en-US" sz="2400" dirty="0"/>
-              <a:t>:[ID -&gt; Val]</a:t>
-            </a:r>
-          </a:p>
-          <a:p>
-            <a:r>
-              <a:rPr lang="en-US" sz="2400" dirty="0"/>
-              <a:t>   </a:t>
-            </a:r>
-            <a:r>
-              <a:rPr lang="en-US" sz="2400" b="1" dirty="0"/>
-              <a:t>transitions</a:t>
-            </a:r>
-          </a:p>
-          <a:p>
-            <a:r>
-              <a:rPr lang="en-US" sz="2400" dirty="0"/>
-              <a:t>      </a:t>
-            </a:r>
-            <a:r>
-              <a:rPr lang="en-US" sz="2400" dirty="0">
-                <a:solidFill>
-                  <a:srgbClr val="0119FF"/>
-                </a:solidFill>
-              </a:rPr>
-              <a:t>update</a:t>
-            </a:r>
-            <a:r>
-              <a:rPr lang="en-US" sz="2400" dirty="0"/>
-              <a:t>(</a:t>
-            </a:r>
-            <a:r>
-              <a:rPr lang="en-US" sz="2400" dirty="0" err="1"/>
-              <a:t>i:ID</a:t>
-            </a:r>
-            <a:r>
-              <a:rPr lang="en-US" sz="2400" dirty="0"/>
-              <a:t>)</a:t>
-            </a:r>
-          </a:p>
-          <a:p>
-            <a:r>
-              <a:rPr lang="en-US" sz="2400" dirty="0"/>
-              <a:t>        </a:t>
-            </a:r>
-            <a:r>
-              <a:rPr lang="en-US" sz="2400" b="1" dirty="0"/>
-              <a:t>pre</a:t>
-            </a:r>
-            <a:r>
-              <a:rPr lang="en-US" sz="2400" dirty="0"/>
-              <a:t> </a:t>
-            </a:r>
-            <a:r>
-              <a:rPr lang="en-US" sz="2400" dirty="0" err="1"/>
-              <a:t>i</a:t>
-            </a:r>
-            <a:r>
-              <a:rPr lang="en-US" sz="2400" dirty="0"/>
-              <a:t> = 0 /\ x[</a:t>
-            </a:r>
-            <a:r>
-              <a:rPr lang="en-US" sz="2400" dirty="0" err="1"/>
-              <a:t>i</a:t>
-            </a:r>
-            <a:r>
-              <a:rPr lang="en-US" sz="2400" dirty="0"/>
-              <a:t>] = x[N-1]</a:t>
-            </a:r>
-          </a:p>
-          <a:p>
-            <a:r>
-              <a:rPr lang="en-US" sz="2400" dirty="0"/>
-              <a:t>        </a:t>
-            </a:r>
-            <a:r>
-              <a:rPr lang="en-US" sz="2400" b="1" dirty="0"/>
-              <a:t>eff</a:t>
-            </a:r>
-            <a:r>
-              <a:rPr lang="en-US" sz="2400" dirty="0"/>
-              <a:t> x[</a:t>
-            </a:r>
-            <a:r>
-              <a:rPr lang="en-US" sz="2400" dirty="0" err="1"/>
-              <a:t>i</a:t>
-            </a:r>
-            <a:r>
-              <a:rPr lang="en-US" sz="2400" dirty="0"/>
-              <a:t>] := (x[</a:t>
-            </a:r>
-            <a:r>
-              <a:rPr lang="en-US" sz="2400" dirty="0" err="1"/>
-              <a:t>i</a:t>
-            </a:r>
-            <a:r>
-              <a:rPr lang="en-US" sz="2400" dirty="0"/>
-              <a:t>] + 1) %  K</a:t>
-            </a:r>
-          </a:p>
-          <a:p>
-            <a:r>
-              <a:rPr lang="en-US" sz="2400" dirty="0"/>
-              <a:t>   </a:t>
-            </a:r>
-          </a:p>
-          <a:p>
-            <a:r>
-              <a:rPr lang="en-US" sz="2400" dirty="0"/>
-              <a:t>       </a:t>
-            </a:r>
-            <a:r>
-              <a:rPr lang="en-US" sz="2400" dirty="0">
-                <a:solidFill>
-                  <a:srgbClr val="0119FF"/>
-                </a:solidFill>
-              </a:rPr>
-              <a:t>update</a:t>
-            </a:r>
-            <a:r>
-              <a:rPr lang="en-US" sz="2400" dirty="0"/>
-              <a:t>(</a:t>
-            </a:r>
-            <a:r>
-              <a:rPr lang="en-US" sz="2400" dirty="0" err="1"/>
-              <a:t>i:ID</a:t>
-            </a:r>
-            <a:r>
-              <a:rPr lang="en-US" sz="2400" dirty="0"/>
-              <a:t>)</a:t>
-            </a:r>
-          </a:p>
-          <a:p>
-            <a:r>
-              <a:rPr lang="en-US" sz="2400" dirty="0"/>
-              <a:t>         </a:t>
-            </a:r>
-            <a:r>
-              <a:rPr lang="en-US" sz="2400" b="1" dirty="0"/>
-              <a:t>pre</a:t>
-            </a:r>
-            <a:r>
-              <a:rPr lang="en-US" sz="2400" dirty="0"/>
-              <a:t> </a:t>
-            </a:r>
-            <a:r>
-              <a:rPr lang="en-US" sz="2400" dirty="0" err="1"/>
-              <a:t>i</a:t>
-            </a:r>
-            <a:r>
-              <a:rPr lang="en-US" sz="2400" dirty="0"/>
-              <a:t> &gt;0  /\ x[</a:t>
-            </a:r>
-            <a:r>
-              <a:rPr lang="en-US" sz="2400" dirty="0" err="1"/>
-              <a:t>i</a:t>
-            </a:r>
-            <a:r>
-              <a:rPr lang="en-US" sz="2400" dirty="0"/>
-              <a:t>] ~= x[i-1]</a:t>
-            </a:r>
-          </a:p>
-          <a:p>
-            <a:r>
-              <a:rPr lang="en-US" sz="2400" dirty="0"/>
-              <a:t>         </a:t>
-            </a:r>
-            <a:r>
-              <a:rPr lang="en-US" sz="2400" b="1" dirty="0"/>
-              <a:t>eff</a:t>
-            </a:r>
-            <a:r>
-              <a:rPr lang="en-US" sz="2400" dirty="0"/>
-              <a:t> x[</a:t>
-            </a:r>
-            <a:r>
-              <a:rPr lang="en-US" sz="2400" dirty="0" err="1"/>
-              <a:t>i</a:t>
-            </a:r>
-            <a:r>
-              <a:rPr lang="en-US" sz="2400" dirty="0"/>
-              <a:t>] := x[i-1]</a:t>
-            </a:r>
-          </a:p>
-        </p:txBody>
-      </p:sp>
-      <p:sp>
-        <p:nvSpPr>
-          <p:cNvPr id="5" name="TextBox 4">
-            <a:extLst>
-              <a:ext uri="{FF2B5EF4-FFF2-40B4-BE49-F238E27FC236}">
-                <a16:creationId xmlns:a16="http://schemas.microsoft.com/office/drawing/2014/main" id="{5DC2086B-C1E3-3047-9A02-47CD138A1299}"/>
-              </a:ext>
-            </a:extLst>
-          </p:cNvPr>
-          <p:cNvSpPr txBox="1"/>
-          <p:nvPr/>
-        </p:nvSpPr>
-        <p:spPr>
-          <a:xfrm>
-            <a:off x="8089106" y="1977682"/>
-            <a:ext cx="3645694" cy="1569660"/>
-          </a:xfrm>
-          <a:prstGeom prst="rect">
-            <a:avLst/>
-          </a:prstGeom>
-          <a:noFill/>
-        </p:spPr>
-        <p:txBody>
-          <a:bodyPr wrap="square" rtlCol="0">
-            <a:spAutoFit/>
-          </a:bodyPr>
-          <a:lstStyle/>
-          <a:p>
-            <a:r>
-              <a:rPr lang="en-US" sz="2400" dirty="0">
-                <a:solidFill>
-                  <a:schemeClr val="accent4">
-                    <a:lumMod val="75000"/>
-                  </a:schemeClr>
-                </a:solidFill>
-              </a:rPr>
-              <a:t>declaration of state variables or variables; this declares an array x[0], x[1], …, x[N-1] of Val’s</a:t>
-            </a:r>
-          </a:p>
-        </p:txBody>
-      </p:sp>
-      <p:sp>
-        <p:nvSpPr>
-          <p:cNvPr id="6" name="TextBox 5">
-            <a:extLst>
-              <a:ext uri="{FF2B5EF4-FFF2-40B4-BE49-F238E27FC236}">
-                <a16:creationId xmlns:a16="http://schemas.microsoft.com/office/drawing/2014/main" id="{7AFB572B-19F5-DC47-8D01-9D90083FF74A}"/>
-              </a:ext>
-            </a:extLst>
-          </p:cNvPr>
-          <p:cNvSpPr txBox="1"/>
-          <p:nvPr/>
-        </p:nvSpPr>
-        <p:spPr>
-          <a:xfrm>
-            <a:off x="5544742" y="6155266"/>
-            <a:ext cx="6647258" cy="461665"/>
-          </a:xfrm>
-          <a:prstGeom prst="rect">
-            <a:avLst/>
-          </a:prstGeom>
-          <a:noFill/>
-        </p:spPr>
-        <p:txBody>
-          <a:bodyPr wrap="square" rtlCol="0">
-            <a:spAutoFit/>
-          </a:bodyPr>
-          <a:lstStyle/>
-          <a:p>
-            <a:r>
-              <a:rPr lang="en-US" sz="2400" dirty="0">
-                <a:solidFill>
-                  <a:schemeClr val="accent4">
-                    <a:lumMod val="75000"/>
-                  </a:schemeClr>
-                </a:solidFill>
-              </a:rPr>
-              <a:t>symbols -&gt; maps, /\ and, \/ or, ~= not equal, % mod</a:t>
-            </a:r>
-          </a:p>
-        </p:txBody>
-      </p:sp>
-    </p:spTree>
-    <p:extLst>
-      <p:ext uri="{BB962C8B-B14F-4D97-AF65-F5344CB8AC3E}">
-        <p14:creationId xmlns:p14="http://schemas.microsoft.com/office/powerpoint/2010/main" val="4059203852"/>
-      </p:ext>
-    </p:extLst>
-  </p:cSld>
-  <p:clrMapOvr>
-    <a:masterClrMapping/>
-  </p:clrMapOvr>
-</p:sld>
-</file>
-
-<file path=ppt/slides/slide16.xml><?xml version="1.0" encoding="utf-8"?>
-<p:sld xmlns:a="http://schemas.openxmlformats.org/drawingml/2006/main" xmlns:r="http://schemas.openxmlformats.org/officeDocument/2006/relationships" xmlns:p="http://schemas.openxmlformats.org/presentationml/2006/main">
-  <p:cSld>
-    <p:spTree>
-      <p:nvGrpSpPr>
-        <p:cNvPr id="1" name=""/>
-        <p:cNvGrpSpPr/>
-        <p:nvPr/>
-      </p:nvGrpSpPr>
-      <p:grpSpPr>
-        <a:xfrm>
-          <a:off x="0" y="0"/>
-          <a:ext cx="0" cy="0"/>
-          <a:chOff x="0" y="0"/>
-          <a:chExt cx="0" cy="0"/>
-        </a:xfrm>
-      </p:grpSpPr>
-      <p:sp>
-        <p:nvSpPr>
-          <p:cNvPr id="4" name="Rectangle 3">
-            <a:extLst>
-              <a:ext uri="{FF2B5EF4-FFF2-40B4-BE49-F238E27FC236}">
-                <a16:creationId xmlns:a16="http://schemas.microsoft.com/office/drawing/2014/main" id="{3629A366-D322-A64E-9916-889C92B67AC1}"/>
-              </a:ext>
-            </a:extLst>
-          </p:cNvPr>
-          <p:cNvSpPr/>
-          <p:nvPr/>
-        </p:nvSpPr>
-        <p:spPr>
-          <a:xfrm>
-            <a:off x="838200" y="3638410"/>
-            <a:ext cx="4445000" cy="3016389"/>
-          </a:xfrm>
-          <a:prstGeom prst="rect">
-            <a:avLst/>
-          </a:prstGeom>
-          <a:ln>
-            <a:noFill/>
-          </a:ln>
-        </p:spPr>
-        <p:style>
-          <a:lnRef idx="2">
-            <a:schemeClr val="accent4">
-              <a:shade val="50000"/>
-            </a:schemeClr>
-          </a:lnRef>
-          <a:fillRef idx="1">
-            <a:schemeClr val="accent4"/>
-          </a:fillRef>
-          <a:effectRef idx="0">
-            <a:schemeClr val="accent4"/>
-          </a:effectRef>
-          <a:fontRef idx="minor">
-            <a:schemeClr val="lt1"/>
-          </a:fontRef>
-        </p:style>
-        <p:txBody>
-          <a:bodyPr rtlCol="0" anchor="ctr"/>
-          <a:lstStyle/>
-          <a:p>
-            <a:pPr algn="ctr"/>
-            <a:endParaRPr lang="en-US"/>
-          </a:p>
-        </p:txBody>
-      </p:sp>
-      <p:sp>
-        <p:nvSpPr>
-          <p:cNvPr id="3" name="Title 2"/>
-          <p:cNvSpPr>
-            <a:spLocks noGrp="1"/>
-          </p:cNvSpPr>
-          <p:nvPr>
-            <p:ph type="title"/>
-          </p:nvPr>
-        </p:nvSpPr>
-        <p:spPr>
-          <a:xfrm>
-            <a:off x="838200" y="0"/>
-            <a:ext cx="10515600" cy="1325563"/>
-          </a:xfrm>
-        </p:spPr>
-        <p:txBody>
-          <a:bodyPr>
-            <a:normAutofit/>
-          </a:bodyPr>
-          <a:lstStyle/>
-          <a:p>
-            <a:r>
-              <a:rPr lang="en-US" dirty="0"/>
-              <a:t>A language for specifying automata</a:t>
-            </a:r>
-          </a:p>
-        </p:txBody>
-      </p:sp>
-      <p:sp>
-        <p:nvSpPr>
-          <p:cNvPr id="2" name="TextBox 1">
-            <a:extLst>
-              <a:ext uri="{FF2B5EF4-FFF2-40B4-BE49-F238E27FC236}">
-                <a16:creationId xmlns:a16="http://schemas.microsoft.com/office/drawing/2014/main" id="{1417CDEB-59C2-494C-B916-ABA6EEECE1D0}"/>
-              </a:ext>
-            </a:extLst>
-          </p:cNvPr>
-          <p:cNvSpPr txBox="1"/>
-          <p:nvPr/>
-        </p:nvSpPr>
-        <p:spPr>
-          <a:xfrm>
-            <a:off x="926544" y="1022489"/>
-            <a:ext cx="6352701" cy="5632311"/>
-          </a:xfrm>
-          <a:prstGeom prst="rect">
-            <a:avLst/>
-          </a:prstGeom>
-          <a:noFill/>
-        </p:spPr>
-        <p:txBody>
-          <a:bodyPr wrap="none" rtlCol="0">
-            <a:spAutoFit/>
-          </a:bodyPr>
-          <a:lstStyle/>
-          <a:p>
-            <a:r>
-              <a:rPr lang="en-US" sz="2400" b="1" dirty="0"/>
-              <a:t>automaton</a:t>
-            </a:r>
-            <a:r>
-              <a:rPr lang="en-US" sz="2400" dirty="0"/>
-              <a:t> </a:t>
-            </a:r>
-            <a:r>
-              <a:rPr lang="en-US" sz="2400" dirty="0" err="1">
-                <a:solidFill>
-                  <a:srgbClr val="0119FF"/>
-                </a:solidFill>
-              </a:rPr>
-              <a:t>DijkstraTR</a:t>
-            </a:r>
-            <a:r>
-              <a:rPr lang="en-US" sz="2400" dirty="0"/>
-              <a:t>(</a:t>
-            </a:r>
-            <a:r>
-              <a:rPr lang="en-US" sz="2400" dirty="0" err="1"/>
-              <a:t>N:</a:t>
-            </a:r>
-            <a:r>
-              <a:rPr lang="en-US" sz="2400" dirty="0" err="1">
-                <a:solidFill>
-                  <a:srgbClr val="00B050"/>
-                </a:solidFill>
-              </a:rPr>
-              <a:t>Nat</a:t>
-            </a:r>
-            <a:r>
-              <a:rPr lang="en-US" sz="2400" dirty="0"/>
-              <a:t>, </a:t>
-            </a:r>
-            <a:r>
-              <a:rPr lang="en-US" sz="2400" dirty="0" err="1"/>
-              <a:t>K:</a:t>
-            </a:r>
-            <a:r>
-              <a:rPr lang="en-US" sz="2400" dirty="0" err="1">
-                <a:solidFill>
-                  <a:srgbClr val="00B050"/>
-                </a:solidFill>
-              </a:rPr>
-              <a:t>Nat</a:t>
-            </a:r>
-            <a:r>
-              <a:rPr lang="en-US" sz="2400" dirty="0"/>
-              <a:t>), </a:t>
-            </a:r>
-            <a:r>
-              <a:rPr lang="en-US" sz="2400" b="1" dirty="0"/>
-              <a:t>where</a:t>
-            </a:r>
-            <a:r>
-              <a:rPr lang="en-US" sz="2400" dirty="0"/>
-              <a:t> K &gt; N</a:t>
-            </a:r>
-          </a:p>
-          <a:p>
-            <a:r>
-              <a:rPr lang="en-US" sz="2400" dirty="0"/>
-              <a:t>  </a:t>
-            </a:r>
-            <a:r>
-              <a:rPr lang="en-US" sz="2400" b="1" dirty="0"/>
-              <a:t>type</a:t>
-            </a:r>
-            <a:r>
-              <a:rPr lang="en-US" sz="2400" dirty="0"/>
-              <a:t> </a:t>
-            </a:r>
-            <a:r>
-              <a:rPr lang="en-US" sz="2400" dirty="0">
-                <a:solidFill>
-                  <a:srgbClr val="0119FF"/>
-                </a:solidFill>
-              </a:rPr>
-              <a:t>ID</a:t>
-            </a:r>
-            <a:r>
-              <a:rPr lang="en-US" sz="2400" dirty="0"/>
-              <a:t>: </a:t>
-            </a:r>
-            <a:r>
-              <a:rPr lang="en-US" sz="2400" b="1" dirty="0"/>
-              <a:t>enumeration</a:t>
-            </a:r>
-            <a:r>
-              <a:rPr lang="en-US" sz="2400" dirty="0"/>
-              <a:t> [0,...,N-1]</a:t>
-            </a:r>
-          </a:p>
-          <a:p>
-            <a:r>
-              <a:rPr lang="en-US" sz="2400" dirty="0"/>
-              <a:t>  </a:t>
-            </a:r>
-            <a:r>
-              <a:rPr lang="en-US" sz="2400" b="1" dirty="0"/>
-              <a:t>type</a:t>
-            </a:r>
-            <a:r>
-              <a:rPr lang="en-US" sz="2400" dirty="0"/>
-              <a:t> </a:t>
-            </a:r>
-            <a:r>
-              <a:rPr lang="en-US" sz="2400" dirty="0">
-                <a:solidFill>
-                  <a:srgbClr val="0119FF"/>
-                </a:solidFill>
-              </a:rPr>
-              <a:t>Val</a:t>
-            </a:r>
-            <a:r>
-              <a:rPr lang="en-US" sz="2400" dirty="0"/>
-              <a:t>: </a:t>
-            </a:r>
-            <a:r>
-              <a:rPr lang="en-US" sz="2400" b="1" dirty="0"/>
-              <a:t>enumeration</a:t>
-            </a:r>
-            <a:r>
-              <a:rPr lang="en-US" sz="2400" dirty="0"/>
-              <a:t> [0,...,K]</a:t>
-            </a:r>
-          </a:p>
-          <a:p>
-            <a:r>
-              <a:rPr lang="en-US" sz="2400" dirty="0"/>
-              <a:t>  </a:t>
-            </a:r>
-            <a:r>
-              <a:rPr lang="en-US" sz="2400" b="1" dirty="0"/>
-              <a:t>actions</a:t>
-            </a:r>
-          </a:p>
-          <a:p>
-            <a:r>
-              <a:rPr lang="en-US" sz="2400" dirty="0"/>
-              <a:t>      </a:t>
-            </a:r>
-            <a:r>
-              <a:rPr lang="en-US" sz="2400" dirty="0">
-                <a:solidFill>
-                  <a:srgbClr val="0119FF"/>
-                </a:solidFill>
-              </a:rPr>
-              <a:t>update</a:t>
-            </a:r>
-            <a:r>
-              <a:rPr lang="en-US" sz="2400" dirty="0"/>
-              <a:t>(</a:t>
-            </a:r>
-            <a:r>
-              <a:rPr lang="en-US" sz="2400" dirty="0" err="1"/>
-              <a:t>i:ID</a:t>
-            </a:r>
-            <a:r>
-              <a:rPr lang="en-US" sz="2400" dirty="0"/>
-              <a:t>)</a:t>
-            </a:r>
-          </a:p>
-          <a:p>
-            <a:r>
-              <a:rPr lang="en-US" sz="2400" dirty="0"/>
-              <a:t>  </a:t>
-            </a:r>
-            <a:r>
-              <a:rPr lang="en-US" sz="2400" b="1" dirty="0"/>
-              <a:t>variables</a:t>
-            </a:r>
-          </a:p>
-          <a:p>
-            <a:r>
-              <a:rPr lang="en-US" sz="2400" dirty="0"/>
-              <a:t>      </a:t>
-            </a:r>
-            <a:r>
-              <a:rPr lang="en-US" sz="2400" dirty="0">
-                <a:solidFill>
-                  <a:srgbClr val="0119FF"/>
-                </a:solidFill>
-              </a:rPr>
-              <a:t>x</a:t>
-            </a:r>
-            <a:r>
-              <a:rPr lang="en-US" sz="2400" dirty="0"/>
-              <a:t>:[ID -&gt; Val]</a:t>
-            </a:r>
-          </a:p>
-          <a:p>
-            <a:r>
-              <a:rPr lang="en-US" sz="2400" dirty="0"/>
-              <a:t>   </a:t>
-            </a:r>
-            <a:r>
-              <a:rPr lang="en-US" sz="2400" b="1" dirty="0"/>
-              <a:t>transitions</a:t>
-            </a:r>
-          </a:p>
-          <a:p>
-            <a:r>
-              <a:rPr lang="en-US" sz="2400" dirty="0"/>
-              <a:t>      </a:t>
-            </a:r>
-            <a:r>
-              <a:rPr lang="en-US" sz="2400" dirty="0">
-                <a:solidFill>
-                  <a:srgbClr val="0119FF"/>
-                </a:solidFill>
-              </a:rPr>
-              <a:t>update</a:t>
-            </a:r>
-            <a:r>
-              <a:rPr lang="en-US" sz="2400" dirty="0"/>
-              <a:t>(</a:t>
-            </a:r>
-            <a:r>
-              <a:rPr lang="en-US" sz="2400" dirty="0" err="1"/>
-              <a:t>i:ID</a:t>
-            </a:r>
-            <a:r>
-              <a:rPr lang="en-US" sz="2400" dirty="0"/>
-              <a:t>) </a:t>
-            </a:r>
-          </a:p>
-          <a:p>
-            <a:r>
-              <a:rPr lang="en-US" sz="2400" b="1" dirty="0"/>
-              <a:t>        pre</a:t>
-            </a:r>
-            <a:r>
-              <a:rPr lang="en-US" sz="2400" dirty="0"/>
-              <a:t> </a:t>
-            </a:r>
-            <a:r>
-              <a:rPr lang="en-US" sz="2400" dirty="0" err="1"/>
-              <a:t>i</a:t>
-            </a:r>
-            <a:r>
-              <a:rPr lang="en-US" sz="2400" dirty="0"/>
-              <a:t> = 0 /\ x[</a:t>
-            </a:r>
-            <a:r>
-              <a:rPr lang="en-US" sz="2400" dirty="0" err="1"/>
-              <a:t>i</a:t>
-            </a:r>
-            <a:r>
-              <a:rPr lang="en-US" sz="2400" dirty="0"/>
-              <a:t>] = x[N-1]</a:t>
-            </a:r>
-          </a:p>
-          <a:p>
-            <a:r>
-              <a:rPr lang="en-US" sz="2400" dirty="0"/>
-              <a:t>        </a:t>
-            </a:r>
-            <a:r>
-              <a:rPr lang="en-US" sz="2400" b="1" dirty="0"/>
-              <a:t>eff</a:t>
-            </a:r>
-            <a:r>
-              <a:rPr lang="en-US" sz="2400" dirty="0"/>
-              <a:t> x[</a:t>
-            </a:r>
-            <a:r>
-              <a:rPr lang="en-US" sz="2400" dirty="0" err="1"/>
-              <a:t>i</a:t>
-            </a:r>
-            <a:r>
-              <a:rPr lang="en-US" sz="2400" dirty="0"/>
-              <a:t>] := (x[</a:t>
-            </a:r>
-            <a:r>
-              <a:rPr lang="en-US" sz="2400" dirty="0" err="1"/>
-              <a:t>i</a:t>
-            </a:r>
-            <a:r>
-              <a:rPr lang="en-US" sz="2400" dirty="0"/>
-              <a:t>] + 1) %  K</a:t>
-            </a:r>
-          </a:p>
-          <a:p>
-            <a:r>
-              <a:rPr lang="en-US" sz="2400" dirty="0"/>
-              <a:t>   </a:t>
-            </a:r>
-          </a:p>
-          <a:p>
-            <a:r>
-              <a:rPr lang="en-US" sz="2400" dirty="0"/>
-              <a:t>       </a:t>
-            </a:r>
-            <a:r>
-              <a:rPr lang="en-US" sz="2400" dirty="0">
-                <a:solidFill>
-                  <a:srgbClr val="0119FF"/>
-                </a:solidFill>
-              </a:rPr>
-              <a:t>update</a:t>
-            </a:r>
-            <a:r>
-              <a:rPr lang="en-US" sz="2400" dirty="0"/>
-              <a:t>(</a:t>
-            </a:r>
-            <a:r>
-              <a:rPr lang="en-US" sz="2400" dirty="0" err="1"/>
-              <a:t>i:ID</a:t>
-            </a:r>
-            <a:r>
-              <a:rPr lang="en-US" sz="2400" dirty="0"/>
-              <a:t>)</a:t>
-            </a:r>
-          </a:p>
-          <a:p>
-            <a:r>
-              <a:rPr lang="en-US" sz="2400" dirty="0"/>
-              <a:t>         </a:t>
-            </a:r>
-            <a:r>
-              <a:rPr lang="en-US" sz="2400" b="1" dirty="0"/>
-              <a:t>pre</a:t>
-            </a:r>
-            <a:r>
-              <a:rPr lang="en-US" sz="2400" dirty="0"/>
-              <a:t> </a:t>
-            </a:r>
-            <a:r>
-              <a:rPr lang="en-US" sz="2400" dirty="0" err="1"/>
-              <a:t>i</a:t>
-            </a:r>
-            <a:r>
-              <a:rPr lang="en-US" sz="2400" dirty="0"/>
-              <a:t> &gt;0  /\ x[</a:t>
-            </a:r>
-            <a:r>
-              <a:rPr lang="en-US" sz="2400" dirty="0" err="1"/>
-              <a:t>i</a:t>
-            </a:r>
-            <a:r>
-              <a:rPr lang="en-US" sz="2400" dirty="0"/>
-              <a:t>] ~= x[i-1]</a:t>
-            </a:r>
-          </a:p>
-          <a:p>
-            <a:r>
-              <a:rPr lang="en-US" sz="2400" dirty="0"/>
-              <a:t>         </a:t>
-            </a:r>
-            <a:r>
-              <a:rPr lang="en-US" sz="2400" b="1" dirty="0"/>
-              <a:t>eff</a:t>
-            </a:r>
-            <a:r>
-              <a:rPr lang="en-US" sz="2400" dirty="0"/>
-              <a:t> x[</a:t>
-            </a:r>
-            <a:r>
-              <a:rPr lang="en-US" sz="2400" dirty="0" err="1"/>
-              <a:t>i</a:t>
-            </a:r>
-            <a:r>
-              <a:rPr lang="en-US" sz="2400" dirty="0"/>
-              <a:t>] := x[i-1]</a:t>
-            </a:r>
-          </a:p>
-        </p:txBody>
-      </p:sp>
-      <p:sp>
-        <p:nvSpPr>
-          <p:cNvPr id="5" name="TextBox 4">
-            <a:extLst>
-              <a:ext uri="{FF2B5EF4-FFF2-40B4-BE49-F238E27FC236}">
-                <a16:creationId xmlns:a16="http://schemas.microsoft.com/office/drawing/2014/main" id="{5DC2086B-C1E3-3047-9A02-47CD138A1299}"/>
-              </a:ext>
-            </a:extLst>
-          </p:cNvPr>
-          <p:cNvSpPr txBox="1"/>
-          <p:nvPr/>
-        </p:nvSpPr>
-        <p:spPr>
-          <a:xfrm>
-            <a:off x="8021373" y="3429000"/>
-            <a:ext cx="3645694" cy="2308324"/>
-          </a:xfrm>
-          <a:prstGeom prst="rect">
-            <a:avLst/>
-          </a:prstGeom>
-          <a:noFill/>
-        </p:spPr>
-        <p:txBody>
-          <a:bodyPr wrap="square" rtlCol="0">
-            <a:spAutoFit/>
-          </a:bodyPr>
-          <a:lstStyle/>
-          <a:p>
-            <a:r>
-              <a:rPr lang="en-US" sz="2400" dirty="0">
-                <a:solidFill>
-                  <a:schemeClr val="accent4">
-                    <a:lumMod val="75000"/>
-                  </a:schemeClr>
-                </a:solidFill>
-              </a:rPr>
-              <a:t>declaration of transitions: for each action this defines when the action can occur (pre) and how the state is updated when the action does occur (eff)</a:t>
-            </a:r>
-          </a:p>
-        </p:txBody>
-      </p:sp>
-      <p:sp>
-        <p:nvSpPr>
-          <p:cNvPr id="6" name="TextBox 5">
-            <a:extLst>
-              <a:ext uri="{FF2B5EF4-FFF2-40B4-BE49-F238E27FC236}">
-                <a16:creationId xmlns:a16="http://schemas.microsoft.com/office/drawing/2014/main" id="{6DE56BD4-9C72-9C4D-AD4D-0227A7ECF5F0}"/>
-              </a:ext>
-            </a:extLst>
-          </p:cNvPr>
-          <p:cNvSpPr txBox="1"/>
-          <p:nvPr/>
-        </p:nvSpPr>
-        <p:spPr>
-          <a:xfrm>
-            <a:off x="5544742" y="6155266"/>
-            <a:ext cx="6647258" cy="461665"/>
-          </a:xfrm>
-          <a:prstGeom prst="rect">
-            <a:avLst/>
-          </a:prstGeom>
-          <a:noFill/>
-        </p:spPr>
-        <p:txBody>
-          <a:bodyPr wrap="square" rtlCol="0">
-            <a:spAutoFit/>
-          </a:bodyPr>
-          <a:lstStyle/>
-          <a:p>
-            <a:r>
-              <a:rPr lang="en-US" sz="2400" dirty="0">
-                <a:solidFill>
-                  <a:schemeClr val="accent4">
-                    <a:lumMod val="75000"/>
-                  </a:schemeClr>
-                </a:solidFill>
-              </a:rPr>
-              <a:t>symbols -&gt; maps, /\ and, \/ or, ~= not equal, % mod</a:t>
-            </a:r>
-          </a:p>
-        </p:txBody>
-      </p:sp>
-    </p:spTree>
-    <p:extLst>
-      <p:ext uri="{BB962C8B-B14F-4D97-AF65-F5344CB8AC3E}">
-        <p14:creationId xmlns:p14="http://schemas.microsoft.com/office/powerpoint/2010/main" val="579389209"/>
-      </p:ext>
-    </p:extLst>
-  </p:cSld>
-  <p:clrMapOvr>
-    <a:masterClrMapping/>
-  </p:clrMapOvr>
-</p:sld>
-</file>
-
-<file path=ppt/slides/slide17.xml><?xml version="1.0" encoding="utf-8"?>
-<p:sld xmlns:a="http://schemas.openxmlformats.org/drawingml/2006/main" xmlns:r="http://schemas.openxmlformats.org/officeDocument/2006/relationships" xmlns:p="http://schemas.openxmlformats.org/presentationml/2006/main">
-  <p:cSld>
-    <p:spTree>
-      <p:nvGrpSpPr>
-        <p:cNvPr id="1" name=""/>
-        <p:cNvGrpSpPr/>
-        <p:nvPr/>
-      </p:nvGrpSpPr>
-      <p:grpSpPr>
-        <a:xfrm>
-          <a:off x="0" y="0"/>
-          <a:ext cx="0" cy="0"/>
-          <a:chOff x="0" y="0"/>
-          <a:chExt cx="0" cy="0"/>
-        </a:xfrm>
-      </p:grpSpPr>
-      <p:sp>
-        <p:nvSpPr>
-          <p:cNvPr id="2" name="Title 1">
-            <a:extLst>
-              <a:ext uri="{FF2B5EF4-FFF2-40B4-BE49-F238E27FC236}">
-                <a16:creationId xmlns:a16="http://schemas.microsoft.com/office/drawing/2014/main" id="{6C511BB6-A486-375B-F43E-0D3D3860A850}"/>
-              </a:ext>
-            </a:extLst>
-          </p:cNvPr>
-          <p:cNvSpPr>
-            <a:spLocks noGrp="1"/>
-          </p:cNvSpPr>
-          <p:nvPr>
-            <p:ph type="title"/>
-          </p:nvPr>
-        </p:nvSpPr>
-        <p:spPr/>
-        <p:txBody>
-          <a:bodyPr/>
-          <a:lstStyle/>
-          <a:p>
-            <a:endParaRPr lang="en-US"/>
-          </a:p>
-        </p:txBody>
-      </p:sp>
-      <p:pic>
-        <p:nvPicPr>
-          <p:cNvPr id="5" name="Picture 4">
-            <a:extLst>
-              <a:ext uri="{FF2B5EF4-FFF2-40B4-BE49-F238E27FC236}">
-                <a16:creationId xmlns:a16="http://schemas.microsoft.com/office/drawing/2014/main" id="{1CB30172-78C2-41FC-0390-4C8A6B546908}"/>
-              </a:ext>
-            </a:extLst>
-          </p:cNvPr>
-          <p:cNvPicPr>
-            <a:picLocks noChangeAspect="1"/>
-          </p:cNvPicPr>
-          <p:nvPr/>
-        </p:nvPicPr>
-        <p:blipFill>
-          <a:blip r:embed="rId2"/>
-          <a:stretch>
-            <a:fillRect/>
-          </a:stretch>
-        </p:blipFill>
-        <p:spPr>
-          <a:xfrm>
-            <a:off x="0" y="2026943"/>
-            <a:ext cx="6728604" cy="3323686"/>
-          </a:xfrm>
-          <a:prstGeom prst="rect">
-            <a:avLst/>
-          </a:prstGeom>
-        </p:spPr>
-      </p:pic>
-    </p:spTree>
-    <p:extLst>
-      <p:ext uri="{BB962C8B-B14F-4D97-AF65-F5344CB8AC3E}">
-        <p14:creationId xmlns:p14="http://schemas.microsoft.com/office/powerpoint/2010/main" val="3814151661"/>
-      </p:ext>
-    </p:extLst>
-  </p:cSld>
-  <p:clrMapOvr>
-    <a:masterClrMapping/>
-  </p:clrMapOvr>
-</p:sld>
-</file>
-
-<file path=ppt/slides/slide18.xml><?xml version="1.0" encoding="utf-8"?>
-<p:sld xmlns:a="http://schemas.openxmlformats.org/drawingml/2006/main" xmlns:r="http://schemas.openxmlformats.org/officeDocument/2006/relationships" xmlns:p="http://schemas.openxmlformats.org/presentationml/2006/main">
-  <p:cSld>
-    <p:spTree>
-      <p:nvGrpSpPr>
-        <p:cNvPr id="1" name=""/>
-        <p:cNvGrpSpPr/>
-        <p:nvPr/>
-      </p:nvGrpSpPr>
-      <p:grpSpPr>
-        <a:xfrm>
-          <a:off x="0" y="0"/>
-          <a:ext cx="0" cy="0"/>
-          <a:chOff x="0" y="0"/>
-          <a:chExt cx="0" cy="0"/>
-        </a:xfrm>
-      </p:grpSpPr>
-      <p:sp>
-        <p:nvSpPr>
           <p:cNvPr id="2" name="Title 1"/>
           <p:cNvSpPr>
             <a:spLocks noGrp="1"/>
@@ -8977,15 +7118,15 @@
               <a:t>Variables, valuations, state space, </a:t>
             </a:r>
             <a:r>
-              <a:rPr lang="en-US" sz="3200"/>
+              <a:rPr lang="en-US" sz="3200" dirty="0" err="1"/>
               <a:t>ececutions</a:t>
             </a:r>
             <a:endParaRPr lang="en-US" sz="3200" dirty="0"/>
           </a:p>
         </p:txBody>
       </p:sp>
-      <mc:AlternateContent xmlns:mc="http://schemas.openxmlformats.org/markup-compatibility/2006" xmlns:a14="http://schemas.microsoft.com/office/drawing/2010/main">
-        <mc:Choice Requires="a14">
+      <mc:AlternateContent xmlns:mc="http://schemas.openxmlformats.org/markup-compatibility/2006">
+        <mc:Choice xmlns:a14="http://schemas.microsoft.com/office/drawing/2010/main" Requires="a14">
           <p:sp>
             <p:nvSpPr>
               <p:cNvPr id="3" name="Content Placeholder 2"/>
@@ -8999,7 +7140,7 @@
             <p:spPr>
               <a:xfrm>
                 <a:off x="579967" y="1690688"/>
-                <a:ext cx="5516033" cy="4879975"/>
+                <a:ext cx="6113441" cy="4879975"/>
               </a:xfrm>
             </p:spPr>
             <p:txBody>
@@ -9252,7 +7393,7 @@
                       <a:rPr lang="en-US" sz="2400" b="0" i="1" smtClean="0">
                         <a:latin typeface="Cambria Math" panose="02040503050406030204" pitchFamily="18" charset="0"/>
                       </a:rPr>
-                      <m:t> = </m:t>
+                      <m:t>= </m:t>
                     </m:r>
                   </m:oMath>
                 </a14:m>
@@ -9552,7 +7693,7 @@
             </p:txBody>
           </p:sp>
         </mc:Choice>
-        <mc:Fallback xmlns="">
+        <mc:Fallback>
           <p:sp>
             <p:nvSpPr>
               <p:cNvPr id="3" name="Content Placeholder 2"/>
@@ -9566,12 +7707,12 @@
             <p:spPr>
               <a:xfrm>
                 <a:off x="579967" y="1690688"/>
-                <a:ext cx="5516033" cy="4879975"/>
+                <a:ext cx="6113441" cy="4879975"/>
               </a:xfrm>
               <a:blipFill>
                 <a:blip r:embed="rId2"/>
                 <a:stretch>
-                  <a:fillRect l="-3678" t="-1299" b="-15325"/>
+                  <a:fillRect l="-1656" t="-1295"/>
                 </a:stretch>
               </a:blipFill>
             </p:spPr>
@@ -10889,6 +9030,1866 @@
 </p:sld>
 </file>
 
+<file path=ppt/slides/slide15.xml><?xml version="1.0" encoding="utf-8"?>
+<p:sld xmlns:a="http://schemas.openxmlformats.org/drawingml/2006/main" xmlns:r="http://schemas.openxmlformats.org/officeDocument/2006/relationships" xmlns:p="http://schemas.openxmlformats.org/presentationml/2006/main">
+  <p:cSld>
+    <p:spTree>
+      <p:nvGrpSpPr>
+        <p:cNvPr id="1" name=""/>
+        <p:cNvGrpSpPr/>
+        <p:nvPr/>
+      </p:nvGrpSpPr>
+      <p:grpSpPr>
+        <a:xfrm>
+          <a:off x="0" y="0"/>
+          <a:ext cx="0" cy="0"/>
+          <a:chOff x="0" y="0"/>
+          <a:chExt cx="0" cy="0"/>
+        </a:xfrm>
+      </p:grpSpPr>
+      <p:sp>
+        <p:nvSpPr>
+          <p:cNvPr id="4" name="Rectangle 3">
+            <a:extLst>
+              <a:ext uri="{FF2B5EF4-FFF2-40B4-BE49-F238E27FC236}">
+                <a16:creationId xmlns:a16="http://schemas.microsoft.com/office/drawing/2014/main" id="{3629A366-D322-A64E-9916-889C92B67AC1}"/>
+              </a:ext>
+            </a:extLst>
+          </p:cNvPr>
+          <p:cNvSpPr/>
+          <p:nvPr/>
+        </p:nvSpPr>
+        <p:spPr>
+          <a:xfrm>
+            <a:off x="838200" y="2131346"/>
+            <a:ext cx="4445000" cy="764254"/>
+          </a:xfrm>
+          <a:prstGeom prst="rect">
+            <a:avLst/>
+          </a:prstGeom>
+          <a:ln>
+            <a:noFill/>
+          </a:ln>
+        </p:spPr>
+        <p:style>
+          <a:lnRef idx="2">
+            <a:schemeClr val="accent4">
+              <a:shade val="50000"/>
+            </a:schemeClr>
+          </a:lnRef>
+          <a:fillRef idx="1">
+            <a:schemeClr val="accent4"/>
+          </a:fillRef>
+          <a:effectRef idx="0">
+            <a:schemeClr val="accent4"/>
+          </a:effectRef>
+          <a:fontRef idx="minor">
+            <a:schemeClr val="lt1"/>
+          </a:fontRef>
+        </p:style>
+        <p:txBody>
+          <a:bodyPr rtlCol="0" anchor="ctr"/>
+          <a:lstStyle/>
+          <a:p>
+            <a:pPr algn="ctr"/>
+            <a:endParaRPr lang="en-US"/>
+          </a:p>
+        </p:txBody>
+      </p:sp>
+      <p:sp>
+        <p:nvSpPr>
+          <p:cNvPr id="3" name="Title 2"/>
+          <p:cNvSpPr>
+            <a:spLocks noGrp="1"/>
+          </p:cNvSpPr>
+          <p:nvPr>
+            <p:ph type="title"/>
+          </p:nvPr>
+        </p:nvSpPr>
+        <p:spPr>
+          <a:xfrm>
+            <a:off x="838200" y="0"/>
+            <a:ext cx="10515600" cy="1325563"/>
+          </a:xfrm>
+        </p:spPr>
+        <p:txBody>
+          <a:bodyPr>
+            <a:normAutofit/>
+          </a:bodyPr>
+          <a:lstStyle/>
+          <a:p>
+            <a:r>
+              <a:rPr lang="en-US" dirty="0"/>
+              <a:t>A language for specifying automata</a:t>
+            </a:r>
+          </a:p>
+        </p:txBody>
+      </p:sp>
+      <p:sp>
+        <p:nvSpPr>
+          <p:cNvPr id="2" name="TextBox 1">
+            <a:extLst>
+              <a:ext uri="{FF2B5EF4-FFF2-40B4-BE49-F238E27FC236}">
+                <a16:creationId xmlns:a16="http://schemas.microsoft.com/office/drawing/2014/main" id="{1417CDEB-59C2-494C-B916-ABA6EEECE1D0}"/>
+              </a:ext>
+            </a:extLst>
+          </p:cNvPr>
+          <p:cNvSpPr txBox="1"/>
+          <p:nvPr/>
+        </p:nvSpPr>
+        <p:spPr>
+          <a:xfrm>
+            <a:off x="926544" y="1022489"/>
+            <a:ext cx="6352701" cy="5632311"/>
+          </a:xfrm>
+          <a:prstGeom prst="rect">
+            <a:avLst/>
+          </a:prstGeom>
+          <a:noFill/>
+        </p:spPr>
+        <p:txBody>
+          <a:bodyPr wrap="none" rtlCol="0">
+            <a:spAutoFit/>
+          </a:bodyPr>
+          <a:lstStyle/>
+          <a:p>
+            <a:r>
+              <a:rPr lang="en-US" sz="2400" b="1" dirty="0"/>
+              <a:t>automaton</a:t>
+            </a:r>
+            <a:r>
+              <a:rPr lang="en-US" sz="2400" dirty="0"/>
+              <a:t> </a:t>
+            </a:r>
+            <a:r>
+              <a:rPr lang="en-US" sz="2400" dirty="0" err="1">
+                <a:solidFill>
+                  <a:srgbClr val="0119FF"/>
+                </a:solidFill>
+              </a:rPr>
+              <a:t>DijkstraTR</a:t>
+            </a:r>
+            <a:r>
+              <a:rPr lang="en-US" sz="2400" dirty="0"/>
+              <a:t>(</a:t>
+            </a:r>
+            <a:r>
+              <a:rPr lang="en-US" sz="2400" dirty="0" err="1"/>
+              <a:t>N:</a:t>
+            </a:r>
+            <a:r>
+              <a:rPr lang="en-US" sz="2400" dirty="0" err="1">
+                <a:solidFill>
+                  <a:srgbClr val="00B050"/>
+                </a:solidFill>
+              </a:rPr>
+              <a:t>Nat</a:t>
+            </a:r>
+            <a:r>
+              <a:rPr lang="en-US" sz="2400" dirty="0"/>
+              <a:t>, </a:t>
+            </a:r>
+            <a:r>
+              <a:rPr lang="en-US" sz="2400" dirty="0" err="1"/>
+              <a:t>K:</a:t>
+            </a:r>
+            <a:r>
+              <a:rPr lang="en-US" sz="2400" dirty="0" err="1">
+                <a:solidFill>
+                  <a:srgbClr val="00B050"/>
+                </a:solidFill>
+              </a:rPr>
+              <a:t>Nat</a:t>
+            </a:r>
+            <a:r>
+              <a:rPr lang="en-US" sz="2400" dirty="0"/>
+              <a:t>), </a:t>
+            </a:r>
+            <a:r>
+              <a:rPr lang="en-US" sz="2400" b="1" dirty="0"/>
+              <a:t>where</a:t>
+            </a:r>
+            <a:r>
+              <a:rPr lang="en-US" sz="2400" dirty="0"/>
+              <a:t> K &gt; N</a:t>
+            </a:r>
+          </a:p>
+          <a:p>
+            <a:r>
+              <a:rPr lang="en-US" sz="2400" dirty="0"/>
+              <a:t>  </a:t>
+            </a:r>
+            <a:r>
+              <a:rPr lang="en-US" sz="2400" b="1" dirty="0"/>
+              <a:t>type</a:t>
+            </a:r>
+            <a:r>
+              <a:rPr lang="en-US" sz="2400" dirty="0"/>
+              <a:t> </a:t>
+            </a:r>
+            <a:r>
+              <a:rPr lang="en-US" sz="2400" dirty="0">
+                <a:solidFill>
+                  <a:srgbClr val="0119FF"/>
+                </a:solidFill>
+              </a:rPr>
+              <a:t>ID</a:t>
+            </a:r>
+            <a:r>
+              <a:rPr lang="en-US" sz="2400" dirty="0"/>
+              <a:t>: </a:t>
+            </a:r>
+            <a:r>
+              <a:rPr lang="en-US" sz="2400" b="1" dirty="0"/>
+              <a:t>enumeration</a:t>
+            </a:r>
+            <a:r>
+              <a:rPr lang="en-US" sz="2400" dirty="0"/>
+              <a:t> [0,...,N-1]</a:t>
+            </a:r>
+          </a:p>
+          <a:p>
+            <a:r>
+              <a:rPr lang="en-US" sz="2400" dirty="0"/>
+              <a:t>  </a:t>
+            </a:r>
+            <a:r>
+              <a:rPr lang="en-US" sz="2400" b="1" dirty="0"/>
+              <a:t>type</a:t>
+            </a:r>
+            <a:r>
+              <a:rPr lang="en-US" sz="2400" dirty="0"/>
+              <a:t> </a:t>
+            </a:r>
+            <a:r>
+              <a:rPr lang="en-US" sz="2400" dirty="0">
+                <a:solidFill>
+                  <a:srgbClr val="0119FF"/>
+                </a:solidFill>
+              </a:rPr>
+              <a:t>Val</a:t>
+            </a:r>
+            <a:r>
+              <a:rPr lang="en-US" sz="2400" dirty="0"/>
+              <a:t>: </a:t>
+            </a:r>
+            <a:r>
+              <a:rPr lang="en-US" sz="2400" b="1" dirty="0"/>
+              <a:t>enumeration</a:t>
+            </a:r>
+            <a:r>
+              <a:rPr lang="en-US" sz="2400" dirty="0"/>
+              <a:t> [0,...,K]</a:t>
+            </a:r>
+          </a:p>
+          <a:p>
+            <a:r>
+              <a:rPr lang="en-US" sz="2400" dirty="0"/>
+              <a:t>  </a:t>
+            </a:r>
+            <a:r>
+              <a:rPr lang="en-US" sz="2400" b="1" dirty="0"/>
+              <a:t>actions</a:t>
+            </a:r>
+          </a:p>
+          <a:p>
+            <a:r>
+              <a:rPr lang="en-US" sz="2400" dirty="0"/>
+              <a:t>      </a:t>
+            </a:r>
+            <a:r>
+              <a:rPr lang="en-US" sz="2400" dirty="0">
+                <a:solidFill>
+                  <a:srgbClr val="0119FF"/>
+                </a:solidFill>
+              </a:rPr>
+              <a:t>update</a:t>
+            </a:r>
+            <a:r>
+              <a:rPr lang="en-US" sz="2400" dirty="0"/>
+              <a:t>(</a:t>
+            </a:r>
+            <a:r>
+              <a:rPr lang="en-US" sz="2400" dirty="0" err="1"/>
+              <a:t>i:ID</a:t>
+            </a:r>
+            <a:r>
+              <a:rPr lang="en-US" sz="2400" dirty="0"/>
+              <a:t>)</a:t>
+            </a:r>
+          </a:p>
+          <a:p>
+            <a:r>
+              <a:rPr lang="en-US" sz="2400" dirty="0"/>
+              <a:t>  </a:t>
+            </a:r>
+            <a:r>
+              <a:rPr lang="en-US" sz="2400" b="1" dirty="0"/>
+              <a:t>variables</a:t>
+            </a:r>
+          </a:p>
+          <a:p>
+            <a:r>
+              <a:rPr lang="en-US" sz="2400" dirty="0"/>
+              <a:t>      </a:t>
+            </a:r>
+            <a:r>
+              <a:rPr lang="en-US" sz="2400" dirty="0">
+                <a:solidFill>
+                  <a:srgbClr val="0119FF"/>
+                </a:solidFill>
+              </a:rPr>
+              <a:t>x</a:t>
+            </a:r>
+            <a:r>
+              <a:rPr lang="en-US" sz="2400" dirty="0"/>
+              <a:t>:[ID -&gt; Val]</a:t>
+            </a:r>
+          </a:p>
+          <a:p>
+            <a:r>
+              <a:rPr lang="en-US" sz="2400" dirty="0"/>
+              <a:t>   </a:t>
+            </a:r>
+            <a:r>
+              <a:rPr lang="en-US" sz="2400" b="1" dirty="0"/>
+              <a:t>transitions</a:t>
+            </a:r>
+          </a:p>
+          <a:p>
+            <a:r>
+              <a:rPr lang="en-US" sz="2400" dirty="0"/>
+              <a:t>      </a:t>
+            </a:r>
+            <a:r>
+              <a:rPr lang="en-US" sz="2400" dirty="0">
+                <a:solidFill>
+                  <a:srgbClr val="0119FF"/>
+                </a:solidFill>
+              </a:rPr>
+              <a:t>update</a:t>
+            </a:r>
+            <a:r>
+              <a:rPr lang="en-US" sz="2400" dirty="0"/>
+              <a:t>(</a:t>
+            </a:r>
+            <a:r>
+              <a:rPr lang="en-US" sz="2400" dirty="0" err="1"/>
+              <a:t>i:ID</a:t>
+            </a:r>
+            <a:r>
+              <a:rPr lang="en-US" sz="2400" dirty="0"/>
+              <a:t>) </a:t>
+            </a:r>
+          </a:p>
+          <a:p>
+            <a:r>
+              <a:rPr lang="en-US" sz="2400" dirty="0"/>
+              <a:t>        </a:t>
+            </a:r>
+            <a:r>
+              <a:rPr lang="en-US" sz="2400" b="1" dirty="0"/>
+              <a:t>pre</a:t>
+            </a:r>
+            <a:r>
+              <a:rPr lang="en-US" sz="2400" dirty="0"/>
+              <a:t> </a:t>
+            </a:r>
+            <a:r>
+              <a:rPr lang="en-US" sz="2400" dirty="0" err="1"/>
+              <a:t>i</a:t>
+            </a:r>
+            <a:r>
+              <a:rPr lang="en-US" sz="2400" dirty="0"/>
+              <a:t> = 0 /\ x[</a:t>
+            </a:r>
+            <a:r>
+              <a:rPr lang="en-US" sz="2400" dirty="0" err="1"/>
+              <a:t>i</a:t>
+            </a:r>
+            <a:r>
+              <a:rPr lang="en-US" sz="2400" dirty="0"/>
+              <a:t>] = x[N-1]</a:t>
+            </a:r>
+          </a:p>
+          <a:p>
+            <a:r>
+              <a:rPr lang="en-US" sz="2400" dirty="0"/>
+              <a:t>        </a:t>
+            </a:r>
+            <a:r>
+              <a:rPr lang="en-US" sz="2400" b="1" dirty="0"/>
+              <a:t>eff</a:t>
+            </a:r>
+            <a:r>
+              <a:rPr lang="en-US" sz="2400" dirty="0"/>
+              <a:t> x[</a:t>
+            </a:r>
+            <a:r>
+              <a:rPr lang="en-US" sz="2400" dirty="0" err="1"/>
+              <a:t>i</a:t>
+            </a:r>
+            <a:r>
+              <a:rPr lang="en-US" sz="2400" dirty="0"/>
+              <a:t>] := (x[</a:t>
+            </a:r>
+            <a:r>
+              <a:rPr lang="en-US" sz="2400" dirty="0" err="1"/>
+              <a:t>i</a:t>
+            </a:r>
+            <a:r>
+              <a:rPr lang="en-US" sz="2400" dirty="0"/>
+              <a:t>] + 1) %  K</a:t>
+            </a:r>
+          </a:p>
+          <a:p>
+            <a:r>
+              <a:rPr lang="en-US" sz="2400" dirty="0"/>
+              <a:t>   </a:t>
+            </a:r>
+          </a:p>
+          <a:p>
+            <a:r>
+              <a:rPr lang="en-US" sz="2400" dirty="0"/>
+              <a:t>       </a:t>
+            </a:r>
+            <a:r>
+              <a:rPr lang="en-US" sz="2400" dirty="0">
+                <a:solidFill>
+                  <a:srgbClr val="0119FF"/>
+                </a:solidFill>
+              </a:rPr>
+              <a:t>update</a:t>
+            </a:r>
+            <a:r>
+              <a:rPr lang="en-US" sz="2400" dirty="0"/>
+              <a:t>(</a:t>
+            </a:r>
+            <a:r>
+              <a:rPr lang="en-US" sz="2400" dirty="0" err="1"/>
+              <a:t>i:ID</a:t>
+            </a:r>
+            <a:r>
+              <a:rPr lang="en-US" sz="2400" dirty="0"/>
+              <a:t>)</a:t>
+            </a:r>
+          </a:p>
+          <a:p>
+            <a:r>
+              <a:rPr lang="en-US" sz="2400" dirty="0"/>
+              <a:t>         </a:t>
+            </a:r>
+            <a:r>
+              <a:rPr lang="en-US" sz="2400" b="1" dirty="0"/>
+              <a:t>pre</a:t>
+            </a:r>
+            <a:r>
+              <a:rPr lang="en-US" sz="2400" dirty="0"/>
+              <a:t> </a:t>
+            </a:r>
+            <a:r>
+              <a:rPr lang="en-US" sz="2400" dirty="0" err="1"/>
+              <a:t>i</a:t>
+            </a:r>
+            <a:r>
+              <a:rPr lang="en-US" sz="2400" dirty="0"/>
+              <a:t> &gt;0  /\ x[</a:t>
+            </a:r>
+            <a:r>
+              <a:rPr lang="en-US" sz="2400" dirty="0" err="1"/>
+              <a:t>i</a:t>
+            </a:r>
+            <a:r>
+              <a:rPr lang="en-US" sz="2400" dirty="0"/>
+              <a:t>] ~= x[i-1]</a:t>
+            </a:r>
+          </a:p>
+          <a:p>
+            <a:r>
+              <a:rPr lang="en-US" sz="2400" dirty="0"/>
+              <a:t>         </a:t>
+            </a:r>
+            <a:r>
+              <a:rPr lang="en-US" sz="2400" b="1" dirty="0"/>
+              <a:t>eff</a:t>
+            </a:r>
+            <a:r>
+              <a:rPr lang="en-US" sz="2400" dirty="0"/>
+              <a:t> x[</a:t>
+            </a:r>
+            <a:r>
+              <a:rPr lang="en-US" sz="2400" dirty="0" err="1"/>
+              <a:t>i</a:t>
+            </a:r>
+            <a:r>
+              <a:rPr lang="en-US" sz="2400" dirty="0"/>
+              <a:t>] := x[i-1]</a:t>
+            </a:r>
+          </a:p>
+        </p:txBody>
+      </p:sp>
+      <p:sp>
+        <p:nvSpPr>
+          <p:cNvPr id="5" name="TextBox 4">
+            <a:extLst>
+              <a:ext uri="{FF2B5EF4-FFF2-40B4-BE49-F238E27FC236}">
+                <a16:creationId xmlns:a16="http://schemas.microsoft.com/office/drawing/2014/main" id="{5DC2086B-C1E3-3047-9A02-47CD138A1299}"/>
+              </a:ext>
+            </a:extLst>
+          </p:cNvPr>
+          <p:cNvSpPr txBox="1"/>
+          <p:nvPr/>
+        </p:nvSpPr>
+        <p:spPr>
+          <a:xfrm>
+            <a:off x="8089106" y="1977682"/>
+            <a:ext cx="3645694" cy="2308324"/>
+          </a:xfrm>
+          <a:prstGeom prst="rect">
+            <a:avLst/>
+          </a:prstGeom>
+          <a:noFill/>
+        </p:spPr>
+        <p:txBody>
+          <a:bodyPr wrap="square" rtlCol="0">
+            <a:spAutoFit/>
+          </a:bodyPr>
+          <a:lstStyle/>
+          <a:p>
+            <a:r>
+              <a:rPr lang="en-US" sz="2400" dirty="0">
+                <a:solidFill>
+                  <a:schemeClr val="accent4">
+                    <a:lumMod val="75000"/>
+                  </a:schemeClr>
+                </a:solidFill>
+              </a:rPr>
+              <a:t>declaration of “actions” or transition labels; actions can have parameter; this declares the actions update(0), update(1), …, update(N-1)</a:t>
+            </a:r>
+          </a:p>
+        </p:txBody>
+      </p:sp>
+      <p:sp>
+        <p:nvSpPr>
+          <p:cNvPr id="6" name="TextBox 5">
+            <a:extLst>
+              <a:ext uri="{FF2B5EF4-FFF2-40B4-BE49-F238E27FC236}">
+                <a16:creationId xmlns:a16="http://schemas.microsoft.com/office/drawing/2014/main" id="{AFE56EDA-4014-D04A-9928-4956AA1A4C3A}"/>
+              </a:ext>
+            </a:extLst>
+          </p:cNvPr>
+          <p:cNvSpPr txBox="1"/>
+          <p:nvPr/>
+        </p:nvSpPr>
+        <p:spPr>
+          <a:xfrm>
+            <a:off x="5544742" y="6155266"/>
+            <a:ext cx="6647258" cy="461665"/>
+          </a:xfrm>
+          <a:prstGeom prst="rect">
+            <a:avLst/>
+          </a:prstGeom>
+          <a:noFill/>
+        </p:spPr>
+        <p:txBody>
+          <a:bodyPr wrap="square" rtlCol="0">
+            <a:spAutoFit/>
+          </a:bodyPr>
+          <a:lstStyle/>
+          <a:p>
+            <a:r>
+              <a:rPr lang="en-US" sz="2400" dirty="0">
+                <a:solidFill>
+                  <a:schemeClr val="accent4">
+                    <a:lumMod val="75000"/>
+                  </a:schemeClr>
+                </a:solidFill>
+              </a:rPr>
+              <a:t>symbols -&gt; maps, /\ and, \/ or, ~= not equal, % mod</a:t>
+            </a:r>
+          </a:p>
+        </p:txBody>
+      </p:sp>
+    </p:spTree>
+    <p:extLst>
+      <p:ext uri="{BB962C8B-B14F-4D97-AF65-F5344CB8AC3E}">
+        <p14:creationId xmlns:p14="http://schemas.microsoft.com/office/powerpoint/2010/main" val="1933890637"/>
+      </p:ext>
+    </p:extLst>
+  </p:cSld>
+  <p:clrMapOvr>
+    <a:masterClrMapping/>
+  </p:clrMapOvr>
+</p:sld>
+</file>
+
+<file path=ppt/slides/slide16.xml><?xml version="1.0" encoding="utf-8"?>
+<p:sld xmlns:a="http://schemas.openxmlformats.org/drawingml/2006/main" xmlns:r="http://schemas.openxmlformats.org/officeDocument/2006/relationships" xmlns:p="http://schemas.openxmlformats.org/presentationml/2006/main">
+  <p:cSld>
+    <p:spTree>
+      <p:nvGrpSpPr>
+        <p:cNvPr id="1" name=""/>
+        <p:cNvGrpSpPr/>
+        <p:nvPr/>
+      </p:nvGrpSpPr>
+      <p:grpSpPr>
+        <a:xfrm>
+          <a:off x="0" y="0"/>
+          <a:ext cx="0" cy="0"/>
+          <a:chOff x="0" y="0"/>
+          <a:chExt cx="0" cy="0"/>
+        </a:xfrm>
+      </p:grpSpPr>
+      <p:sp>
+        <p:nvSpPr>
+          <p:cNvPr id="4" name="Rectangle 3">
+            <a:extLst>
+              <a:ext uri="{FF2B5EF4-FFF2-40B4-BE49-F238E27FC236}">
+                <a16:creationId xmlns:a16="http://schemas.microsoft.com/office/drawing/2014/main" id="{3629A366-D322-A64E-9916-889C92B67AC1}"/>
+              </a:ext>
+            </a:extLst>
+          </p:cNvPr>
+          <p:cNvSpPr/>
+          <p:nvPr/>
+        </p:nvSpPr>
+        <p:spPr>
+          <a:xfrm>
+            <a:off x="838200" y="2927212"/>
+            <a:ext cx="4445000" cy="764254"/>
+          </a:xfrm>
+          <a:prstGeom prst="rect">
+            <a:avLst/>
+          </a:prstGeom>
+          <a:ln>
+            <a:noFill/>
+          </a:ln>
+        </p:spPr>
+        <p:style>
+          <a:lnRef idx="2">
+            <a:schemeClr val="accent4">
+              <a:shade val="50000"/>
+            </a:schemeClr>
+          </a:lnRef>
+          <a:fillRef idx="1">
+            <a:schemeClr val="accent4"/>
+          </a:fillRef>
+          <a:effectRef idx="0">
+            <a:schemeClr val="accent4"/>
+          </a:effectRef>
+          <a:fontRef idx="minor">
+            <a:schemeClr val="lt1"/>
+          </a:fontRef>
+        </p:style>
+        <p:txBody>
+          <a:bodyPr rtlCol="0" anchor="ctr"/>
+          <a:lstStyle/>
+          <a:p>
+            <a:pPr algn="ctr"/>
+            <a:endParaRPr lang="en-US"/>
+          </a:p>
+        </p:txBody>
+      </p:sp>
+      <p:sp>
+        <p:nvSpPr>
+          <p:cNvPr id="3" name="Title 2"/>
+          <p:cNvSpPr>
+            <a:spLocks noGrp="1"/>
+          </p:cNvSpPr>
+          <p:nvPr>
+            <p:ph type="title"/>
+          </p:nvPr>
+        </p:nvSpPr>
+        <p:spPr>
+          <a:xfrm>
+            <a:off x="838200" y="0"/>
+            <a:ext cx="10515600" cy="1325563"/>
+          </a:xfrm>
+        </p:spPr>
+        <p:txBody>
+          <a:bodyPr>
+            <a:normAutofit/>
+          </a:bodyPr>
+          <a:lstStyle/>
+          <a:p>
+            <a:r>
+              <a:rPr lang="en-US" dirty="0"/>
+              <a:t>A language for specifying automata</a:t>
+            </a:r>
+          </a:p>
+        </p:txBody>
+      </p:sp>
+      <p:sp>
+        <p:nvSpPr>
+          <p:cNvPr id="2" name="TextBox 1">
+            <a:extLst>
+              <a:ext uri="{FF2B5EF4-FFF2-40B4-BE49-F238E27FC236}">
+                <a16:creationId xmlns:a16="http://schemas.microsoft.com/office/drawing/2014/main" id="{1417CDEB-59C2-494C-B916-ABA6EEECE1D0}"/>
+              </a:ext>
+            </a:extLst>
+          </p:cNvPr>
+          <p:cNvSpPr txBox="1"/>
+          <p:nvPr/>
+        </p:nvSpPr>
+        <p:spPr>
+          <a:xfrm>
+            <a:off x="926544" y="1022489"/>
+            <a:ext cx="6352701" cy="5632311"/>
+          </a:xfrm>
+          <a:prstGeom prst="rect">
+            <a:avLst/>
+          </a:prstGeom>
+          <a:noFill/>
+        </p:spPr>
+        <p:txBody>
+          <a:bodyPr wrap="none" rtlCol="0">
+            <a:spAutoFit/>
+          </a:bodyPr>
+          <a:lstStyle/>
+          <a:p>
+            <a:r>
+              <a:rPr lang="en-US" sz="2400" b="1" dirty="0"/>
+              <a:t>automaton</a:t>
+            </a:r>
+            <a:r>
+              <a:rPr lang="en-US" sz="2400" dirty="0"/>
+              <a:t> </a:t>
+            </a:r>
+            <a:r>
+              <a:rPr lang="en-US" sz="2400" dirty="0" err="1">
+                <a:solidFill>
+                  <a:srgbClr val="0119FF"/>
+                </a:solidFill>
+              </a:rPr>
+              <a:t>DijkstraTR</a:t>
+            </a:r>
+            <a:r>
+              <a:rPr lang="en-US" sz="2400" dirty="0"/>
+              <a:t>(</a:t>
+            </a:r>
+            <a:r>
+              <a:rPr lang="en-US" sz="2400" dirty="0" err="1"/>
+              <a:t>N:</a:t>
+            </a:r>
+            <a:r>
+              <a:rPr lang="en-US" sz="2400" dirty="0" err="1">
+                <a:solidFill>
+                  <a:srgbClr val="00B050"/>
+                </a:solidFill>
+              </a:rPr>
+              <a:t>Nat</a:t>
+            </a:r>
+            <a:r>
+              <a:rPr lang="en-US" sz="2400" dirty="0"/>
+              <a:t>, </a:t>
+            </a:r>
+            <a:r>
+              <a:rPr lang="en-US" sz="2400" dirty="0" err="1"/>
+              <a:t>K:</a:t>
+            </a:r>
+            <a:r>
+              <a:rPr lang="en-US" sz="2400" dirty="0" err="1">
+                <a:solidFill>
+                  <a:srgbClr val="00B050"/>
+                </a:solidFill>
+              </a:rPr>
+              <a:t>Nat</a:t>
+            </a:r>
+            <a:r>
+              <a:rPr lang="en-US" sz="2400" dirty="0"/>
+              <a:t>), </a:t>
+            </a:r>
+            <a:r>
+              <a:rPr lang="en-US" sz="2400" b="1" dirty="0"/>
+              <a:t>where</a:t>
+            </a:r>
+            <a:r>
+              <a:rPr lang="en-US" sz="2400" dirty="0"/>
+              <a:t> K &gt; N</a:t>
+            </a:r>
+          </a:p>
+          <a:p>
+            <a:r>
+              <a:rPr lang="en-US" sz="2400" dirty="0"/>
+              <a:t>  </a:t>
+            </a:r>
+            <a:r>
+              <a:rPr lang="en-US" sz="2400" b="1" dirty="0"/>
+              <a:t>type</a:t>
+            </a:r>
+            <a:r>
+              <a:rPr lang="en-US" sz="2400" dirty="0"/>
+              <a:t> </a:t>
+            </a:r>
+            <a:r>
+              <a:rPr lang="en-US" sz="2400" dirty="0">
+                <a:solidFill>
+                  <a:srgbClr val="0119FF"/>
+                </a:solidFill>
+              </a:rPr>
+              <a:t>ID</a:t>
+            </a:r>
+            <a:r>
+              <a:rPr lang="en-US" sz="2400" dirty="0"/>
+              <a:t>: </a:t>
+            </a:r>
+            <a:r>
+              <a:rPr lang="en-US" sz="2400" b="1" dirty="0"/>
+              <a:t>enumeration</a:t>
+            </a:r>
+            <a:r>
+              <a:rPr lang="en-US" sz="2400" dirty="0"/>
+              <a:t> [0,...,N-1]</a:t>
+            </a:r>
+          </a:p>
+          <a:p>
+            <a:r>
+              <a:rPr lang="en-US" sz="2400" dirty="0"/>
+              <a:t>  </a:t>
+            </a:r>
+            <a:r>
+              <a:rPr lang="en-US" sz="2400" b="1" dirty="0"/>
+              <a:t>type</a:t>
+            </a:r>
+            <a:r>
+              <a:rPr lang="en-US" sz="2400" dirty="0"/>
+              <a:t> </a:t>
+            </a:r>
+            <a:r>
+              <a:rPr lang="en-US" sz="2400" dirty="0">
+                <a:solidFill>
+                  <a:srgbClr val="0119FF"/>
+                </a:solidFill>
+              </a:rPr>
+              <a:t>Val</a:t>
+            </a:r>
+            <a:r>
+              <a:rPr lang="en-US" sz="2400" dirty="0"/>
+              <a:t>: </a:t>
+            </a:r>
+            <a:r>
+              <a:rPr lang="en-US" sz="2400" b="1" dirty="0"/>
+              <a:t>enumeration</a:t>
+            </a:r>
+            <a:r>
+              <a:rPr lang="en-US" sz="2400" dirty="0"/>
+              <a:t> [0,...,K]</a:t>
+            </a:r>
+          </a:p>
+          <a:p>
+            <a:r>
+              <a:rPr lang="en-US" sz="2400" dirty="0"/>
+              <a:t>  </a:t>
+            </a:r>
+            <a:r>
+              <a:rPr lang="en-US" sz="2400" b="1" dirty="0"/>
+              <a:t>actions</a:t>
+            </a:r>
+          </a:p>
+          <a:p>
+            <a:r>
+              <a:rPr lang="en-US" sz="2400" dirty="0"/>
+              <a:t>      </a:t>
+            </a:r>
+            <a:r>
+              <a:rPr lang="en-US" sz="2400" dirty="0">
+                <a:solidFill>
+                  <a:srgbClr val="0119FF"/>
+                </a:solidFill>
+              </a:rPr>
+              <a:t>update</a:t>
+            </a:r>
+            <a:r>
+              <a:rPr lang="en-US" sz="2400" dirty="0"/>
+              <a:t>(</a:t>
+            </a:r>
+            <a:r>
+              <a:rPr lang="en-US" sz="2400" dirty="0" err="1"/>
+              <a:t>i:ID</a:t>
+            </a:r>
+            <a:r>
+              <a:rPr lang="en-US" sz="2400" dirty="0"/>
+              <a:t>)</a:t>
+            </a:r>
+          </a:p>
+          <a:p>
+            <a:r>
+              <a:rPr lang="en-US" sz="2400" dirty="0"/>
+              <a:t>  </a:t>
+            </a:r>
+            <a:r>
+              <a:rPr lang="en-US" sz="2400" b="1" dirty="0"/>
+              <a:t>variables</a:t>
+            </a:r>
+          </a:p>
+          <a:p>
+            <a:r>
+              <a:rPr lang="en-US" sz="2400" dirty="0"/>
+              <a:t>      </a:t>
+            </a:r>
+            <a:r>
+              <a:rPr lang="en-US" sz="2400" dirty="0">
+                <a:solidFill>
+                  <a:srgbClr val="0119FF"/>
+                </a:solidFill>
+              </a:rPr>
+              <a:t>x</a:t>
+            </a:r>
+            <a:r>
+              <a:rPr lang="en-US" sz="2400" dirty="0"/>
+              <a:t>:[ID -&gt; Val]</a:t>
+            </a:r>
+          </a:p>
+          <a:p>
+            <a:r>
+              <a:rPr lang="en-US" sz="2400" dirty="0"/>
+              <a:t>   </a:t>
+            </a:r>
+            <a:r>
+              <a:rPr lang="en-US" sz="2400" b="1" dirty="0"/>
+              <a:t>transitions</a:t>
+            </a:r>
+          </a:p>
+          <a:p>
+            <a:r>
+              <a:rPr lang="en-US" sz="2400" dirty="0"/>
+              <a:t>      </a:t>
+            </a:r>
+            <a:r>
+              <a:rPr lang="en-US" sz="2400" dirty="0">
+                <a:solidFill>
+                  <a:srgbClr val="0119FF"/>
+                </a:solidFill>
+              </a:rPr>
+              <a:t>update</a:t>
+            </a:r>
+            <a:r>
+              <a:rPr lang="en-US" sz="2400" dirty="0"/>
+              <a:t>(</a:t>
+            </a:r>
+            <a:r>
+              <a:rPr lang="en-US" sz="2400" dirty="0" err="1"/>
+              <a:t>i:ID</a:t>
+            </a:r>
+            <a:r>
+              <a:rPr lang="en-US" sz="2400" dirty="0"/>
+              <a:t>)</a:t>
+            </a:r>
+          </a:p>
+          <a:p>
+            <a:r>
+              <a:rPr lang="en-US" sz="2400" dirty="0"/>
+              <a:t>        </a:t>
+            </a:r>
+            <a:r>
+              <a:rPr lang="en-US" sz="2400" b="1" dirty="0"/>
+              <a:t>pre</a:t>
+            </a:r>
+            <a:r>
+              <a:rPr lang="en-US" sz="2400" dirty="0"/>
+              <a:t> </a:t>
+            </a:r>
+            <a:r>
+              <a:rPr lang="en-US" sz="2400" dirty="0" err="1"/>
+              <a:t>i</a:t>
+            </a:r>
+            <a:r>
+              <a:rPr lang="en-US" sz="2400" dirty="0"/>
+              <a:t> = 0 /\ x[</a:t>
+            </a:r>
+            <a:r>
+              <a:rPr lang="en-US" sz="2400" dirty="0" err="1"/>
+              <a:t>i</a:t>
+            </a:r>
+            <a:r>
+              <a:rPr lang="en-US" sz="2400" dirty="0"/>
+              <a:t>] = x[N-1]</a:t>
+            </a:r>
+          </a:p>
+          <a:p>
+            <a:r>
+              <a:rPr lang="en-US" sz="2400" dirty="0"/>
+              <a:t>        </a:t>
+            </a:r>
+            <a:r>
+              <a:rPr lang="en-US" sz="2400" b="1" dirty="0"/>
+              <a:t>eff</a:t>
+            </a:r>
+            <a:r>
+              <a:rPr lang="en-US" sz="2400" dirty="0"/>
+              <a:t> x[</a:t>
+            </a:r>
+            <a:r>
+              <a:rPr lang="en-US" sz="2400" dirty="0" err="1"/>
+              <a:t>i</a:t>
+            </a:r>
+            <a:r>
+              <a:rPr lang="en-US" sz="2400" dirty="0"/>
+              <a:t>] := (x[</a:t>
+            </a:r>
+            <a:r>
+              <a:rPr lang="en-US" sz="2400" dirty="0" err="1"/>
+              <a:t>i</a:t>
+            </a:r>
+            <a:r>
+              <a:rPr lang="en-US" sz="2400" dirty="0"/>
+              <a:t>] + 1) %  K</a:t>
+            </a:r>
+          </a:p>
+          <a:p>
+            <a:r>
+              <a:rPr lang="en-US" sz="2400" dirty="0"/>
+              <a:t>   </a:t>
+            </a:r>
+          </a:p>
+          <a:p>
+            <a:r>
+              <a:rPr lang="en-US" sz="2400" dirty="0"/>
+              <a:t>       </a:t>
+            </a:r>
+            <a:r>
+              <a:rPr lang="en-US" sz="2400" dirty="0">
+                <a:solidFill>
+                  <a:srgbClr val="0119FF"/>
+                </a:solidFill>
+              </a:rPr>
+              <a:t>update</a:t>
+            </a:r>
+            <a:r>
+              <a:rPr lang="en-US" sz="2400" dirty="0"/>
+              <a:t>(</a:t>
+            </a:r>
+            <a:r>
+              <a:rPr lang="en-US" sz="2400" dirty="0" err="1"/>
+              <a:t>i:ID</a:t>
+            </a:r>
+            <a:r>
+              <a:rPr lang="en-US" sz="2400" dirty="0"/>
+              <a:t>)</a:t>
+            </a:r>
+          </a:p>
+          <a:p>
+            <a:r>
+              <a:rPr lang="en-US" sz="2400" dirty="0"/>
+              <a:t>         </a:t>
+            </a:r>
+            <a:r>
+              <a:rPr lang="en-US" sz="2400" b="1" dirty="0"/>
+              <a:t>pre</a:t>
+            </a:r>
+            <a:r>
+              <a:rPr lang="en-US" sz="2400" dirty="0"/>
+              <a:t> </a:t>
+            </a:r>
+            <a:r>
+              <a:rPr lang="en-US" sz="2400" dirty="0" err="1"/>
+              <a:t>i</a:t>
+            </a:r>
+            <a:r>
+              <a:rPr lang="en-US" sz="2400" dirty="0"/>
+              <a:t> &gt;0  /\ x[</a:t>
+            </a:r>
+            <a:r>
+              <a:rPr lang="en-US" sz="2400" dirty="0" err="1"/>
+              <a:t>i</a:t>
+            </a:r>
+            <a:r>
+              <a:rPr lang="en-US" sz="2400" dirty="0"/>
+              <a:t>] ~= x[i-1]</a:t>
+            </a:r>
+          </a:p>
+          <a:p>
+            <a:r>
+              <a:rPr lang="en-US" sz="2400" dirty="0"/>
+              <a:t>         </a:t>
+            </a:r>
+            <a:r>
+              <a:rPr lang="en-US" sz="2400" b="1" dirty="0"/>
+              <a:t>eff</a:t>
+            </a:r>
+            <a:r>
+              <a:rPr lang="en-US" sz="2400" dirty="0"/>
+              <a:t> x[</a:t>
+            </a:r>
+            <a:r>
+              <a:rPr lang="en-US" sz="2400" dirty="0" err="1"/>
+              <a:t>i</a:t>
+            </a:r>
+            <a:r>
+              <a:rPr lang="en-US" sz="2400" dirty="0"/>
+              <a:t>] := x[i-1]</a:t>
+            </a:r>
+          </a:p>
+        </p:txBody>
+      </p:sp>
+      <p:sp>
+        <p:nvSpPr>
+          <p:cNvPr id="5" name="TextBox 4">
+            <a:extLst>
+              <a:ext uri="{FF2B5EF4-FFF2-40B4-BE49-F238E27FC236}">
+                <a16:creationId xmlns:a16="http://schemas.microsoft.com/office/drawing/2014/main" id="{5DC2086B-C1E3-3047-9A02-47CD138A1299}"/>
+              </a:ext>
+            </a:extLst>
+          </p:cNvPr>
+          <p:cNvSpPr txBox="1"/>
+          <p:nvPr/>
+        </p:nvSpPr>
+        <p:spPr>
+          <a:xfrm>
+            <a:off x="8089106" y="1977682"/>
+            <a:ext cx="3645694" cy="1569660"/>
+          </a:xfrm>
+          <a:prstGeom prst="rect">
+            <a:avLst/>
+          </a:prstGeom>
+          <a:noFill/>
+        </p:spPr>
+        <p:txBody>
+          <a:bodyPr wrap="square" rtlCol="0">
+            <a:spAutoFit/>
+          </a:bodyPr>
+          <a:lstStyle/>
+          <a:p>
+            <a:r>
+              <a:rPr lang="en-US" sz="2400" dirty="0">
+                <a:solidFill>
+                  <a:schemeClr val="accent4">
+                    <a:lumMod val="75000"/>
+                  </a:schemeClr>
+                </a:solidFill>
+              </a:rPr>
+              <a:t>declaration of state variables or variables; this declares an array x[0], x[1], …, x[N-1] of Val’s</a:t>
+            </a:r>
+          </a:p>
+        </p:txBody>
+      </p:sp>
+      <p:sp>
+        <p:nvSpPr>
+          <p:cNvPr id="6" name="TextBox 5">
+            <a:extLst>
+              <a:ext uri="{FF2B5EF4-FFF2-40B4-BE49-F238E27FC236}">
+                <a16:creationId xmlns:a16="http://schemas.microsoft.com/office/drawing/2014/main" id="{7AFB572B-19F5-DC47-8D01-9D90083FF74A}"/>
+              </a:ext>
+            </a:extLst>
+          </p:cNvPr>
+          <p:cNvSpPr txBox="1"/>
+          <p:nvPr/>
+        </p:nvSpPr>
+        <p:spPr>
+          <a:xfrm>
+            <a:off x="5544742" y="6155266"/>
+            <a:ext cx="6647258" cy="461665"/>
+          </a:xfrm>
+          <a:prstGeom prst="rect">
+            <a:avLst/>
+          </a:prstGeom>
+          <a:noFill/>
+        </p:spPr>
+        <p:txBody>
+          <a:bodyPr wrap="square" rtlCol="0">
+            <a:spAutoFit/>
+          </a:bodyPr>
+          <a:lstStyle/>
+          <a:p>
+            <a:r>
+              <a:rPr lang="en-US" sz="2400" dirty="0">
+                <a:solidFill>
+                  <a:schemeClr val="accent4">
+                    <a:lumMod val="75000"/>
+                  </a:schemeClr>
+                </a:solidFill>
+              </a:rPr>
+              <a:t>symbols -&gt; maps, /\ and, \/ or, ~= not equal, % mod</a:t>
+            </a:r>
+          </a:p>
+        </p:txBody>
+      </p:sp>
+    </p:spTree>
+    <p:extLst>
+      <p:ext uri="{BB962C8B-B14F-4D97-AF65-F5344CB8AC3E}">
+        <p14:creationId xmlns:p14="http://schemas.microsoft.com/office/powerpoint/2010/main" val="4059203852"/>
+      </p:ext>
+    </p:extLst>
+  </p:cSld>
+  <p:clrMapOvr>
+    <a:masterClrMapping/>
+  </p:clrMapOvr>
+</p:sld>
+</file>
+
+<file path=ppt/slides/slide17.xml><?xml version="1.0" encoding="utf-8"?>
+<p:sld xmlns:a="http://schemas.openxmlformats.org/drawingml/2006/main" xmlns:r="http://schemas.openxmlformats.org/officeDocument/2006/relationships" xmlns:p="http://schemas.openxmlformats.org/presentationml/2006/main">
+  <p:cSld>
+    <p:spTree>
+      <p:nvGrpSpPr>
+        <p:cNvPr id="1" name=""/>
+        <p:cNvGrpSpPr/>
+        <p:nvPr/>
+      </p:nvGrpSpPr>
+      <p:grpSpPr>
+        <a:xfrm>
+          <a:off x="0" y="0"/>
+          <a:ext cx="0" cy="0"/>
+          <a:chOff x="0" y="0"/>
+          <a:chExt cx="0" cy="0"/>
+        </a:xfrm>
+      </p:grpSpPr>
+      <p:sp>
+        <p:nvSpPr>
+          <p:cNvPr id="4" name="Rectangle 3">
+            <a:extLst>
+              <a:ext uri="{FF2B5EF4-FFF2-40B4-BE49-F238E27FC236}">
+                <a16:creationId xmlns:a16="http://schemas.microsoft.com/office/drawing/2014/main" id="{3629A366-D322-A64E-9916-889C92B67AC1}"/>
+              </a:ext>
+            </a:extLst>
+          </p:cNvPr>
+          <p:cNvSpPr/>
+          <p:nvPr/>
+        </p:nvSpPr>
+        <p:spPr>
+          <a:xfrm>
+            <a:off x="838200" y="3638410"/>
+            <a:ext cx="4445000" cy="3016389"/>
+          </a:xfrm>
+          <a:prstGeom prst="rect">
+            <a:avLst/>
+          </a:prstGeom>
+          <a:ln>
+            <a:noFill/>
+          </a:ln>
+        </p:spPr>
+        <p:style>
+          <a:lnRef idx="2">
+            <a:schemeClr val="accent4">
+              <a:shade val="50000"/>
+            </a:schemeClr>
+          </a:lnRef>
+          <a:fillRef idx="1">
+            <a:schemeClr val="accent4"/>
+          </a:fillRef>
+          <a:effectRef idx="0">
+            <a:schemeClr val="accent4"/>
+          </a:effectRef>
+          <a:fontRef idx="minor">
+            <a:schemeClr val="lt1"/>
+          </a:fontRef>
+        </p:style>
+        <p:txBody>
+          <a:bodyPr rtlCol="0" anchor="ctr"/>
+          <a:lstStyle/>
+          <a:p>
+            <a:pPr algn="ctr"/>
+            <a:endParaRPr lang="en-US"/>
+          </a:p>
+        </p:txBody>
+      </p:sp>
+      <p:sp>
+        <p:nvSpPr>
+          <p:cNvPr id="3" name="Title 2"/>
+          <p:cNvSpPr>
+            <a:spLocks noGrp="1"/>
+          </p:cNvSpPr>
+          <p:nvPr>
+            <p:ph type="title"/>
+          </p:nvPr>
+        </p:nvSpPr>
+        <p:spPr>
+          <a:xfrm>
+            <a:off x="838200" y="0"/>
+            <a:ext cx="10515600" cy="1325563"/>
+          </a:xfrm>
+        </p:spPr>
+        <p:txBody>
+          <a:bodyPr>
+            <a:normAutofit/>
+          </a:bodyPr>
+          <a:lstStyle/>
+          <a:p>
+            <a:r>
+              <a:rPr lang="en-US" dirty="0"/>
+              <a:t>A language for specifying automata</a:t>
+            </a:r>
+          </a:p>
+        </p:txBody>
+      </p:sp>
+      <p:sp>
+        <p:nvSpPr>
+          <p:cNvPr id="2" name="TextBox 1">
+            <a:extLst>
+              <a:ext uri="{FF2B5EF4-FFF2-40B4-BE49-F238E27FC236}">
+                <a16:creationId xmlns:a16="http://schemas.microsoft.com/office/drawing/2014/main" id="{1417CDEB-59C2-494C-B916-ABA6EEECE1D0}"/>
+              </a:ext>
+            </a:extLst>
+          </p:cNvPr>
+          <p:cNvSpPr txBox="1"/>
+          <p:nvPr/>
+        </p:nvSpPr>
+        <p:spPr>
+          <a:xfrm>
+            <a:off x="926544" y="1022489"/>
+            <a:ext cx="6352701" cy="5632311"/>
+          </a:xfrm>
+          <a:prstGeom prst="rect">
+            <a:avLst/>
+          </a:prstGeom>
+          <a:noFill/>
+        </p:spPr>
+        <p:txBody>
+          <a:bodyPr wrap="none" rtlCol="0">
+            <a:spAutoFit/>
+          </a:bodyPr>
+          <a:lstStyle/>
+          <a:p>
+            <a:r>
+              <a:rPr lang="en-US" sz="2400" b="1" dirty="0"/>
+              <a:t>automaton</a:t>
+            </a:r>
+            <a:r>
+              <a:rPr lang="en-US" sz="2400" dirty="0"/>
+              <a:t> </a:t>
+            </a:r>
+            <a:r>
+              <a:rPr lang="en-US" sz="2400" dirty="0" err="1">
+                <a:solidFill>
+                  <a:srgbClr val="0119FF"/>
+                </a:solidFill>
+              </a:rPr>
+              <a:t>DijkstraTR</a:t>
+            </a:r>
+            <a:r>
+              <a:rPr lang="en-US" sz="2400" dirty="0"/>
+              <a:t>(</a:t>
+            </a:r>
+            <a:r>
+              <a:rPr lang="en-US" sz="2400" dirty="0" err="1"/>
+              <a:t>N:</a:t>
+            </a:r>
+            <a:r>
+              <a:rPr lang="en-US" sz="2400" dirty="0" err="1">
+                <a:solidFill>
+                  <a:srgbClr val="00B050"/>
+                </a:solidFill>
+              </a:rPr>
+              <a:t>Nat</a:t>
+            </a:r>
+            <a:r>
+              <a:rPr lang="en-US" sz="2400" dirty="0"/>
+              <a:t>, </a:t>
+            </a:r>
+            <a:r>
+              <a:rPr lang="en-US" sz="2400" dirty="0" err="1"/>
+              <a:t>K:</a:t>
+            </a:r>
+            <a:r>
+              <a:rPr lang="en-US" sz="2400" dirty="0" err="1">
+                <a:solidFill>
+                  <a:srgbClr val="00B050"/>
+                </a:solidFill>
+              </a:rPr>
+              <a:t>Nat</a:t>
+            </a:r>
+            <a:r>
+              <a:rPr lang="en-US" sz="2400" dirty="0"/>
+              <a:t>), </a:t>
+            </a:r>
+            <a:r>
+              <a:rPr lang="en-US" sz="2400" b="1" dirty="0"/>
+              <a:t>where</a:t>
+            </a:r>
+            <a:r>
+              <a:rPr lang="en-US" sz="2400" dirty="0"/>
+              <a:t> K &gt; N</a:t>
+            </a:r>
+          </a:p>
+          <a:p>
+            <a:r>
+              <a:rPr lang="en-US" sz="2400" dirty="0"/>
+              <a:t>  </a:t>
+            </a:r>
+            <a:r>
+              <a:rPr lang="en-US" sz="2400" b="1" dirty="0"/>
+              <a:t>type</a:t>
+            </a:r>
+            <a:r>
+              <a:rPr lang="en-US" sz="2400" dirty="0"/>
+              <a:t> </a:t>
+            </a:r>
+            <a:r>
+              <a:rPr lang="en-US" sz="2400" dirty="0">
+                <a:solidFill>
+                  <a:srgbClr val="0119FF"/>
+                </a:solidFill>
+              </a:rPr>
+              <a:t>ID</a:t>
+            </a:r>
+            <a:r>
+              <a:rPr lang="en-US" sz="2400" dirty="0"/>
+              <a:t>: </a:t>
+            </a:r>
+            <a:r>
+              <a:rPr lang="en-US" sz="2400" b="1" dirty="0"/>
+              <a:t>enumeration</a:t>
+            </a:r>
+            <a:r>
+              <a:rPr lang="en-US" sz="2400" dirty="0"/>
+              <a:t> [0,...,N-1]</a:t>
+            </a:r>
+          </a:p>
+          <a:p>
+            <a:r>
+              <a:rPr lang="en-US" sz="2400" dirty="0"/>
+              <a:t>  </a:t>
+            </a:r>
+            <a:r>
+              <a:rPr lang="en-US" sz="2400" b="1" dirty="0"/>
+              <a:t>type</a:t>
+            </a:r>
+            <a:r>
+              <a:rPr lang="en-US" sz="2400" dirty="0"/>
+              <a:t> </a:t>
+            </a:r>
+            <a:r>
+              <a:rPr lang="en-US" sz="2400" dirty="0">
+                <a:solidFill>
+                  <a:srgbClr val="0119FF"/>
+                </a:solidFill>
+              </a:rPr>
+              <a:t>Val</a:t>
+            </a:r>
+            <a:r>
+              <a:rPr lang="en-US" sz="2400" dirty="0"/>
+              <a:t>: </a:t>
+            </a:r>
+            <a:r>
+              <a:rPr lang="en-US" sz="2400" b="1" dirty="0"/>
+              <a:t>enumeration</a:t>
+            </a:r>
+            <a:r>
+              <a:rPr lang="en-US" sz="2400" dirty="0"/>
+              <a:t> [0,...,K]</a:t>
+            </a:r>
+          </a:p>
+          <a:p>
+            <a:r>
+              <a:rPr lang="en-US" sz="2400" dirty="0"/>
+              <a:t>  </a:t>
+            </a:r>
+            <a:r>
+              <a:rPr lang="en-US" sz="2400" b="1" dirty="0"/>
+              <a:t>actions</a:t>
+            </a:r>
+          </a:p>
+          <a:p>
+            <a:r>
+              <a:rPr lang="en-US" sz="2400" dirty="0"/>
+              <a:t>      </a:t>
+            </a:r>
+            <a:r>
+              <a:rPr lang="en-US" sz="2400" dirty="0">
+                <a:solidFill>
+                  <a:srgbClr val="0119FF"/>
+                </a:solidFill>
+              </a:rPr>
+              <a:t>update</a:t>
+            </a:r>
+            <a:r>
+              <a:rPr lang="en-US" sz="2400" dirty="0"/>
+              <a:t>(</a:t>
+            </a:r>
+            <a:r>
+              <a:rPr lang="en-US" sz="2400" dirty="0" err="1"/>
+              <a:t>i:ID</a:t>
+            </a:r>
+            <a:r>
+              <a:rPr lang="en-US" sz="2400" dirty="0"/>
+              <a:t>)</a:t>
+            </a:r>
+          </a:p>
+          <a:p>
+            <a:r>
+              <a:rPr lang="en-US" sz="2400" dirty="0"/>
+              <a:t>  </a:t>
+            </a:r>
+            <a:r>
+              <a:rPr lang="en-US" sz="2400" b="1" dirty="0"/>
+              <a:t>variables</a:t>
+            </a:r>
+          </a:p>
+          <a:p>
+            <a:r>
+              <a:rPr lang="en-US" sz="2400" dirty="0"/>
+              <a:t>      </a:t>
+            </a:r>
+            <a:r>
+              <a:rPr lang="en-US" sz="2400" dirty="0">
+                <a:solidFill>
+                  <a:srgbClr val="0119FF"/>
+                </a:solidFill>
+              </a:rPr>
+              <a:t>x</a:t>
+            </a:r>
+            <a:r>
+              <a:rPr lang="en-US" sz="2400" dirty="0"/>
+              <a:t>:[ID -&gt; Val]</a:t>
+            </a:r>
+          </a:p>
+          <a:p>
+            <a:r>
+              <a:rPr lang="en-US" sz="2400" dirty="0"/>
+              <a:t>   </a:t>
+            </a:r>
+            <a:r>
+              <a:rPr lang="en-US" sz="2400" b="1" dirty="0"/>
+              <a:t>transitions</a:t>
+            </a:r>
+          </a:p>
+          <a:p>
+            <a:r>
+              <a:rPr lang="en-US" sz="2400" dirty="0"/>
+              <a:t>      </a:t>
+            </a:r>
+            <a:r>
+              <a:rPr lang="en-US" sz="2400" dirty="0">
+                <a:solidFill>
+                  <a:srgbClr val="0119FF"/>
+                </a:solidFill>
+              </a:rPr>
+              <a:t>update</a:t>
+            </a:r>
+            <a:r>
+              <a:rPr lang="en-US" sz="2400" dirty="0"/>
+              <a:t>(</a:t>
+            </a:r>
+            <a:r>
+              <a:rPr lang="en-US" sz="2400" dirty="0" err="1"/>
+              <a:t>i:ID</a:t>
+            </a:r>
+            <a:r>
+              <a:rPr lang="en-US" sz="2400" dirty="0"/>
+              <a:t>) </a:t>
+            </a:r>
+          </a:p>
+          <a:p>
+            <a:r>
+              <a:rPr lang="en-US" sz="2400" b="1" dirty="0"/>
+              <a:t>        pre</a:t>
+            </a:r>
+            <a:r>
+              <a:rPr lang="en-US" sz="2400" dirty="0"/>
+              <a:t> </a:t>
+            </a:r>
+            <a:r>
+              <a:rPr lang="en-US" sz="2400" dirty="0" err="1"/>
+              <a:t>i</a:t>
+            </a:r>
+            <a:r>
+              <a:rPr lang="en-US" sz="2400" dirty="0"/>
+              <a:t> = 0 /\ x[</a:t>
+            </a:r>
+            <a:r>
+              <a:rPr lang="en-US" sz="2400" dirty="0" err="1"/>
+              <a:t>i</a:t>
+            </a:r>
+            <a:r>
+              <a:rPr lang="en-US" sz="2400" dirty="0"/>
+              <a:t>] = x[N-1]</a:t>
+            </a:r>
+          </a:p>
+          <a:p>
+            <a:r>
+              <a:rPr lang="en-US" sz="2400" dirty="0"/>
+              <a:t>        </a:t>
+            </a:r>
+            <a:r>
+              <a:rPr lang="en-US" sz="2400" b="1" dirty="0"/>
+              <a:t>eff</a:t>
+            </a:r>
+            <a:r>
+              <a:rPr lang="en-US" sz="2400" dirty="0"/>
+              <a:t> x[</a:t>
+            </a:r>
+            <a:r>
+              <a:rPr lang="en-US" sz="2400" dirty="0" err="1"/>
+              <a:t>i</a:t>
+            </a:r>
+            <a:r>
+              <a:rPr lang="en-US" sz="2400" dirty="0"/>
+              <a:t>] := (x[</a:t>
+            </a:r>
+            <a:r>
+              <a:rPr lang="en-US" sz="2400" dirty="0" err="1"/>
+              <a:t>i</a:t>
+            </a:r>
+            <a:r>
+              <a:rPr lang="en-US" sz="2400" dirty="0"/>
+              <a:t>] + 1) %  K</a:t>
+            </a:r>
+          </a:p>
+          <a:p>
+            <a:r>
+              <a:rPr lang="en-US" sz="2400" dirty="0"/>
+              <a:t>   </a:t>
+            </a:r>
+          </a:p>
+          <a:p>
+            <a:r>
+              <a:rPr lang="en-US" sz="2400" dirty="0"/>
+              <a:t>       </a:t>
+            </a:r>
+            <a:r>
+              <a:rPr lang="en-US" sz="2400" dirty="0">
+                <a:solidFill>
+                  <a:srgbClr val="0119FF"/>
+                </a:solidFill>
+              </a:rPr>
+              <a:t>update</a:t>
+            </a:r>
+            <a:r>
+              <a:rPr lang="en-US" sz="2400" dirty="0"/>
+              <a:t>(</a:t>
+            </a:r>
+            <a:r>
+              <a:rPr lang="en-US" sz="2400" dirty="0" err="1"/>
+              <a:t>i:ID</a:t>
+            </a:r>
+            <a:r>
+              <a:rPr lang="en-US" sz="2400" dirty="0"/>
+              <a:t>)</a:t>
+            </a:r>
+          </a:p>
+          <a:p>
+            <a:r>
+              <a:rPr lang="en-US" sz="2400" dirty="0"/>
+              <a:t>         </a:t>
+            </a:r>
+            <a:r>
+              <a:rPr lang="en-US" sz="2400" b="1" dirty="0"/>
+              <a:t>pre</a:t>
+            </a:r>
+            <a:r>
+              <a:rPr lang="en-US" sz="2400" dirty="0"/>
+              <a:t> </a:t>
+            </a:r>
+            <a:r>
+              <a:rPr lang="en-US" sz="2400" dirty="0" err="1"/>
+              <a:t>i</a:t>
+            </a:r>
+            <a:r>
+              <a:rPr lang="en-US" sz="2400" dirty="0"/>
+              <a:t> &gt;0  /\ x[</a:t>
+            </a:r>
+            <a:r>
+              <a:rPr lang="en-US" sz="2400" dirty="0" err="1"/>
+              <a:t>i</a:t>
+            </a:r>
+            <a:r>
+              <a:rPr lang="en-US" sz="2400" dirty="0"/>
+              <a:t>] ~= x[i-1]</a:t>
+            </a:r>
+          </a:p>
+          <a:p>
+            <a:r>
+              <a:rPr lang="en-US" sz="2400" dirty="0"/>
+              <a:t>         </a:t>
+            </a:r>
+            <a:r>
+              <a:rPr lang="en-US" sz="2400" b="1" dirty="0"/>
+              <a:t>eff</a:t>
+            </a:r>
+            <a:r>
+              <a:rPr lang="en-US" sz="2400" dirty="0"/>
+              <a:t> x[</a:t>
+            </a:r>
+            <a:r>
+              <a:rPr lang="en-US" sz="2400" dirty="0" err="1"/>
+              <a:t>i</a:t>
+            </a:r>
+            <a:r>
+              <a:rPr lang="en-US" sz="2400" dirty="0"/>
+              <a:t>] := x[i-1]</a:t>
+            </a:r>
+          </a:p>
+        </p:txBody>
+      </p:sp>
+      <p:sp>
+        <p:nvSpPr>
+          <p:cNvPr id="5" name="TextBox 4">
+            <a:extLst>
+              <a:ext uri="{FF2B5EF4-FFF2-40B4-BE49-F238E27FC236}">
+                <a16:creationId xmlns:a16="http://schemas.microsoft.com/office/drawing/2014/main" id="{5DC2086B-C1E3-3047-9A02-47CD138A1299}"/>
+              </a:ext>
+            </a:extLst>
+          </p:cNvPr>
+          <p:cNvSpPr txBox="1"/>
+          <p:nvPr/>
+        </p:nvSpPr>
+        <p:spPr>
+          <a:xfrm>
+            <a:off x="8021373" y="3429000"/>
+            <a:ext cx="3645694" cy="2308324"/>
+          </a:xfrm>
+          <a:prstGeom prst="rect">
+            <a:avLst/>
+          </a:prstGeom>
+          <a:noFill/>
+        </p:spPr>
+        <p:txBody>
+          <a:bodyPr wrap="square" rtlCol="0">
+            <a:spAutoFit/>
+          </a:bodyPr>
+          <a:lstStyle/>
+          <a:p>
+            <a:r>
+              <a:rPr lang="en-US" sz="2400" dirty="0">
+                <a:solidFill>
+                  <a:schemeClr val="accent4">
+                    <a:lumMod val="75000"/>
+                  </a:schemeClr>
+                </a:solidFill>
+              </a:rPr>
+              <a:t>declaration of transitions: for each action this defines when the action can occur (pre) and how the state is updated when the action does occur (eff)</a:t>
+            </a:r>
+          </a:p>
+        </p:txBody>
+      </p:sp>
+      <p:sp>
+        <p:nvSpPr>
+          <p:cNvPr id="6" name="TextBox 5">
+            <a:extLst>
+              <a:ext uri="{FF2B5EF4-FFF2-40B4-BE49-F238E27FC236}">
+                <a16:creationId xmlns:a16="http://schemas.microsoft.com/office/drawing/2014/main" id="{6DE56BD4-9C72-9C4D-AD4D-0227A7ECF5F0}"/>
+              </a:ext>
+            </a:extLst>
+          </p:cNvPr>
+          <p:cNvSpPr txBox="1"/>
+          <p:nvPr/>
+        </p:nvSpPr>
+        <p:spPr>
+          <a:xfrm>
+            <a:off x="5544742" y="6155266"/>
+            <a:ext cx="6647258" cy="461665"/>
+          </a:xfrm>
+          <a:prstGeom prst="rect">
+            <a:avLst/>
+          </a:prstGeom>
+          <a:noFill/>
+        </p:spPr>
+        <p:txBody>
+          <a:bodyPr wrap="square" rtlCol="0">
+            <a:spAutoFit/>
+          </a:bodyPr>
+          <a:lstStyle/>
+          <a:p>
+            <a:r>
+              <a:rPr lang="en-US" sz="2400" dirty="0">
+                <a:solidFill>
+                  <a:schemeClr val="accent4">
+                    <a:lumMod val="75000"/>
+                  </a:schemeClr>
+                </a:solidFill>
+              </a:rPr>
+              <a:t>symbols -&gt; maps, /\ and, \/ or, ~= not equal, % mod</a:t>
+            </a:r>
+          </a:p>
+        </p:txBody>
+      </p:sp>
+    </p:spTree>
+    <p:extLst>
+      <p:ext uri="{BB962C8B-B14F-4D97-AF65-F5344CB8AC3E}">
+        <p14:creationId xmlns:p14="http://schemas.microsoft.com/office/powerpoint/2010/main" val="579389209"/>
+      </p:ext>
+    </p:extLst>
+  </p:cSld>
+  <p:clrMapOvr>
+    <a:masterClrMapping/>
+  </p:clrMapOvr>
+</p:sld>
+</file>
+
+<file path=ppt/slides/slide18.xml><?xml version="1.0" encoding="utf-8"?>
+<p:sld xmlns:a="http://schemas.openxmlformats.org/drawingml/2006/main" xmlns:r="http://schemas.openxmlformats.org/officeDocument/2006/relationships" xmlns:p="http://schemas.openxmlformats.org/presentationml/2006/main">
+  <p:cSld>
+    <p:spTree>
+      <p:nvGrpSpPr>
+        <p:cNvPr id="1" name=""/>
+        <p:cNvGrpSpPr/>
+        <p:nvPr/>
+      </p:nvGrpSpPr>
+      <p:grpSpPr>
+        <a:xfrm>
+          <a:off x="0" y="0"/>
+          <a:ext cx="0" cy="0"/>
+          <a:chOff x="0" y="0"/>
+          <a:chExt cx="0" cy="0"/>
+        </a:xfrm>
+      </p:grpSpPr>
+      <p:sp>
+        <p:nvSpPr>
+          <p:cNvPr id="2" name="Title 1">
+            <a:extLst>
+              <a:ext uri="{FF2B5EF4-FFF2-40B4-BE49-F238E27FC236}">
+                <a16:creationId xmlns:a16="http://schemas.microsoft.com/office/drawing/2014/main" id="{6C511BB6-A486-375B-F43E-0D3D3860A850}"/>
+              </a:ext>
+            </a:extLst>
+          </p:cNvPr>
+          <p:cNvSpPr>
+            <a:spLocks noGrp="1"/>
+          </p:cNvSpPr>
+          <p:nvPr>
+            <p:ph type="title"/>
+          </p:nvPr>
+        </p:nvSpPr>
+        <p:spPr/>
+        <p:txBody>
+          <a:bodyPr/>
+          <a:lstStyle/>
+          <a:p>
+            <a:endParaRPr lang="en-US"/>
+          </a:p>
+        </p:txBody>
+      </p:sp>
+      <p:pic>
+        <p:nvPicPr>
+          <p:cNvPr id="5" name="Picture 4">
+            <a:extLst>
+              <a:ext uri="{FF2B5EF4-FFF2-40B4-BE49-F238E27FC236}">
+                <a16:creationId xmlns:a16="http://schemas.microsoft.com/office/drawing/2014/main" id="{1CB30172-78C2-41FC-0390-4C8A6B546908}"/>
+              </a:ext>
+            </a:extLst>
+          </p:cNvPr>
+          <p:cNvPicPr>
+            <a:picLocks noChangeAspect="1"/>
+          </p:cNvPicPr>
+          <p:nvPr/>
+        </p:nvPicPr>
+        <p:blipFill>
+          <a:blip r:embed="rId2"/>
+          <a:stretch>
+            <a:fillRect/>
+          </a:stretch>
+        </p:blipFill>
+        <p:spPr>
+          <a:xfrm>
+            <a:off x="0" y="2026943"/>
+            <a:ext cx="6728604" cy="3323686"/>
+          </a:xfrm>
+          <a:prstGeom prst="rect">
+            <a:avLst/>
+          </a:prstGeom>
+        </p:spPr>
+      </p:pic>
+    </p:spTree>
+    <p:extLst>
+      <p:ext uri="{BB962C8B-B14F-4D97-AF65-F5344CB8AC3E}">
+        <p14:creationId xmlns:p14="http://schemas.microsoft.com/office/powerpoint/2010/main" val="3814151661"/>
+      </p:ext>
+    </p:extLst>
+  </p:cSld>
+  <p:clrMapOvr>
+    <a:masterClrMapping/>
+  </p:clrMapOvr>
+</p:sld>
+</file>
+
 <file path=ppt/slides/slide19.xml><?xml version="1.0" encoding="utf-8"?>
 <p:sld xmlns:a="http://schemas.openxmlformats.org/drawingml/2006/main" xmlns:r="http://schemas.openxmlformats.org/officeDocument/2006/relationships" xmlns:p="http://schemas.openxmlformats.org/presentationml/2006/main">
   <p:cSld>
@@ -16783,6 +16784,95 @@
       </p:grpSpPr>
       <p:sp>
         <p:nvSpPr>
+          <p:cNvPr id="2" name="Title 1">
+            <a:extLst>
+              <a:ext uri="{FF2B5EF4-FFF2-40B4-BE49-F238E27FC236}">
+                <a16:creationId xmlns:a16="http://schemas.microsoft.com/office/drawing/2014/main" id="{352D9A75-FB4D-6144-10CB-969A022E1052}"/>
+              </a:ext>
+            </a:extLst>
+          </p:cNvPr>
+          <p:cNvSpPr>
+            <a:spLocks noGrp="1"/>
+          </p:cNvSpPr>
+          <p:nvPr>
+            <p:ph type="title"/>
+          </p:nvPr>
+        </p:nvSpPr>
+        <p:spPr/>
+        <p:txBody>
+          <a:bodyPr/>
+          <a:lstStyle/>
+          <a:p>
+            <a:r>
+              <a:rPr lang="en-US" dirty="0" err="1"/>
+              <a:t>Collatz</a:t>
+            </a:r>
+            <a:endParaRPr lang="en-US" dirty="0"/>
+          </a:p>
+        </p:txBody>
+      </p:sp>
+      <p:pic>
+        <p:nvPicPr>
+          <p:cNvPr id="4" name="Picture 3">
+            <a:extLst>
+              <a:ext uri="{FF2B5EF4-FFF2-40B4-BE49-F238E27FC236}">
+                <a16:creationId xmlns:a16="http://schemas.microsoft.com/office/drawing/2014/main" id="{33296AFD-92BC-0AC9-5242-EB26132CB126}"/>
+              </a:ext>
+            </a:extLst>
+          </p:cNvPr>
+          <p:cNvPicPr>
+            <a:picLocks noChangeAspect="1"/>
+          </p:cNvPicPr>
+          <p:nvPr/>
+        </p:nvPicPr>
+        <p:blipFill>
+          <a:blip r:embed="rId2"/>
+          <a:stretch>
+            <a:fillRect/>
+          </a:stretch>
+        </p:blipFill>
+        <p:spPr>
+          <a:xfrm>
+            <a:off x="4038600" y="2702042"/>
+            <a:ext cx="7772400" cy="3790833"/>
+          </a:xfrm>
+          <a:prstGeom prst="rect">
+            <a:avLst/>
+          </a:prstGeom>
+        </p:spPr>
+      </p:pic>
+    </p:spTree>
+    <p:extLst>
+      <p:ext uri="{BB962C8B-B14F-4D97-AF65-F5344CB8AC3E}">
+        <p14:creationId xmlns:p14="http://schemas.microsoft.com/office/powerpoint/2010/main" val="3189619594"/>
+      </p:ext>
+    </p:extLst>
+  </p:cSld>
+  <p:clrMapOvr>
+    <a:masterClrMapping/>
+  </p:clrMapOvr>
+</p:sld>
+</file>
+
+<file path=ppt/slides/slide24.xml><?xml version="1.0" encoding="utf-8"?>
+<p:sld xmlns:a="http://schemas.openxmlformats.org/drawingml/2006/main" xmlns:r="http://schemas.openxmlformats.org/officeDocument/2006/relationships" xmlns:p="http://schemas.openxmlformats.org/presentationml/2006/main">
+  <p:cSld>
+    <p:spTree>
+      <p:nvGrpSpPr>
+        <p:cNvPr id="1" name=""/>
+        <p:cNvGrpSpPr/>
+        <p:nvPr/>
+      </p:nvGrpSpPr>
+      <p:grpSpPr>
+        <a:xfrm>
+          <a:off x="0" y="0"/>
+          <a:ext cx="0" cy="0"/>
+          <a:chOff x="0" y="0"/>
+          <a:chExt cx="0" cy="0"/>
+        </a:xfrm>
+      </p:grpSpPr>
+      <p:sp>
+        <p:nvSpPr>
           <p:cNvPr id="2" name="Title 1"/>
           <p:cNvSpPr>
             <a:spLocks noGrp="1"/>
@@ -17340,7 +17430,7 @@
 </p:sld>
 </file>
 
-<file path=ppt/slides/slide24.xml><?xml version="1.0" encoding="utf-8"?>
+<file path=ppt/slides/slide25.xml><?xml version="1.0" encoding="utf-8"?>
 <p:sld xmlns:a="http://schemas.openxmlformats.org/drawingml/2006/main" xmlns:r="http://schemas.openxmlformats.org/officeDocument/2006/relationships" xmlns:p="http://schemas.openxmlformats.org/presentationml/2006/main">
   <p:cSld>
     <p:spTree>
@@ -17774,7 +17864,7 @@
 </p:sld>
 </file>
 
-<file path=ppt/slides/slide25.xml><?xml version="1.0" encoding="utf-8"?>
+<file path=ppt/slides/slide26.xml><?xml version="1.0" encoding="utf-8"?>
 <p:sld xmlns:a="http://schemas.openxmlformats.org/drawingml/2006/main" xmlns:r="http://schemas.openxmlformats.org/officeDocument/2006/relationships" xmlns:p="http://schemas.openxmlformats.org/presentationml/2006/main">
   <p:cSld>
     <p:spTree>
@@ -18636,7 +18726,7 @@
 </p:sld>
 </file>
 
-<file path=ppt/slides/slide26.xml><?xml version="1.0" encoding="utf-8"?>
+<file path=ppt/slides/slide27.xml><?xml version="1.0" encoding="utf-8"?>
 <p:sld xmlns:a="http://schemas.openxmlformats.org/drawingml/2006/main" xmlns:r="http://schemas.openxmlformats.org/officeDocument/2006/relationships" xmlns:p="http://schemas.openxmlformats.org/presentationml/2006/main">
   <p:cSld>
     <p:spTree>
@@ -19518,7 +19608,7 @@
 </p:sld>
 </file>
 
-<file path=ppt/slides/slide27.xml><?xml version="1.0" encoding="utf-8"?>
+<file path=ppt/slides/slide28.xml><?xml version="1.0" encoding="utf-8"?>
 <p:sld xmlns:a="http://schemas.openxmlformats.org/drawingml/2006/main" xmlns:r="http://schemas.openxmlformats.org/officeDocument/2006/relationships" xmlns:p="http://schemas.openxmlformats.org/presentationml/2006/main">
   <p:cSld>
     <p:spTree>
@@ -20304,7 +20394,7 @@
 </p:sld>
 </file>
 
-<file path=ppt/slides/slide28.xml><?xml version="1.0" encoding="utf-8"?>
+<file path=ppt/slides/slide29.xml><?xml version="1.0" encoding="utf-8"?>
 <p:sld xmlns:a="http://schemas.openxmlformats.org/drawingml/2006/main" xmlns:r="http://schemas.openxmlformats.org/officeDocument/2006/relationships" xmlns:p="http://schemas.openxmlformats.org/presentationml/2006/main">
   <p:cSld>
     <p:spTree>
@@ -22040,7 +22130,285 @@
 </p:sld>
 </file>
 
-<file path=ppt/slides/slide29.xml><?xml version="1.0" encoding="utf-8"?>
+<file path=ppt/slides/slide3.xml><?xml version="1.0" encoding="utf-8"?>
+<p:sld xmlns:a="http://schemas.openxmlformats.org/drawingml/2006/main" xmlns:r="http://schemas.openxmlformats.org/officeDocument/2006/relationships" xmlns:p="http://schemas.openxmlformats.org/presentationml/2006/main">
+  <p:cSld>
+    <p:spTree>
+      <p:nvGrpSpPr>
+        <p:cNvPr id="1" name=""/>
+        <p:cNvGrpSpPr/>
+        <p:nvPr/>
+      </p:nvGrpSpPr>
+      <p:grpSpPr>
+        <a:xfrm>
+          <a:off x="0" y="0"/>
+          <a:ext cx="0" cy="0"/>
+          <a:chOff x="0" y="0"/>
+          <a:chExt cx="0" cy="0"/>
+        </a:xfrm>
+      </p:grpSpPr>
+      <p:sp>
+        <p:nvSpPr>
+          <p:cNvPr id="2" name="Title 1">
+            <a:extLst>
+              <a:ext uri="{FF2B5EF4-FFF2-40B4-BE49-F238E27FC236}">
+                <a16:creationId xmlns:a16="http://schemas.microsoft.com/office/drawing/2014/main" id="{89A6E0D0-E74E-2B45-B640-A1E3517EF8C2}"/>
+              </a:ext>
+            </a:extLst>
+          </p:cNvPr>
+          <p:cNvSpPr>
+            <a:spLocks noGrp="1"/>
+          </p:cNvSpPr>
+          <p:nvPr>
+            <p:ph type="title"/>
+          </p:nvPr>
+        </p:nvSpPr>
+        <p:spPr/>
+        <p:txBody>
+          <a:bodyPr/>
+          <a:lstStyle/>
+          <a:p>
+            <a:r>
+              <a:rPr lang="en-US" dirty="0"/>
+              <a:t>Automata or discrete transition systems</a:t>
+            </a:r>
+          </a:p>
+        </p:txBody>
+      </p:sp>
+      <p:sp>
+        <p:nvSpPr>
+          <p:cNvPr id="3" name="Content Placeholder 2">
+            <a:extLst>
+              <a:ext uri="{FF2B5EF4-FFF2-40B4-BE49-F238E27FC236}">
+                <a16:creationId xmlns:a16="http://schemas.microsoft.com/office/drawing/2014/main" id="{F147AA83-84E3-0342-8A94-AC07EADC2024}"/>
+              </a:ext>
+            </a:extLst>
+          </p:cNvPr>
+          <p:cNvSpPr>
+            <a:spLocks noGrp="1"/>
+          </p:cNvSpPr>
+          <p:nvPr>
+            <p:ph idx="1"/>
+          </p:nvPr>
+        </p:nvSpPr>
+        <p:spPr>
+          <a:xfrm>
+            <a:off x="838200" y="1560576"/>
+            <a:ext cx="10515600" cy="4932299"/>
+          </a:xfrm>
+        </p:spPr>
+        <p:txBody>
+          <a:bodyPr>
+            <a:normAutofit/>
+          </a:bodyPr>
+          <a:lstStyle/>
+          <a:p>
+            <a:pPr>
+              <a:lnSpc>
+                <a:spcPct val="110000"/>
+              </a:lnSpc>
+            </a:pPr>
+            <a:r>
+              <a:rPr lang="en-US" b="0" dirty="0">
+                <a:latin typeface="+mj-lt"/>
+                <a:ea typeface="Cambria Math" panose="02040503050406030204" pitchFamily="18" charset="0"/>
+              </a:rPr>
+              <a:t>The “state” of a system captures </a:t>
+            </a:r>
+            <a:r>
+              <a:rPr lang="en-US" dirty="0">
+                <a:latin typeface="+mj-lt"/>
+                <a:ea typeface="Cambria Math" panose="02040503050406030204" pitchFamily="18" charset="0"/>
+              </a:rPr>
+              <a:t>all the information needed to predict the system’s future behavior</a:t>
+            </a:r>
+          </a:p>
+          <a:p>
+            <a:pPr>
+              <a:lnSpc>
+                <a:spcPct val="110000"/>
+              </a:lnSpc>
+            </a:pPr>
+            <a:r>
+              <a:rPr lang="en-US" dirty="0">
+                <a:latin typeface="+mj-lt"/>
+                <a:ea typeface="Cambria Math" panose="02040503050406030204" pitchFamily="18" charset="0"/>
+              </a:rPr>
+              <a:t>Behavior of a system is a sequence of states</a:t>
+            </a:r>
+          </a:p>
+          <a:p>
+            <a:pPr>
+              <a:lnSpc>
+                <a:spcPct val="110000"/>
+              </a:lnSpc>
+            </a:pPr>
+            <a:r>
+              <a:rPr lang="en-US" i="1" dirty="0">
+                <a:latin typeface="+mj-lt"/>
+                <a:ea typeface="Cambria Math" panose="02040503050406030204" pitchFamily="18" charset="0"/>
+              </a:rPr>
+              <a:t>Our ultimate goal: write programs that prove properties about all behaviors of a system</a:t>
+            </a:r>
+          </a:p>
+          <a:p>
+            <a:pPr>
+              <a:lnSpc>
+                <a:spcPct val="110000"/>
+              </a:lnSpc>
+            </a:pPr>
+            <a:r>
+              <a:rPr lang="en-US" dirty="0">
+                <a:latin typeface="+mj-lt"/>
+                <a:ea typeface="Cambria Math" panose="02040503050406030204" pitchFamily="18" charset="0"/>
+              </a:rPr>
+              <a:t>“Transitions” capture how the state can change</a:t>
+            </a:r>
+          </a:p>
+        </p:txBody>
+      </p:sp>
+    </p:spTree>
+    <p:extLst>
+      <p:ext uri="{BB962C8B-B14F-4D97-AF65-F5344CB8AC3E}">
+        <p14:creationId xmlns:p14="http://schemas.microsoft.com/office/powerpoint/2010/main" val="3978938520"/>
+      </p:ext>
+    </p:extLst>
+  </p:cSld>
+  <p:clrMapOvr>
+    <a:masterClrMapping/>
+  </p:clrMapOvr>
+  <p:timing>
+    <p:tnLst>
+      <p:par>
+        <p:cTn id="1" dur="indefinite" restart="never" nodeType="tmRoot">
+          <p:childTnLst>
+            <p:seq concurrent="1" nextAc="seek">
+              <p:cTn id="2" dur="indefinite" nodeType="mainSeq">
+                <p:childTnLst>
+                  <p:par>
+                    <p:cTn id="3" fill="hold">
+                      <p:stCondLst>
+                        <p:cond delay="indefinite"/>
+                      </p:stCondLst>
+                      <p:childTnLst>
+                        <p:par>
+                          <p:cTn id="4" fill="hold">
+                            <p:stCondLst>
+                              <p:cond delay="0"/>
+                            </p:stCondLst>
+                            <p:childTnLst>
+                              <p:par>
+                                <p:cTn id="5" presetID="1" presetClass="entr" presetSubtype="0" fill="hold" nodeType="clickEffect">
+                                  <p:stCondLst>
+                                    <p:cond delay="0"/>
+                                  </p:stCondLst>
+                                  <p:childTnLst>
+                                    <p:set>
+                                      <p:cBhvr>
+                                        <p:cTn id="6" dur="1" fill="hold">
+                                          <p:stCondLst>
+                                            <p:cond delay="0"/>
+                                          </p:stCondLst>
+                                        </p:cTn>
+                                        <p:tgtEl>
+                                          <p:spTgt spid="3">
+                                            <p:txEl>
+                                              <p:pRg st="2" end="2"/>
+                                            </p:txEl>
+                                          </p:spTgt>
+                                        </p:tgtEl>
+                                        <p:attrNameLst>
+                                          <p:attrName>style.visibility</p:attrName>
+                                        </p:attrNameLst>
+                                      </p:cBhvr>
+                                      <p:to>
+                                        <p:strVal val="visible"/>
+                                      </p:to>
+                                    </p:set>
+                                  </p:childTnLst>
+                                </p:cTn>
+                              </p:par>
+                            </p:childTnLst>
+                          </p:cTn>
+                        </p:par>
+                      </p:childTnLst>
+                    </p:cTn>
+                  </p:par>
+                  <p:par>
+                    <p:cTn id="7" fill="hold">
+                      <p:stCondLst>
+                        <p:cond delay="indefinite"/>
+                      </p:stCondLst>
+                      <p:childTnLst>
+                        <p:par>
+                          <p:cTn id="8" fill="hold">
+                            <p:stCondLst>
+                              <p:cond delay="0"/>
+                            </p:stCondLst>
+                            <p:childTnLst>
+                              <p:par>
+                                <p:cTn id="9" presetID="1" presetClass="entr" presetSubtype="0" fill="hold" nodeType="clickEffect">
+                                  <p:stCondLst>
+                                    <p:cond delay="0"/>
+                                  </p:stCondLst>
+                                  <p:childTnLst>
+                                    <p:set>
+                                      <p:cBhvr>
+                                        <p:cTn id="10" dur="1" fill="hold">
+                                          <p:stCondLst>
+                                            <p:cond delay="0"/>
+                                          </p:stCondLst>
+                                        </p:cTn>
+                                        <p:tgtEl>
+                                          <p:spTgt spid="3">
+                                            <p:txEl>
+                                              <p:pRg st="3" end="3"/>
+                                            </p:txEl>
+                                          </p:spTgt>
+                                        </p:tgtEl>
+                                        <p:attrNameLst>
+                                          <p:attrName>style.visibility</p:attrName>
+                                        </p:attrNameLst>
+                                      </p:cBhvr>
+                                      <p:to>
+                                        <p:strVal val="visible"/>
+                                      </p:to>
+                                    </p:set>
+                                  </p:childTnLst>
+                                </p:cTn>
+                              </p:par>
+                            </p:childTnLst>
+                          </p:cTn>
+                        </p:par>
+                      </p:childTnLst>
+                    </p:cTn>
+                  </p:par>
+                </p:childTnLst>
+              </p:cTn>
+              <p:prevCondLst>
+                <p:cond evt="onPrev" delay="0">
+                  <p:tgtEl>
+                    <p:sldTgt/>
+                  </p:tgtEl>
+                </p:cond>
+              </p:prevCondLst>
+              <p:nextCondLst>
+                <p:cond evt="onNext" delay="0">
+                  <p:tgtEl>
+                    <p:sldTgt/>
+                  </p:tgtEl>
+                </p:cond>
+              </p:nextCondLst>
+            </p:seq>
+          </p:childTnLst>
+        </p:cTn>
+      </p:par>
+    </p:tnLst>
+  </p:timing>
+</p:sld>
+</file>
+
+<file path=ppt/slides/slide30.xml><?xml version="1.0" encoding="utf-8"?>
 <p:sld xmlns:a="http://schemas.openxmlformats.org/drawingml/2006/main" xmlns:r="http://schemas.openxmlformats.org/officeDocument/2006/relationships" xmlns:p="http://schemas.openxmlformats.org/presentationml/2006/main">
   <p:cSld>
     <p:spTree>
@@ -26024,285 +26392,7 @@
 </p:sld>
 </file>
 
-<file path=ppt/slides/slide3.xml><?xml version="1.0" encoding="utf-8"?>
-<p:sld xmlns:a="http://schemas.openxmlformats.org/drawingml/2006/main" xmlns:r="http://schemas.openxmlformats.org/officeDocument/2006/relationships" xmlns:p="http://schemas.openxmlformats.org/presentationml/2006/main">
-  <p:cSld>
-    <p:spTree>
-      <p:nvGrpSpPr>
-        <p:cNvPr id="1" name=""/>
-        <p:cNvGrpSpPr/>
-        <p:nvPr/>
-      </p:nvGrpSpPr>
-      <p:grpSpPr>
-        <a:xfrm>
-          <a:off x="0" y="0"/>
-          <a:ext cx="0" cy="0"/>
-          <a:chOff x="0" y="0"/>
-          <a:chExt cx="0" cy="0"/>
-        </a:xfrm>
-      </p:grpSpPr>
-      <p:sp>
-        <p:nvSpPr>
-          <p:cNvPr id="2" name="Title 1">
-            <a:extLst>
-              <a:ext uri="{FF2B5EF4-FFF2-40B4-BE49-F238E27FC236}">
-                <a16:creationId xmlns:a16="http://schemas.microsoft.com/office/drawing/2014/main" id="{89A6E0D0-E74E-2B45-B640-A1E3517EF8C2}"/>
-              </a:ext>
-            </a:extLst>
-          </p:cNvPr>
-          <p:cNvSpPr>
-            <a:spLocks noGrp="1"/>
-          </p:cNvSpPr>
-          <p:nvPr>
-            <p:ph type="title"/>
-          </p:nvPr>
-        </p:nvSpPr>
-        <p:spPr/>
-        <p:txBody>
-          <a:bodyPr/>
-          <a:lstStyle/>
-          <a:p>
-            <a:r>
-              <a:rPr lang="en-US" dirty="0"/>
-              <a:t>Automata or discrete transition systems</a:t>
-            </a:r>
-          </a:p>
-        </p:txBody>
-      </p:sp>
-      <p:sp>
-        <p:nvSpPr>
-          <p:cNvPr id="3" name="Content Placeholder 2">
-            <a:extLst>
-              <a:ext uri="{FF2B5EF4-FFF2-40B4-BE49-F238E27FC236}">
-                <a16:creationId xmlns:a16="http://schemas.microsoft.com/office/drawing/2014/main" id="{F147AA83-84E3-0342-8A94-AC07EADC2024}"/>
-              </a:ext>
-            </a:extLst>
-          </p:cNvPr>
-          <p:cNvSpPr>
-            <a:spLocks noGrp="1"/>
-          </p:cNvSpPr>
-          <p:nvPr>
-            <p:ph idx="1"/>
-          </p:nvPr>
-        </p:nvSpPr>
-        <p:spPr>
-          <a:xfrm>
-            <a:off x="838200" y="1560576"/>
-            <a:ext cx="10515600" cy="4932299"/>
-          </a:xfrm>
-        </p:spPr>
-        <p:txBody>
-          <a:bodyPr>
-            <a:normAutofit/>
-          </a:bodyPr>
-          <a:lstStyle/>
-          <a:p>
-            <a:pPr>
-              <a:lnSpc>
-                <a:spcPct val="110000"/>
-              </a:lnSpc>
-            </a:pPr>
-            <a:r>
-              <a:rPr lang="en-US" b="0" dirty="0">
-                <a:latin typeface="+mj-lt"/>
-                <a:ea typeface="Cambria Math" panose="02040503050406030204" pitchFamily="18" charset="0"/>
-              </a:rPr>
-              <a:t>The “state” of a system captures </a:t>
-            </a:r>
-            <a:r>
-              <a:rPr lang="en-US" dirty="0">
-                <a:latin typeface="+mj-lt"/>
-                <a:ea typeface="Cambria Math" panose="02040503050406030204" pitchFamily="18" charset="0"/>
-              </a:rPr>
-              <a:t>all the information needed to predict the system’s future behavior</a:t>
-            </a:r>
-          </a:p>
-          <a:p>
-            <a:pPr>
-              <a:lnSpc>
-                <a:spcPct val="110000"/>
-              </a:lnSpc>
-            </a:pPr>
-            <a:r>
-              <a:rPr lang="en-US" dirty="0">
-                <a:latin typeface="+mj-lt"/>
-                <a:ea typeface="Cambria Math" panose="02040503050406030204" pitchFamily="18" charset="0"/>
-              </a:rPr>
-              <a:t>Behavior of a system is a sequence of states</a:t>
-            </a:r>
-          </a:p>
-          <a:p>
-            <a:pPr>
-              <a:lnSpc>
-                <a:spcPct val="110000"/>
-              </a:lnSpc>
-            </a:pPr>
-            <a:r>
-              <a:rPr lang="en-US" i="1" dirty="0">
-                <a:latin typeface="+mj-lt"/>
-                <a:ea typeface="Cambria Math" panose="02040503050406030204" pitchFamily="18" charset="0"/>
-              </a:rPr>
-              <a:t>Our ultimate goal: write programs that prove properties about all behaviors of a system</a:t>
-            </a:r>
-          </a:p>
-          <a:p>
-            <a:pPr>
-              <a:lnSpc>
-                <a:spcPct val="110000"/>
-              </a:lnSpc>
-            </a:pPr>
-            <a:r>
-              <a:rPr lang="en-US" dirty="0">
-                <a:latin typeface="+mj-lt"/>
-                <a:ea typeface="Cambria Math" panose="02040503050406030204" pitchFamily="18" charset="0"/>
-              </a:rPr>
-              <a:t>“Transitions” capture how the state can change</a:t>
-            </a:r>
-          </a:p>
-        </p:txBody>
-      </p:sp>
-    </p:spTree>
-    <p:extLst>
-      <p:ext uri="{BB962C8B-B14F-4D97-AF65-F5344CB8AC3E}">
-        <p14:creationId xmlns:p14="http://schemas.microsoft.com/office/powerpoint/2010/main" val="3978938520"/>
-      </p:ext>
-    </p:extLst>
-  </p:cSld>
-  <p:clrMapOvr>
-    <a:masterClrMapping/>
-  </p:clrMapOvr>
-  <p:timing>
-    <p:tnLst>
-      <p:par>
-        <p:cTn id="1" dur="indefinite" restart="never" nodeType="tmRoot">
-          <p:childTnLst>
-            <p:seq concurrent="1" nextAc="seek">
-              <p:cTn id="2" dur="indefinite" nodeType="mainSeq">
-                <p:childTnLst>
-                  <p:par>
-                    <p:cTn id="3" fill="hold">
-                      <p:stCondLst>
-                        <p:cond delay="indefinite"/>
-                      </p:stCondLst>
-                      <p:childTnLst>
-                        <p:par>
-                          <p:cTn id="4" fill="hold">
-                            <p:stCondLst>
-                              <p:cond delay="0"/>
-                            </p:stCondLst>
-                            <p:childTnLst>
-                              <p:par>
-                                <p:cTn id="5" presetID="1" presetClass="entr" presetSubtype="0" fill="hold" nodeType="clickEffect">
-                                  <p:stCondLst>
-                                    <p:cond delay="0"/>
-                                  </p:stCondLst>
-                                  <p:childTnLst>
-                                    <p:set>
-                                      <p:cBhvr>
-                                        <p:cTn id="6" dur="1" fill="hold">
-                                          <p:stCondLst>
-                                            <p:cond delay="0"/>
-                                          </p:stCondLst>
-                                        </p:cTn>
-                                        <p:tgtEl>
-                                          <p:spTgt spid="3">
-                                            <p:txEl>
-                                              <p:pRg st="2" end="2"/>
-                                            </p:txEl>
-                                          </p:spTgt>
-                                        </p:tgtEl>
-                                        <p:attrNameLst>
-                                          <p:attrName>style.visibility</p:attrName>
-                                        </p:attrNameLst>
-                                      </p:cBhvr>
-                                      <p:to>
-                                        <p:strVal val="visible"/>
-                                      </p:to>
-                                    </p:set>
-                                  </p:childTnLst>
-                                </p:cTn>
-                              </p:par>
-                            </p:childTnLst>
-                          </p:cTn>
-                        </p:par>
-                      </p:childTnLst>
-                    </p:cTn>
-                  </p:par>
-                  <p:par>
-                    <p:cTn id="7" fill="hold">
-                      <p:stCondLst>
-                        <p:cond delay="indefinite"/>
-                      </p:stCondLst>
-                      <p:childTnLst>
-                        <p:par>
-                          <p:cTn id="8" fill="hold">
-                            <p:stCondLst>
-                              <p:cond delay="0"/>
-                            </p:stCondLst>
-                            <p:childTnLst>
-                              <p:par>
-                                <p:cTn id="9" presetID="1" presetClass="entr" presetSubtype="0" fill="hold" nodeType="clickEffect">
-                                  <p:stCondLst>
-                                    <p:cond delay="0"/>
-                                  </p:stCondLst>
-                                  <p:childTnLst>
-                                    <p:set>
-                                      <p:cBhvr>
-                                        <p:cTn id="10" dur="1" fill="hold">
-                                          <p:stCondLst>
-                                            <p:cond delay="0"/>
-                                          </p:stCondLst>
-                                        </p:cTn>
-                                        <p:tgtEl>
-                                          <p:spTgt spid="3">
-                                            <p:txEl>
-                                              <p:pRg st="3" end="3"/>
-                                            </p:txEl>
-                                          </p:spTgt>
-                                        </p:tgtEl>
-                                        <p:attrNameLst>
-                                          <p:attrName>style.visibility</p:attrName>
-                                        </p:attrNameLst>
-                                      </p:cBhvr>
-                                      <p:to>
-                                        <p:strVal val="visible"/>
-                                      </p:to>
-                                    </p:set>
-                                  </p:childTnLst>
-                                </p:cTn>
-                              </p:par>
-                            </p:childTnLst>
-                          </p:cTn>
-                        </p:par>
-                      </p:childTnLst>
-                    </p:cTn>
-                  </p:par>
-                </p:childTnLst>
-              </p:cTn>
-              <p:prevCondLst>
-                <p:cond evt="onPrev" delay="0">
-                  <p:tgtEl>
-                    <p:sldTgt/>
-                  </p:tgtEl>
-                </p:cond>
-              </p:prevCondLst>
-              <p:nextCondLst>
-                <p:cond evt="onNext" delay="0">
-                  <p:tgtEl>
-                    <p:sldTgt/>
-                  </p:tgtEl>
-                </p:cond>
-              </p:nextCondLst>
-            </p:seq>
-          </p:childTnLst>
-        </p:cTn>
-      </p:par>
-    </p:tnLst>
-  </p:timing>
-</p:sld>
-</file>
-
-<file path=ppt/slides/slide30.xml><?xml version="1.0" encoding="utf-8"?>
+<file path=ppt/slides/slide31.xml><?xml version="1.0" encoding="utf-8"?>
 <p:sld xmlns:a="http://schemas.openxmlformats.org/drawingml/2006/main" xmlns:r="http://schemas.openxmlformats.org/officeDocument/2006/relationships" xmlns:p="http://schemas.openxmlformats.org/presentationml/2006/main">
   <p:cSld>
     <p:spTree>
@@ -26409,7 +26499,7 @@
 </p:sld>
 </file>
 
-<file path=ppt/slides/slide31.xml><?xml version="1.0" encoding="utf-8"?>
+<file path=ppt/slides/slide32.xml><?xml version="1.0" encoding="utf-8"?>
 <p:sld xmlns:a="http://schemas.openxmlformats.org/drawingml/2006/main" xmlns:r="http://schemas.openxmlformats.org/officeDocument/2006/relationships" xmlns:p="http://schemas.openxmlformats.org/presentationml/2006/main">
   <p:cSld>
     <p:spTree>
@@ -26480,7 +26570,7 @@
 </p:sld>
 </file>
 
-<file path=ppt/slides/slide32.xml><?xml version="1.0" encoding="utf-8"?>
+<file path=ppt/slides/slide33.xml><?xml version="1.0" encoding="utf-8"?>
 <p:sld xmlns:a="http://schemas.openxmlformats.org/drawingml/2006/main" xmlns:r="http://schemas.openxmlformats.org/officeDocument/2006/relationships" xmlns:p="http://schemas.openxmlformats.org/presentationml/2006/main">
   <p:cSld>
     <p:spTree>

</xml_diff>

<commit_message>
Added tests, made post, post_action, post_all.
</commit_message>
<xml_diff>
--- a/Slides/2025/L2_ModelingComputation.pptx
+++ b/Slides/2025/L2_ModelingComputation.pptx
@@ -16887,15 +16887,14 @@
           <a:lstStyle/>
           <a:p>
             <a:r>
-              <a:rPr lang="en-US" dirty="0" err="1"/>
-              <a:t>Nondeterminism</a:t>
-            </a:r>
-            <a:endParaRPr lang="en-US" dirty="0"/>
+              <a:rPr lang="en-US" dirty="0"/>
+              <a:t>Internal and External Nondeterminism</a:t>
+            </a:r>
           </a:p>
         </p:txBody>
       </p:sp>
-      <mc:AlternateContent xmlns:mc="http://schemas.openxmlformats.org/markup-compatibility/2006" xmlns:a14="http://schemas.microsoft.com/office/drawing/2010/main">
-        <mc:Choice Requires="a14">
+      <mc:AlternateContent xmlns:mc="http://schemas.openxmlformats.org/markup-compatibility/2006">
+        <mc:Choice xmlns:a14="http://schemas.microsoft.com/office/drawing/2010/main" Requires="a14">
           <p:sp>
             <p:nvSpPr>
               <p:cNvPr id="3" name="Content Placeholder 2"/>
@@ -16906,7 +16905,12 @@
                 <p:ph idx="1"/>
               </p:nvPr>
             </p:nvSpPr>
-            <p:spPr/>
+            <p:spPr>
+              <a:xfrm>
+                <a:off x="648419" y="1547521"/>
+                <a:ext cx="10515600" cy="4351338"/>
+              </a:xfrm>
+            </p:spPr>
             <p:txBody>
               <a:bodyPr>
                 <a:noAutofit/>
@@ -16917,7 +16921,7 @@
                   <a:buNone/>
                 </a:pPr>
                 <a:r>
-                  <a:rPr lang="en-US" dirty="0">
+                  <a:rPr lang="en-US" sz="2400" dirty="0">
                     <a:latin typeface="+mj-lt"/>
                   </a:rPr>
                   <a:t>For an action </a:t>
@@ -16925,19 +16929,19 @@
                 <a14:m>
                   <m:oMath xmlns:m="http://schemas.openxmlformats.org/officeDocument/2006/math">
                     <m:r>
-                      <a:rPr lang="en-US" b="0" i="1" smtClean="0">
+                      <a:rPr lang="en-US" sz="2400" b="0" i="1" smtClean="0">
                         <a:latin typeface="Cambria Math" panose="02040503050406030204" pitchFamily="18" charset="0"/>
                       </a:rPr>
                       <m:t>𝑎</m:t>
                     </m:r>
                     <m:r>
-                      <a:rPr lang="en-US" b="0" i="1" smtClean="0">
+                      <a:rPr lang="en-US" sz="2400" b="0" i="1" smtClean="0">
                         <a:latin typeface="Cambria Math" panose="02040503050406030204" pitchFamily="18" charset="0"/>
                       </a:rPr>
                       <m:t>∈</m:t>
                     </m:r>
                     <m:r>
-                      <a:rPr lang="en-US" b="0" i="1" smtClean="0">
+                      <a:rPr lang="en-US" sz="2400" b="0" i="1" smtClean="0">
                         <a:latin typeface="Cambria Math" panose="02040503050406030204" pitchFamily="18" charset="0"/>
                       </a:rPr>
                       <m:t>𝐴</m:t>
@@ -16945,50 +16949,79 @@
                   </m:oMath>
                 </a14:m>
                 <a:r>
-                  <a:rPr lang="en-US" dirty="0">
+                  <a:rPr lang="en-US" sz="2400" dirty="0">
                     <a:latin typeface="+mj-lt"/>
                   </a:rPr>
                   <a:t>, Pre(a) is the formula defining its </a:t>
                 </a:r>
                 <a:r>
-                  <a:rPr lang="en-US" b="1" dirty="0">
+                  <a:rPr lang="en-US" sz="2400" b="1" dirty="0">
                     <a:latin typeface="+mj-lt"/>
                   </a:rPr>
                   <a:t>pre</a:t>
                 </a:r>
                 <a:r>
-                  <a:rPr lang="en-US" dirty="0">
+                  <a:rPr lang="en-US" sz="2400" dirty="0">
                     <a:latin typeface="+mj-lt"/>
                   </a:rPr>
-                  <a:t>condition, and </a:t>
-                </a:r>
-                <a:r>
-                  <a:rPr lang="en-US" dirty="0" err="1">
-                    <a:latin typeface="+mj-lt"/>
-                  </a:rPr>
-                  <a:t>Eff</a:t>
-                </a:r>
-                <a:r>
-                  <a:rPr lang="en-US" dirty="0">
-                    <a:latin typeface="+mj-lt"/>
-                  </a:rPr>
-                  <a:t>(a) is the relation defining the </a:t>
-                </a:r>
-                <a:r>
-                  <a:rPr lang="en-US" b="1" dirty="0">
+                  <a:t>condition, and Eff(a) is the relation defining the </a:t>
+                </a:r>
+                <a:r>
+                  <a:rPr lang="en-US" sz="2400" b="1" dirty="0">
                     <a:latin typeface="+mj-lt"/>
                   </a:rPr>
                   <a:t>eff</a:t>
                 </a:r>
                 <a:r>
-                  <a:rPr lang="en-US" dirty="0">
+                  <a:rPr lang="en-US" sz="2400" dirty="0">
                     <a:latin typeface="+mj-lt"/>
                   </a:rPr>
                   <a:t>ect.</a:t>
                 </a:r>
               </a:p>
               <a:p>
-                <a:endParaRPr lang="en-US" dirty="0">
+                <a:pPr marL="0" indent="0">
+                  <a:buNone/>
+                </a:pPr>
+                <a:r>
+                  <a:rPr lang="en-US" sz="2400" dirty="0">
+                    <a:latin typeface="+mj-lt"/>
+                  </a:rPr>
+                  <a:t>States satisfying precondition are said to </a:t>
+                </a:r>
+                <a:r>
+                  <a:rPr lang="en-US" sz="2400" b="1" i="1" dirty="0">
+                    <a:solidFill>
+                      <a:srgbClr val="0070C0"/>
+                    </a:solidFill>
+                    <a:latin typeface="+mj-lt"/>
+                  </a:rPr>
+                  <a:t>enable</a:t>
+                </a:r>
+                <a:r>
+                  <a:rPr lang="en-US" sz="2400" dirty="0">
+                    <a:latin typeface="+mj-lt"/>
+                  </a:rPr>
+                  <a:t> the action</a:t>
+                </a:r>
+              </a:p>
+              <a:p>
+                <a:pPr marL="0" indent="0">
+                  <a:buNone/>
+                </a:pPr>
+                <a:r>
+                  <a:rPr lang="en-US" sz="2400" dirty="0">
+                    <a:latin typeface="+mj-lt"/>
+                  </a:rPr>
+                  <a:t>In general Eff(a) could be a relation, but for this example it is </a:t>
+                </a:r>
+                <a:r>
+                  <a:rPr lang="en-US" sz="2400">
+                    <a:latin typeface="+mj-lt"/>
+                  </a:rPr>
+                  <a:t>a function</a:t>
+                </a:r>
+                <a:endParaRPr lang="en-US" sz="2400" b="1" dirty="0">
                   <a:latin typeface="+mj-lt"/>
                 </a:endParaRPr>
               </a:p>
@@ -16997,88 +17030,51 @@
                   <a:buNone/>
                 </a:pPr>
                 <a:r>
-                  <a:rPr lang="en-US" dirty="0">
+                  <a:rPr lang="en-US" sz="2400" b="1" dirty="0">
                     <a:latin typeface="+mj-lt"/>
                   </a:rPr>
-                  <a:t>States satisfying precondition are said to </a:t>
-                </a:r>
-                <a:r>
-                  <a:rPr lang="en-US" b="1" i="1" dirty="0">
-                    <a:solidFill>
-                      <a:srgbClr val="0070C0"/>
-                    </a:solidFill>
+                  <a:t>Nondeterminism</a:t>
+                </a:r>
+              </a:p>
+              <a:p>
+                <a:r>
+                  <a:rPr lang="en-US" sz="2400" dirty="0">
                     <a:latin typeface="+mj-lt"/>
                   </a:rPr>
-                  <a:t>enable</a:t>
-                </a:r>
-                <a:r>
-                  <a:rPr lang="en-US" dirty="0">
+                  <a:t>Multiple initial states</a:t>
+                </a:r>
+              </a:p>
+              <a:p>
+                <a:r>
+                  <a:rPr lang="en-US" sz="2400" dirty="0">
                     <a:latin typeface="+mj-lt"/>
                   </a:rPr>
-                  <a:t> the action</a:t>
+                  <a:t>External nondeterminism: Multiple actions enabled from the same state</a:t>
                 </a:r>
               </a:p>
               <a:p>
-                <a:endParaRPr lang="en-US" dirty="0">
+                <a:r>
+                  <a:rPr lang="en-US" sz="2400" dirty="0">
+                    <a:latin typeface="+mj-lt"/>
+                  </a:rPr>
+                  <a:t>Internal nondeterminism: Multiple post-states from the same state and action</a:t>
+                </a:r>
+              </a:p>
+              <a:p>
+                <a:pPr marL="285750" indent="-285750"/>
+                <a:endParaRPr lang="en-US" sz="2400" dirty="0">
                   <a:latin typeface="+mj-lt"/>
                 </a:endParaRPr>
               </a:p>
               <a:p>
-                <a:pPr marL="0" indent="0">
-                  <a:buNone/>
-                </a:pPr>
-                <a:r>
-                  <a:rPr lang="en-US" dirty="0">
-                    <a:latin typeface="+mj-lt"/>
-                  </a:rPr>
-                  <a:t>In general Eff(a) could be a relation, but for this example it is a function</a:t>
-                </a:r>
-                <a:endParaRPr lang="en-US" b="1" dirty="0">
-                  <a:latin typeface="+mj-lt"/>
-                </a:endParaRPr>
-              </a:p>
-              <a:p>
-                <a:pPr marL="0" indent="0">
-                  <a:buNone/>
-                </a:pPr>
-                <a:r>
-                  <a:rPr lang="en-US" b="1" dirty="0">
-                    <a:latin typeface="+mj-lt"/>
-                  </a:rPr>
-                  <a:t>Nondeterminism</a:t>
-                </a:r>
-              </a:p>
-              <a:p>
-                <a:r>
-                  <a:rPr lang="en-US" dirty="0">
-                    <a:latin typeface="+mj-lt"/>
-                  </a:rPr>
-                  <a:t>Multiple actions enabled from the same state</a:t>
-                </a:r>
-              </a:p>
-              <a:p>
-                <a:r>
-                  <a:rPr lang="en-US" dirty="0">
-                    <a:latin typeface="+mj-lt"/>
-                  </a:rPr>
-                  <a:t>Multiple post-states from the same action</a:t>
-                </a:r>
-              </a:p>
-              <a:p>
-                <a:pPr marL="285750" indent="-285750"/>
-                <a:endParaRPr lang="en-US" dirty="0">
-                  <a:latin typeface="+mj-lt"/>
-                </a:endParaRPr>
-              </a:p>
-              <a:p>
-                <a:endParaRPr lang="en-US" dirty="0">
+                <a:endParaRPr lang="en-US" sz="2400" dirty="0">
                   <a:latin typeface="+mj-lt"/>
                 </a:endParaRPr>
               </a:p>
             </p:txBody>
           </p:sp>
         </mc:Choice>
-        <mc:Fallback xmlns="">
+        <mc:Fallback>
           <p:sp>
             <p:nvSpPr>
               <p:cNvPr id="3" name="Content Placeholder 2"/>
@@ -17090,10 +17086,14 @@
               </p:nvPr>
             </p:nvSpPr>
             <p:spPr>
+              <a:xfrm>
+                <a:off x="648419" y="1547521"/>
+                <a:ext cx="10515600" cy="4351338"/>
+              </a:xfrm>
               <a:blipFill>
                 <a:blip r:embed="rId2"/>
                 <a:stretch>
-                  <a:fillRect l="-1086" t="-2632" b="-5848"/>
+                  <a:fillRect l="-844" t="-1453"/>
                 </a:stretch>
               </a:blipFill>
             </p:spPr>
@@ -17188,7 +17188,7 @@
                                         <p:tgtEl>
                                           <p:spTgt spid="3">
                                             <p:txEl>
-                                              <p:pRg st="2" end="2"/>
+                                              <p:pRg st="1" end="1"/>
                                             </p:txEl>
                                           </p:spTgt>
                                         </p:tgtEl>
@@ -17237,7 +17237,7 @@
                                         <p:tgtEl>
                                           <p:spTgt spid="3">
                                             <p:txEl>
-                                              <p:pRg st="4" end="4"/>
+                                              <p:pRg st="2" end="2"/>
                                             </p:txEl>
                                           </p:spTgt>
                                         </p:tgtEl>
@@ -17286,7 +17286,7 @@
                                         <p:tgtEl>
                                           <p:spTgt spid="3">
                                             <p:txEl>
-                                              <p:pRg st="5" end="5"/>
+                                              <p:pRg st="3" end="3"/>
                                             </p:txEl>
                                           </p:spTgt>
                                         </p:tgtEl>
@@ -17335,7 +17335,7 @@
                                         <p:tgtEl>
                                           <p:spTgt spid="3">
                                             <p:txEl>
-                                              <p:pRg st="6" end="6"/>
+                                              <p:pRg st="4" end="4"/>
                                             </p:txEl>
                                           </p:spTgt>
                                         </p:tgtEl>
@@ -17384,7 +17384,56 @@
                                         <p:tgtEl>
                                           <p:spTgt spid="3">
                                             <p:txEl>
-                                              <p:pRg st="7" end="7"/>
+                                              <p:pRg st="5" end="5"/>
+                                            </p:txEl>
+                                          </p:spTgt>
+                                        </p:tgtEl>
+                                        <p:attrNameLst>
+                                          <p:attrName>style.visibility</p:attrName>
+                                        </p:attrNameLst>
+                                      </p:cBhvr>
+                                      <p:to>
+                                        <p:strVal val="visible"/>
+                                      </p:to>
+                                    </p:set>
+                                  </p:childTnLst>
+                                </p:cTn>
+                              </p:par>
+                            </p:childTnLst>
+                          </p:cTn>
+                        </p:par>
+                      </p:childTnLst>
+                    </p:cTn>
+                  </p:par>
+                  <p:par>
+                    <p:cTn id="23" fill="hold">
+                      <p:stCondLst>
+                        <p:cond delay="indefinite"/>
+                      </p:stCondLst>
+                      <p:childTnLst>
+                        <p:par>
+                          <p:cTn id="24" fill="hold">
+                            <p:stCondLst>
+                              <p:cond delay="0"/>
+                            </p:stCondLst>
+                            <p:childTnLst>
+                              <p:par>
+                                <p:cTn id="25" presetID="1" presetClass="entr" presetSubtype="0" fill="hold" nodeType="clickEffect">
+                                  <p:stCondLst>
+                                    <p:cond delay="0"/>
+                                  </p:stCondLst>
+                                  <p:childTnLst>
+                                    <p:set>
+                                      <p:cBhvr>
+                                        <p:cTn id="26" dur="1" fill="hold">
+                                          <p:stCondLst>
+                                            <p:cond delay="0"/>
+                                          </p:stCondLst>
+                                        </p:cTn>
+                                        <p:tgtEl>
+                                          <p:spTgt spid="3">
+                                            <p:txEl>
+                                              <p:pRg st="6" end="6"/>
                                             </p:txEl>
                                           </p:spTgt>
                                         </p:tgtEl>

</xml_diff>

<commit_message>
graphviz does not seem to work
</commit_message>
<xml_diff>
--- a/Slides/2025/L2_ModelingComputation.pptx
+++ b/Slides/2025/L2_ModelingComputation.pptx
@@ -5,7 +5,7 @@
     <p:sldMasterId id="2147483648" r:id="rId1"/>
   </p:sldMasterIdLst>
   <p:notesMasterIdLst>
-    <p:notesMasterId r:id="rId35"/>
+    <p:notesMasterId r:id="rId36"/>
   </p:notesMasterIdLst>
   <p:sldIdLst>
     <p:sldId id="324" r:id="rId2"/>
@@ -31,16 +31,17 @@
     <p:sldId id="319" r:id="rId22"/>
     <p:sldId id="320" r:id="rId23"/>
     <p:sldId id="345" r:id="rId24"/>
-    <p:sldId id="321" r:id="rId25"/>
-    <p:sldId id="335" r:id="rId26"/>
-    <p:sldId id="307" r:id="rId27"/>
-    <p:sldId id="322" r:id="rId28"/>
-    <p:sldId id="338" r:id="rId29"/>
-    <p:sldId id="337" r:id="rId30"/>
-    <p:sldId id="339" r:id="rId31"/>
-    <p:sldId id="340" r:id="rId32"/>
-    <p:sldId id="323" r:id="rId33"/>
-    <p:sldId id="293" r:id="rId34"/>
+    <p:sldId id="346" r:id="rId25"/>
+    <p:sldId id="321" r:id="rId26"/>
+    <p:sldId id="335" r:id="rId27"/>
+    <p:sldId id="307" r:id="rId28"/>
+    <p:sldId id="322" r:id="rId29"/>
+    <p:sldId id="338" r:id="rId30"/>
+    <p:sldId id="337" r:id="rId31"/>
+    <p:sldId id="339" r:id="rId32"/>
+    <p:sldId id="340" r:id="rId33"/>
+    <p:sldId id="323" r:id="rId34"/>
+    <p:sldId id="293" r:id="rId35"/>
   </p:sldIdLst>
   <p:sldSz cx="12192000" cy="6858000"/>
   <p:notesSz cx="6858000" cy="9144000"/>
@@ -1222,7 +1223,7 @@
             <a:fld id="{478875BD-0904-456D-BF1F-B156B76088E4}" type="slidenum">
               <a:rPr lang="en-US" sz="1200" smtClean="0"/>
               <a:pPr/>
-              <a:t>26</a:t>
+              <a:t>27</a:t>
             </a:fld>
             <a:endParaRPr lang="en-US" sz="1200"/>
           </a:p>
@@ -16873,6 +16874,94 @@
       </p:grpSpPr>
       <p:sp>
         <p:nvSpPr>
+          <p:cNvPr id="2" name="Title 1">
+            <a:extLst>
+              <a:ext uri="{FF2B5EF4-FFF2-40B4-BE49-F238E27FC236}">
+                <a16:creationId xmlns:a16="http://schemas.microsoft.com/office/drawing/2014/main" id="{FC011178-E247-853F-2425-5AEE5B0D2407}"/>
+              </a:ext>
+            </a:extLst>
+          </p:cNvPr>
+          <p:cNvSpPr>
+            <a:spLocks noGrp="1"/>
+          </p:cNvSpPr>
+          <p:nvPr>
+            <p:ph type="title"/>
+          </p:nvPr>
+        </p:nvSpPr>
+        <p:spPr/>
+        <p:txBody>
+          <a:bodyPr/>
+          <a:lstStyle/>
+          <a:p>
+            <a:r>
+              <a:rPr lang="en-US"/>
+              <a:t>Bit flip</a:t>
+            </a:r>
+          </a:p>
+        </p:txBody>
+      </p:sp>
+      <p:pic>
+        <p:nvPicPr>
+          <p:cNvPr id="4" name="Picture 3">
+            <a:extLst>
+              <a:ext uri="{FF2B5EF4-FFF2-40B4-BE49-F238E27FC236}">
+                <a16:creationId xmlns:a16="http://schemas.microsoft.com/office/drawing/2014/main" id="{6CA82748-7106-3910-B75F-D72C53F3BD5B}"/>
+              </a:ext>
+            </a:extLst>
+          </p:cNvPr>
+          <p:cNvPicPr>
+            <a:picLocks noChangeAspect="1"/>
+          </p:cNvPicPr>
+          <p:nvPr/>
+        </p:nvPicPr>
+        <p:blipFill>
+          <a:blip r:embed="rId2"/>
+          <a:stretch>
+            <a:fillRect/>
+          </a:stretch>
+        </p:blipFill>
+        <p:spPr>
+          <a:xfrm>
+            <a:off x="3581400" y="2254612"/>
+            <a:ext cx="6891068" cy="4409291"/>
+          </a:xfrm>
+          <a:prstGeom prst="rect">
+            <a:avLst/>
+          </a:prstGeom>
+        </p:spPr>
+      </p:pic>
+    </p:spTree>
+    <p:extLst>
+      <p:ext uri="{BB962C8B-B14F-4D97-AF65-F5344CB8AC3E}">
+        <p14:creationId xmlns:p14="http://schemas.microsoft.com/office/powerpoint/2010/main" val="4265624354"/>
+      </p:ext>
+    </p:extLst>
+  </p:cSld>
+  <p:clrMapOvr>
+    <a:masterClrMapping/>
+  </p:clrMapOvr>
+</p:sld>
+</file>
+
+<file path=ppt/slides/slide25.xml><?xml version="1.0" encoding="utf-8"?>
+<p:sld xmlns:a="http://schemas.openxmlformats.org/drawingml/2006/main" xmlns:r="http://schemas.openxmlformats.org/officeDocument/2006/relationships" xmlns:p="http://schemas.openxmlformats.org/presentationml/2006/main">
+  <p:cSld>
+    <p:spTree>
+      <p:nvGrpSpPr>
+        <p:cNvPr id="1" name=""/>
+        <p:cNvGrpSpPr/>
+        <p:nvPr/>
+      </p:nvGrpSpPr>
+      <p:grpSpPr>
+        <a:xfrm>
+          <a:off x="0" y="0"/>
+          <a:ext cx="0" cy="0"/>
+          <a:chOff x="0" y="0"/>
+          <a:chExt cx="0" cy="0"/>
+        </a:xfrm>
+      </p:grpSpPr>
+      <p:sp>
+        <p:nvSpPr>
           <p:cNvPr id="2" name="Title 1"/>
           <p:cNvSpPr>
             <a:spLocks noGrp="1"/>
@@ -17013,13 +17102,7 @@
                   <a:rPr lang="en-US" sz="2400" dirty="0">
                     <a:latin typeface="+mj-lt"/>
                   </a:rPr>
-                  <a:t>In general Eff(a) could be a relation, but for this example it is </a:t>
-                </a:r>
-                <a:r>
-                  <a:rPr lang="en-US" sz="2400">
-                    <a:latin typeface="+mj-lt"/>
-                  </a:rPr>
-                  <a:t>a function</a:t>
+                  <a:t>In general Eff(a) could be a relation, but for this example it is a function</a:t>
                 </a:r>
                 <a:endParaRPr lang="en-US" sz="2400" b="1" dirty="0">
                   <a:latin typeface="+mj-lt"/>
@@ -17479,7 +17562,7 @@
 </p:sld>
 </file>
 
-<file path=ppt/slides/slide25.xml><?xml version="1.0" encoding="utf-8"?>
+<file path=ppt/slides/slide26.xml><?xml version="1.0" encoding="utf-8"?>
 <p:sld xmlns:a="http://schemas.openxmlformats.org/drawingml/2006/main" xmlns:r="http://schemas.openxmlformats.org/officeDocument/2006/relationships" xmlns:p="http://schemas.openxmlformats.org/presentationml/2006/main">
   <p:cSld>
     <p:spTree>
@@ -17913,7 +17996,7 @@
 </p:sld>
 </file>
 
-<file path=ppt/slides/slide26.xml><?xml version="1.0" encoding="utf-8"?>
+<file path=ppt/slides/slide27.xml><?xml version="1.0" encoding="utf-8"?>
 <p:sld xmlns:a="http://schemas.openxmlformats.org/drawingml/2006/main" xmlns:r="http://schemas.openxmlformats.org/officeDocument/2006/relationships" xmlns:p="http://schemas.openxmlformats.org/presentationml/2006/main">
   <p:cSld>
     <p:spTree>
@@ -18775,7 +18858,7 @@
 </p:sld>
 </file>
 
-<file path=ppt/slides/slide27.xml><?xml version="1.0" encoding="utf-8"?>
+<file path=ppt/slides/slide28.xml><?xml version="1.0" encoding="utf-8"?>
 <p:sld xmlns:a="http://schemas.openxmlformats.org/drawingml/2006/main" xmlns:r="http://schemas.openxmlformats.org/officeDocument/2006/relationships" xmlns:p="http://schemas.openxmlformats.org/presentationml/2006/main">
   <p:cSld>
     <p:spTree>
@@ -19657,7 +19740,7 @@
 </p:sld>
 </file>
 
-<file path=ppt/slides/slide28.xml><?xml version="1.0" encoding="utf-8"?>
+<file path=ppt/slides/slide29.xml><?xml version="1.0" encoding="utf-8"?>
 <p:sld xmlns:a="http://schemas.openxmlformats.org/drawingml/2006/main" xmlns:r="http://schemas.openxmlformats.org/officeDocument/2006/relationships" xmlns:p="http://schemas.openxmlformats.org/presentationml/2006/main">
   <p:cSld>
     <p:spTree>
@@ -20443,7 +20526,285 @@
 </p:sld>
 </file>
 
-<file path=ppt/slides/slide29.xml><?xml version="1.0" encoding="utf-8"?>
+<file path=ppt/slides/slide3.xml><?xml version="1.0" encoding="utf-8"?>
+<p:sld xmlns:a="http://schemas.openxmlformats.org/drawingml/2006/main" xmlns:r="http://schemas.openxmlformats.org/officeDocument/2006/relationships" xmlns:p="http://schemas.openxmlformats.org/presentationml/2006/main">
+  <p:cSld>
+    <p:spTree>
+      <p:nvGrpSpPr>
+        <p:cNvPr id="1" name=""/>
+        <p:cNvGrpSpPr/>
+        <p:nvPr/>
+      </p:nvGrpSpPr>
+      <p:grpSpPr>
+        <a:xfrm>
+          <a:off x="0" y="0"/>
+          <a:ext cx="0" cy="0"/>
+          <a:chOff x="0" y="0"/>
+          <a:chExt cx="0" cy="0"/>
+        </a:xfrm>
+      </p:grpSpPr>
+      <p:sp>
+        <p:nvSpPr>
+          <p:cNvPr id="2" name="Title 1">
+            <a:extLst>
+              <a:ext uri="{FF2B5EF4-FFF2-40B4-BE49-F238E27FC236}">
+                <a16:creationId xmlns:a16="http://schemas.microsoft.com/office/drawing/2014/main" id="{89A6E0D0-E74E-2B45-B640-A1E3517EF8C2}"/>
+              </a:ext>
+            </a:extLst>
+          </p:cNvPr>
+          <p:cNvSpPr>
+            <a:spLocks noGrp="1"/>
+          </p:cNvSpPr>
+          <p:nvPr>
+            <p:ph type="title"/>
+          </p:nvPr>
+        </p:nvSpPr>
+        <p:spPr/>
+        <p:txBody>
+          <a:bodyPr/>
+          <a:lstStyle/>
+          <a:p>
+            <a:r>
+              <a:rPr lang="en-US" dirty="0"/>
+              <a:t>Automata or discrete transition systems</a:t>
+            </a:r>
+          </a:p>
+        </p:txBody>
+      </p:sp>
+      <p:sp>
+        <p:nvSpPr>
+          <p:cNvPr id="3" name="Content Placeholder 2">
+            <a:extLst>
+              <a:ext uri="{FF2B5EF4-FFF2-40B4-BE49-F238E27FC236}">
+                <a16:creationId xmlns:a16="http://schemas.microsoft.com/office/drawing/2014/main" id="{F147AA83-84E3-0342-8A94-AC07EADC2024}"/>
+              </a:ext>
+            </a:extLst>
+          </p:cNvPr>
+          <p:cNvSpPr>
+            <a:spLocks noGrp="1"/>
+          </p:cNvSpPr>
+          <p:nvPr>
+            <p:ph idx="1"/>
+          </p:nvPr>
+        </p:nvSpPr>
+        <p:spPr>
+          <a:xfrm>
+            <a:off x="838200" y="1560576"/>
+            <a:ext cx="10515600" cy="4932299"/>
+          </a:xfrm>
+        </p:spPr>
+        <p:txBody>
+          <a:bodyPr>
+            <a:normAutofit/>
+          </a:bodyPr>
+          <a:lstStyle/>
+          <a:p>
+            <a:pPr>
+              <a:lnSpc>
+                <a:spcPct val="110000"/>
+              </a:lnSpc>
+            </a:pPr>
+            <a:r>
+              <a:rPr lang="en-US" b="0" dirty="0">
+                <a:latin typeface="+mj-lt"/>
+                <a:ea typeface="Cambria Math" panose="02040503050406030204" pitchFamily="18" charset="0"/>
+              </a:rPr>
+              <a:t>The “state” of a system captures </a:t>
+            </a:r>
+            <a:r>
+              <a:rPr lang="en-US" dirty="0">
+                <a:latin typeface="+mj-lt"/>
+                <a:ea typeface="Cambria Math" panose="02040503050406030204" pitchFamily="18" charset="0"/>
+              </a:rPr>
+              <a:t>all the information needed to predict the system’s future behavior</a:t>
+            </a:r>
+          </a:p>
+          <a:p>
+            <a:pPr>
+              <a:lnSpc>
+                <a:spcPct val="110000"/>
+              </a:lnSpc>
+            </a:pPr>
+            <a:r>
+              <a:rPr lang="en-US" dirty="0">
+                <a:latin typeface="+mj-lt"/>
+                <a:ea typeface="Cambria Math" panose="02040503050406030204" pitchFamily="18" charset="0"/>
+              </a:rPr>
+              <a:t>Behavior of a system is a sequence of states</a:t>
+            </a:r>
+          </a:p>
+          <a:p>
+            <a:pPr>
+              <a:lnSpc>
+                <a:spcPct val="110000"/>
+              </a:lnSpc>
+            </a:pPr>
+            <a:r>
+              <a:rPr lang="en-US" i="1" dirty="0">
+                <a:latin typeface="+mj-lt"/>
+                <a:ea typeface="Cambria Math" panose="02040503050406030204" pitchFamily="18" charset="0"/>
+              </a:rPr>
+              <a:t>Our ultimate goal: write programs that prove properties about all behaviors of a system</a:t>
+            </a:r>
+          </a:p>
+          <a:p>
+            <a:pPr>
+              <a:lnSpc>
+                <a:spcPct val="110000"/>
+              </a:lnSpc>
+            </a:pPr>
+            <a:r>
+              <a:rPr lang="en-US" dirty="0">
+                <a:latin typeface="+mj-lt"/>
+                <a:ea typeface="Cambria Math" panose="02040503050406030204" pitchFamily="18" charset="0"/>
+              </a:rPr>
+              <a:t>“Transitions” capture how the state can change</a:t>
+            </a:r>
+          </a:p>
+        </p:txBody>
+      </p:sp>
+    </p:spTree>
+    <p:extLst>
+      <p:ext uri="{BB962C8B-B14F-4D97-AF65-F5344CB8AC3E}">
+        <p14:creationId xmlns:p14="http://schemas.microsoft.com/office/powerpoint/2010/main" val="3978938520"/>
+      </p:ext>
+    </p:extLst>
+  </p:cSld>
+  <p:clrMapOvr>
+    <a:masterClrMapping/>
+  </p:clrMapOvr>
+  <p:timing>
+    <p:tnLst>
+      <p:par>
+        <p:cTn id="1" dur="indefinite" restart="never" nodeType="tmRoot">
+          <p:childTnLst>
+            <p:seq concurrent="1" nextAc="seek">
+              <p:cTn id="2" dur="indefinite" nodeType="mainSeq">
+                <p:childTnLst>
+                  <p:par>
+                    <p:cTn id="3" fill="hold">
+                      <p:stCondLst>
+                        <p:cond delay="indefinite"/>
+                      </p:stCondLst>
+                      <p:childTnLst>
+                        <p:par>
+                          <p:cTn id="4" fill="hold">
+                            <p:stCondLst>
+                              <p:cond delay="0"/>
+                            </p:stCondLst>
+                            <p:childTnLst>
+                              <p:par>
+                                <p:cTn id="5" presetID="1" presetClass="entr" presetSubtype="0" fill="hold" nodeType="clickEffect">
+                                  <p:stCondLst>
+                                    <p:cond delay="0"/>
+                                  </p:stCondLst>
+                                  <p:childTnLst>
+                                    <p:set>
+                                      <p:cBhvr>
+                                        <p:cTn id="6" dur="1" fill="hold">
+                                          <p:stCondLst>
+                                            <p:cond delay="0"/>
+                                          </p:stCondLst>
+                                        </p:cTn>
+                                        <p:tgtEl>
+                                          <p:spTgt spid="3">
+                                            <p:txEl>
+                                              <p:pRg st="2" end="2"/>
+                                            </p:txEl>
+                                          </p:spTgt>
+                                        </p:tgtEl>
+                                        <p:attrNameLst>
+                                          <p:attrName>style.visibility</p:attrName>
+                                        </p:attrNameLst>
+                                      </p:cBhvr>
+                                      <p:to>
+                                        <p:strVal val="visible"/>
+                                      </p:to>
+                                    </p:set>
+                                  </p:childTnLst>
+                                </p:cTn>
+                              </p:par>
+                            </p:childTnLst>
+                          </p:cTn>
+                        </p:par>
+                      </p:childTnLst>
+                    </p:cTn>
+                  </p:par>
+                  <p:par>
+                    <p:cTn id="7" fill="hold">
+                      <p:stCondLst>
+                        <p:cond delay="indefinite"/>
+                      </p:stCondLst>
+                      <p:childTnLst>
+                        <p:par>
+                          <p:cTn id="8" fill="hold">
+                            <p:stCondLst>
+                              <p:cond delay="0"/>
+                            </p:stCondLst>
+                            <p:childTnLst>
+                              <p:par>
+                                <p:cTn id="9" presetID="1" presetClass="entr" presetSubtype="0" fill="hold" nodeType="clickEffect">
+                                  <p:stCondLst>
+                                    <p:cond delay="0"/>
+                                  </p:stCondLst>
+                                  <p:childTnLst>
+                                    <p:set>
+                                      <p:cBhvr>
+                                        <p:cTn id="10" dur="1" fill="hold">
+                                          <p:stCondLst>
+                                            <p:cond delay="0"/>
+                                          </p:stCondLst>
+                                        </p:cTn>
+                                        <p:tgtEl>
+                                          <p:spTgt spid="3">
+                                            <p:txEl>
+                                              <p:pRg st="3" end="3"/>
+                                            </p:txEl>
+                                          </p:spTgt>
+                                        </p:tgtEl>
+                                        <p:attrNameLst>
+                                          <p:attrName>style.visibility</p:attrName>
+                                        </p:attrNameLst>
+                                      </p:cBhvr>
+                                      <p:to>
+                                        <p:strVal val="visible"/>
+                                      </p:to>
+                                    </p:set>
+                                  </p:childTnLst>
+                                </p:cTn>
+                              </p:par>
+                            </p:childTnLst>
+                          </p:cTn>
+                        </p:par>
+                      </p:childTnLst>
+                    </p:cTn>
+                  </p:par>
+                </p:childTnLst>
+              </p:cTn>
+              <p:prevCondLst>
+                <p:cond evt="onPrev" delay="0">
+                  <p:tgtEl>
+                    <p:sldTgt/>
+                  </p:tgtEl>
+                </p:cond>
+              </p:prevCondLst>
+              <p:nextCondLst>
+                <p:cond evt="onNext" delay="0">
+                  <p:tgtEl>
+                    <p:sldTgt/>
+                  </p:tgtEl>
+                </p:cond>
+              </p:nextCondLst>
+            </p:seq>
+          </p:childTnLst>
+        </p:cTn>
+      </p:par>
+    </p:tnLst>
+  </p:timing>
+</p:sld>
+</file>
+
+<file path=ppt/slides/slide30.xml><?xml version="1.0" encoding="utf-8"?>
 <p:sld xmlns:a="http://schemas.openxmlformats.org/drawingml/2006/main" xmlns:r="http://schemas.openxmlformats.org/officeDocument/2006/relationships" xmlns:p="http://schemas.openxmlformats.org/presentationml/2006/main">
   <p:cSld>
     <p:spTree>
@@ -22179,285 +22540,7 @@
 </p:sld>
 </file>
 
-<file path=ppt/slides/slide3.xml><?xml version="1.0" encoding="utf-8"?>
-<p:sld xmlns:a="http://schemas.openxmlformats.org/drawingml/2006/main" xmlns:r="http://schemas.openxmlformats.org/officeDocument/2006/relationships" xmlns:p="http://schemas.openxmlformats.org/presentationml/2006/main">
-  <p:cSld>
-    <p:spTree>
-      <p:nvGrpSpPr>
-        <p:cNvPr id="1" name=""/>
-        <p:cNvGrpSpPr/>
-        <p:nvPr/>
-      </p:nvGrpSpPr>
-      <p:grpSpPr>
-        <a:xfrm>
-          <a:off x="0" y="0"/>
-          <a:ext cx="0" cy="0"/>
-          <a:chOff x="0" y="0"/>
-          <a:chExt cx="0" cy="0"/>
-        </a:xfrm>
-      </p:grpSpPr>
-      <p:sp>
-        <p:nvSpPr>
-          <p:cNvPr id="2" name="Title 1">
-            <a:extLst>
-              <a:ext uri="{FF2B5EF4-FFF2-40B4-BE49-F238E27FC236}">
-                <a16:creationId xmlns:a16="http://schemas.microsoft.com/office/drawing/2014/main" id="{89A6E0D0-E74E-2B45-B640-A1E3517EF8C2}"/>
-              </a:ext>
-            </a:extLst>
-          </p:cNvPr>
-          <p:cNvSpPr>
-            <a:spLocks noGrp="1"/>
-          </p:cNvSpPr>
-          <p:nvPr>
-            <p:ph type="title"/>
-          </p:nvPr>
-        </p:nvSpPr>
-        <p:spPr/>
-        <p:txBody>
-          <a:bodyPr/>
-          <a:lstStyle/>
-          <a:p>
-            <a:r>
-              <a:rPr lang="en-US" dirty="0"/>
-              <a:t>Automata or discrete transition systems</a:t>
-            </a:r>
-          </a:p>
-        </p:txBody>
-      </p:sp>
-      <p:sp>
-        <p:nvSpPr>
-          <p:cNvPr id="3" name="Content Placeholder 2">
-            <a:extLst>
-              <a:ext uri="{FF2B5EF4-FFF2-40B4-BE49-F238E27FC236}">
-                <a16:creationId xmlns:a16="http://schemas.microsoft.com/office/drawing/2014/main" id="{F147AA83-84E3-0342-8A94-AC07EADC2024}"/>
-              </a:ext>
-            </a:extLst>
-          </p:cNvPr>
-          <p:cNvSpPr>
-            <a:spLocks noGrp="1"/>
-          </p:cNvSpPr>
-          <p:nvPr>
-            <p:ph idx="1"/>
-          </p:nvPr>
-        </p:nvSpPr>
-        <p:spPr>
-          <a:xfrm>
-            <a:off x="838200" y="1560576"/>
-            <a:ext cx="10515600" cy="4932299"/>
-          </a:xfrm>
-        </p:spPr>
-        <p:txBody>
-          <a:bodyPr>
-            <a:normAutofit/>
-          </a:bodyPr>
-          <a:lstStyle/>
-          <a:p>
-            <a:pPr>
-              <a:lnSpc>
-                <a:spcPct val="110000"/>
-              </a:lnSpc>
-            </a:pPr>
-            <a:r>
-              <a:rPr lang="en-US" b="0" dirty="0">
-                <a:latin typeface="+mj-lt"/>
-                <a:ea typeface="Cambria Math" panose="02040503050406030204" pitchFamily="18" charset="0"/>
-              </a:rPr>
-              <a:t>The “state” of a system captures </a:t>
-            </a:r>
-            <a:r>
-              <a:rPr lang="en-US" dirty="0">
-                <a:latin typeface="+mj-lt"/>
-                <a:ea typeface="Cambria Math" panose="02040503050406030204" pitchFamily="18" charset="0"/>
-              </a:rPr>
-              <a:t>all the information needed to predict the system’s future behavior</a:t>
-            </a:r>
-          </a:p>
-          <a:p>
-            <a:pPr>
-              <a:lnSpc>
-                <a:spcPct val="110000"/>
-              </a:lnSpc>
-            </a:pPr>
-            <a:r>
-              <a:rPr lang="en-US" dirty="0">
-                <a:latin typeface="+mj-lt"/>
-                <a:ea typeface="Cambria Math" panose="02040503050406030204" pitchFamily="18" charset="0"/>
-              </a:rPr>
-              <a:t>Behavior of a system is a sequence of states</a:t>
-            </a:r>
-          </a:p>
-          <a:p>
-            <a:pPr>
-              <a:lnSpc>
-                <a:spcPct val="110000"/>
-              </a:lnSpc>
-            </a:pPr>
-            <a:r>
-              <a:rPr lang="en-US" i="1" dirty="0">
-                <a:latin typeface="+mj-lt"/>
-                <a:ea typeface="Cambria Math" panose="02040503050406030204" pitchFamily="18" charset="0"/>
-              </a:rPr>
-              <a:t>Our ultimate goal: write programs that prove properties about all behaviors of a system</a:t>
-            </a:r>
-          </a:p>
-          <a:p>
-            <a:pPr>
-              <a:lnSpc>
-                <a:spcPct val="110000"/>
-              </a:lnSpc>
-            </a:pPr>
-            <a:r>
-              <a:rPr lang="en-US" dirty="0">
-                <a:latin typeface="+mj-lt"/>
-                <a:ea typeface="Cambria Math" panose="02040503050406030204" pitchFamily="18" charset="0"/>
-              </a:rPr>
-              <a:t>“Transitions” capture how the state can change</a:t>
-            </a:r>
-          </a:p>
-        </p:txBody>
-      </p:sp>
-    </p:spTree>
-    <p:extLst>
-      <p:ext uri="{BB962C8B-B14F-4D97-AF65-F5344CB8AC3E}">
-        <p14:creationId xmlns:p14="http://schemas.microsoft.com/office/powerpoint/2010/main" val="3978938520"/>
-      </p:ext>
-    </p:extLst>
-  </p:cSld>
-  <p:clrMapOvr>
-    <a:masterClrMapping/>
-  </p:clrMapOvr>
-  <p:timing>
-    <p:tnLst>
-      <p:par>
-        <p:cTn id="1" dur="indefinite" restart="never" nodeType="tmRoot">
-          <p:childTnLst>
-            <p:seq concurrent="1" nextAc="seek">
-              <p:cTn id="2" dur="indefinite" nodeType="mainSeq">
-                <p:childTnLst>
-                  <p:par>
-                    <p:cTn id="3" fill="hold">
-                      <p:stCondLst>
-                        <p:cond delay="indefinite"/>
-                      </p:stCondLst>
-                      <p:childTnLst>
-                        <p:par>
-                          <p:cTn id="4" fill="hold">
-                            <p:stCondLst>
-                              <p:cond delay="0"/>
-                            </p:stCondLst>
-                            <p:childTnLst>
-                              <p:par>
-                                <p:cTn id="5" presetID="1" presetClass="entr" presetSubtype="0" fill="hold" nodeType="clickEffect">
-                                  <p:stCondLst>
-                                    <p:cond delay="0"/>
-                                  </p:stCondLst>
-                                  <p:childTnLst>
-                                    <p:set>
-                                      <p:cBhvr>
-                                        <p:cTn id="6" dur="1" fill="hold">
-                                          <p:stCondLst>
-                                            <p:cond delay="0"/>
-                                          </p:stCondLst>
-                                        </p:cTn>
-                                        <p:tgtEl>
-                                          <p:spTgt spid="3">
-                                            <p:txEl>
-                                              <p:pRg st="2" end="2"/>
-                                            </p:txEl>
-                                          </p:spTgt>
-                                        </p:tgtEl>
-                                        <p:attrNameLst>
-                                          <p:attrName>style.visibility</p:attrName>
-                                        </p:attrNameLst>
-                                      </p:cBhvr>
-                                      <p:to>
-                                        <p:strVal val="visible"/>
-                                      </p:to>
-                                    </p:set>
-                                  </p:childTnLst>
-                                </p:cTn>
-                              </p:par>
-                            </p:childTnLst>
-                          </p:cTn>
-                        </p:par>
-                      </p:childTnLst>
-                    </p:cTn>
-                  </p:par>
-                  <p:par>
-                    <p:cTn id="7" fill="hold">
-                      <p:stCondLst>
-                        <p:cond delay="indefinite"/>
-                      </p:stCondLst>
-                      <p:childTnLst>
-                        <p:par>
-                          <p:cTn id="8" fill="hold">
-                            <p:stCondLst>
-                              <p:cond delay="0"/>
-                            </p:stCondLst>
-                            <p:childTnLst>
-                              <p:par>
-                                <p:cTn id="9" presetID="1" presetClass="entr" presetSubtype="0" fill="hold" nodeType="clickEffect">
-                                  <p:stCondLst>
-                                    <p:cond delay="0"/>
-                                  </p:stCondLst>
-                                  <p:childTnLst>
-                                    <p:set>
-                                      <p:cBhvr>
-                                        <p:cTn id="10" dur="1" fill="hold">
-                                          <p:stCondLst>
-                                            <p:cond delay="0"/>
-                                          </p:stCondLst>
-                                        </p:cTn>
-                                        <p:tgtEl>
-                                          <p:spTgt spid="3">
-                                            <p:txEl>
-                                              <p:pRg st="3" end="3"/>
-                                            </p:txEl>
-                                          </p:spTgt>
-                                        </p:tgtEl>
-                                        <p:attrNameLst>
-                                          <p:attrName>style.visibility</p:attrName>
-                                        </p:attrNameLst>
-                                      </p:cBhvr>
-                                      <p:to>
-                                        <p:strVal val="visible"/>
-                                      </p:to>
-                                    </p:set>
-                                  </p:childTnLst>
-                                </p:cTn>
-                              </p:par>
-                            </p:childTnLst>
-                          </p:cTn>
-                        </p:par>
-                      </p:childTnLst>
-                    </p:cTn>
-                  </p:par>
-                </p:childTnLst>
-              </p:cTn>
-              <p:prevCondLst>
-                <p:cond evt="onPrev" delay="0">
-                  <p:tgtEl>
-                    <p:sldTgt/>
-                  </p:tgtEl>
-                </p:cond>
-              </p:prevCondLst>
-              <p:nextCondLst>
-                <p:cond evt="onNext" delay="0">
-                  <p:tgtEl>
-                    <p:sldTgt/>
-                  </p:tgtEl>
-                </p:cond>
-              </p:nextCondLst>
-            </p:seq>
-          </p:childTnLst>
-        </p:cTn>
-      </p:par>
-    </p:tnLst>
-  </p:timing>
-</p:sld>
-</file>
-
-<file path=ppt/slides/slide30.xml><?xml version="1.0" encoding="utf-8"?>
+<file path=ppt/slides/slide31.xml><?xml version="1.0" encoding="utf-8"?>
 <p:sld xmlns:a="http://schemas.openxmlformats.org/drawingml/2006/main" xmlns:r="http://schemas.openxmlformats.org/officeDocument/2006/relationships" xmlns:p="http://schemas.openxmlformats.org/presentationml/2006/main">
   <p:cSld>
     <p:spTree>
@@ -26441,7 +26524,7 @@
 </p:sld>
 </file>
 
-<file path=ppt/slides/slide31.xml><?xml version="1.0" encoding="utf-8"?>
+<file path=ppt/slides/slide32.xml><?xml version="1.0" encoding="utf-8"?>
 <p:sld xmlns:a="http://schemas.openxmlformats.org/drawingml/2006/main" xmlns:r="http://schemas.openxmlformats.org/officeDocument/2006/relationships" xmlns:p="http://schemas.openxmlformats.org/presentationml/2006/main">
   <p:cSld>
     <p:spTree>
@@ -26548,7 +26631,7 @@
 </p:sld>
 </file>
 
-<file path=ppt/slides/slide32.xml><?xml version="1.0" encoding="utf-8"?>
+<file path=ppt/slides/slide33.xml><?xml version="1.0" encoding="utf-8"?>
 <p:sld xmlns:a="http://schemas.openxmlformats.org/drawingml/2006/main" xmlns:r="http://schemas.openxmlformats.org/officeDocument/2006/relationships" xmlns:p="http://schemas.openxmlformats.org/presentationml/2006/main">
   <p:cSld>
     <p:spTree>
@@ -26619,7 +26702,7 @@
 </p:sld>
 </file>
 
-<file path=ppt/slides/slide33.xml><?xml version="1.0" encoding="utf-8"?>
+<file path=ppt/slides/slide34.xml><?xml version="1.0" encoding="utf-8"?>
 <p:sld xmlns:a="http://schemas.openxmlformats.org/drawingml/2006/main" xmlns:r="http://schemas.openxmlformats.org/officeDocument/2006/relationships" xmlns:p="http://schemas.openxmlformats.org/presentationml/2006/main">
   <p:cSld>
     <p:spTree>

</xml_diff>

<commit_message>
Working graphviz, but there is a bug with duplication of 000 in IncDec
</commit_message>
<xml_diff>
--- a/Slides/2025/L2_ModelingComputation.pptx
+++ b/Slides/2025/L2_ModelingComputation.pptx
@@ -5,7 +5,7 @@
     <p:sldMasterId id="2147483648" r:id="rId1"/>
   </p:sldMasterIdLst>
   <p:notesMasterIdLst>
-    <p:notesMasterId r:id="rId36"/>
+    <p:notesMasterId r:id="rId37"/>
   </p:notesMasterIdLst>
   <p:sldIdLst>
     <p:sldId id="324" r:id="rId2"/>
@@ -31,17 +31,18 @@
     <p:sldId id="319" r:id="rId22"/>
     <p:sldId id="320" r:id="rId23"/>
     <p:sldId id="345" r:id="rId24"/>
-    <p:sldId id="346" r:id="rId25"/>
-    <p:sldId id="321" r:id="rId26"/>
-    <p:sldId id="335" r:id="rId27"/>
-    <p:sldId id="307" r:id="rId28"/>
-    <p:sldId id="322" r:id="rId29"/>
-    <p:sldId id="338" r:id="rId30"/>
-    <p:sldId id="337" r:id="rId31"/>
-    <p:sldId id="339" r:id="rId32"/>
-    <p:sldId id="340" r:id="rId33"/>
-    <p:sldId id="323" r:id="rId34"/>
-    <p:sldId id="293" r:id="rId35"/>
+    <p:sldId id="347" r:id="rId25"/>
+    <p:sldId id="346" r:id="rId26"/>
+    <p:sldId id="321" r:id="rId27"/>
+    <p:sldId id="335" r:id="rId28"/>
+    <p:sldId id="307" r:id="rId29"/>
+    <p:sldId id="322" r:id="rId30"/>
+    <p:sldId id="338" r:id="rId31"/>
+    <p:sldId id="337" r:id="rId32"/>
+    <p:sldId id="339" r:id="rId33"/>
+    <p:sldId id="340" r:id="rId34"/>
+    <p:sldId id="323" r:id="rId35"/>
+    <p:sldId id="293" r:id="rId36"/>
   </p:sldIdLst>
   <p:sldSz cx="12192000" cy="6858000"/>
   <p:notesSz cx="6858000" cy="9144000"/>
@@ -1223,7 +1224,7 @@
             <a:fld id="{478875BD-0904-456D-BF1F-B156B76088E4}" type="slidenum">
               <a:rPr lang="en-US" sz="1200" smtClean="0"/>
               <a:pPr/>
-              <a:t>27</a:t>
+              <a:t>28</a:t>
             </a:fld>
             <a:endParaRPr lang="en-US" sz="1200"/>
           </a:p>
@@ -16877,6 +16878,124 @@
           <p:cNvPr id="2" name="Title 1">
             <a:extLst>
               <a:ext uri="{FF2B5EF4-FFF2-40B4-BE49-F238E27FC236}">
+                <a16:creationId xmlns:a16="http://schemas.microsoft.com/office/drawing/2014/main" id="{D2E8BF0A-3B55-6903-5855-DDD10FBEDB89}"/>
+              </a:ext>
+            </a:extLst>
+          </p:cNvPr>
+          <p:cNvSpPr>
+            <a:spLocks noGrp="1"/>
+          </p:cNvSpPr>
+          <p:nvPr>
+            <p:ph type="title"/>
+          </p:nvPr>
+        </p:nvSpPr>
+        <p:spPr/>
+        <p:txBody>
+          <a:bodyPr/>
+          <a:lstStyle/>
+          <a:p>
+            <a:r>
+              <a:rPr lang="en-US" dirty="0"/>
+              <a:t>Inc dec</a:t>
+            </a:r>
+          </a:p>
+        </p:txBody>
+      </p:sp>
+      <p:sp>
+        <p:nvSpPr>
+          <p:cNvPr id="3" name="Content Placeholder 2">
+            <a:extLst>
+              <a:ext uri="{FF2B5EF4-FFF2-40B4-BE49-F238E27FC236}">
+                <a16:creationId xmlns:a16="http://schemas.microsoft.com/office/drawing/2014/main" id="{B8568BC5-910F-5390-9DA2-C104CAD31328}"/>
+              </a:ext>
+            </a:extLst>
+          </p:cNvPr>
+          <p:cNvSpPr>
+            <a:spLocks noGrp="1"/>
+          </p:cNvSpPr>
+          <p:nvPr>
+            <p:ph idx="1"/>
+          </p:nvPr>
+        </p:nvSpPr>
+        <p:spPr>
+          <a:xfrm>
+            <a:off x="838200" y="1825625"/>
+            <a:ext cx="5873151" cy="4351338"/>
+          </a:xfrm>
+        </p:spPr>
+        <p:txBody>
+          <a:bodyPr/>
+          <a:lstStyle/>
+          <a:p>
+            <a:endParaRPr lang="en-US" dirty="0"/>
+          </a:p>
+        </p:txBody>
+      </p:sp>
+      <p:pic>
+        <p:nvPicPr>
+          <p:cNvPr id="4" name="Picture 3">
+            <a:extLst>
+              <a:ext uri="{FF2B5EF4-FFF2-40B4-BE49-F238E27FC236}">
+                <a16:creationId xmlns:a16="http://schemas.microsoft.com/office/drawing/2014/main" id="{710EF7E6-7CB9-C8D0-EA3E-4ED88CBCE8F6}"/>
+              </a:ext>
+            </a:extLst>
+          </p:cNvPr>
+          <p:cNvPicPr>
+            <a:picLocks noChangeAspect="1"/>
+          </p:cNvPicPr>
+          <p:nvPr/>
+        </p:nvPicPr>
+        <p:blipFill>
+          <a:blip r:embed="rId2"/>
+          <a:stretch>
+            <a:fillRect/>
+          </a:stretch>
+        </p:blipFill>
+        <p:spPr>
+          <a:xfrm>
+            <a:off x="8716994" y="0"/>
+            <a:ext cx="3660471" cy="6858000"/>
+          </a:xfrm>
+          <a:prstGeom prst="rect">
+            <a:avLst/>
+          </a:prstGeom>
+        </p:spPr>
+      </p:pic>
+    </p:spTree>
+    <p:extLst>
+      <p:ext uri="{BB962C8B-B14F-4D97-AF65-F5344CB8AC3E}">
+        <p14:creationId xmlns:p14="http://schemas.microsoft.com/office/powerpoint/2010/main" val="3951314231"/>
+      </p:ext>
+    </p:extLst>
+  </p:cSld>
+  <p:clrMapOvr>
+    <a:masterClrMapping/>
+  </p:clrMapOvr>
+</p:sld>
+</file>
+
+<file path=ppt/slides/slide25.xml><?xml version="1.0" encoding="utf-8"?>
+<p:sld xmlns:a="http://schemas.openxmlformats.org/drawingml/2006/main" xmlns:r="http://schemas.openxmlformats.org/officeDocument/2006/relationships" xmlns:p="http://schemas.openxmlformats.org/presentationml/2006/main">
+  <p:cSld>
+    <p:spTree>
+      <p:nvGrpSpPr>
+        <p:cNvPr id="1" name=""/>
+        <p:cNvGrpSpPr/>
+        <p:nvPr/>
+      </p:nvGrpSpPr>
+      <p:grpSpPr>
+        <a:xfrm>
+          <a:off x="0" y="0"/>
+          <a:ext cx="0" cy="0"/>
+          <a:chOff x="0" y="0"/>
+          <a:chExt cx="0" cy="0"/>
+        </a:xfrm>
+      </p:grpSpPr>
+      <p:sp>
+        <p:nvSpPr>
+          <p:cNvPr id="2" name="Title 1">
+            <a:extLst>
+              <a:ext uri="{FF2B5EF4-FFF2-40B4-BE49-F238E27FC236}">
                 <a16:creationId xmlns:a16="http://schemas.microsoft.com/office/drawing/2014/main" id="{FC011178-E247-853F-2425-5AEE5B0D2407}"/>
               </a:ext>
             </a:extLst>
@@ -16894,7 +17013,7 @@
           <a:lstStyle/>
           <a:p>
             <a:r>
-              <a:rPr lang="en-US"/>
+              <a:rPr lang="en-US" dirty="0"/>
               <a:t>Bit flip</a:t>
             </a:r>
           </a:p>
@@ -16943,7 +17062,7 @@
 </p:sld>
 </file>
 
-<file path=ppt/slides/slide25.xml><?xml version="1.0" encoding="utf-8"?>
+<file path=ppt/slides/slide26.xml><?xml version="1.0" encoding="utf-8"?>
 <p:sld xmlns:a="http://schemas.openxmlformats.org/drawingml/2006/main" xmlns:r="http://schemas.openxmlformats.org/officeDocument/2006/relationships" xmlns:p="http://schemas.openxmlformats.org/presentationml/2006/main">
   <p:cSld>
     <p:spTree>
@@ -17562,7 +17681,7 @@
 </p:sld>
 </file>
 
-<file path=ppt/slides/slide26.xml><?xml version="1.0" encoding="utf-8"?>
+<file path=ppt/slides/slide27.xml><?xml version="1.0" encoding="utf-8"?>
 <p:sld xmlns:a="http://schemas.openxmlformats.org/drawingml/2006/main" xmlns:r="http://schemas.openxmlformats.org/officeDocument/2006/relationships" xmlns:p="http://schemas.openxmlformats.org/presentationml/2006/main">
   <p:cSld>
     <p:spTree>
@@ -17996,7 +18115,7 @@
 </p:sld>
 </file>
 
-<file path=ppt/slides/slide27.xml><?xml version="1.0" encoding="utf-8"?>
+<file path=ppt/slides/slide28.xml><?xml version="1.0" encoding="utf-8"?>
 <p:sld xmlns:a="http://schemas.openxmlformats.org/drawingml/2006/main" xmlns:r="http://schemas.openxmlformats.org/officeDocument/2006/relationships" xmlns:p="http://schemas.openxmlformats.org/presentationml/2006/main">
   <p:cSld>
     <p:spTree>
@@ -18858,7 +18977,7 @@
 </p:sld>
 </file>
 
-<file path=ppt/slides/slide28.xml><?xml version="1.0" encoding="utf-8"?>
+<file path=ppt/slides/slide29.xml><?xml version="1.0" encoding="utf-8"?>
 <p:sld xmlns:a="http://schemas.openxmlformats.org/drawingml/2006/main" xmlns:r="http://schemas.openxmlformats.org/officeDocument/2006/relationships" xmlns:p="http://schemas.openxmlformats.org/presentationml/2006/main">
   <p:cSld>
     <p:spTree>
@@ -19740,7 +19859,285 @@
 </p:sld>
 </file>
 
-<file path=ppt/slides/slide29.xml><?xml version="1.0" encoding="utf-8"?>
+<file path=ppt/slides/slide3.xml><?xml version="1.0" encoding="utf-8"?>
+<p:sld xmlns:a="http://schemas.openxmlformats.org/drawingml/2006/main" xmlns:r="http://schemas.openxmlformats.org/officeDocument/2006/relationships" xmlns:p="http://schemas.openxmlformats.org/presentationml/2006/main">
+  <p:cSld>
+    <p:spTree>
+      <p:nvGrpSpPr>
+        <p:cNvPr id="1" name=""/>
+        <p:cNvGrpSpPr/>
+        <p:nvPr/>
+      </p:nvGrpSpPr>
+      <p:grpSpPr>
+        <a:xfrm>
+          <a:off x="0" y="0"/>
+          <a:ext cx="0" cy="0"/>
+          <a:chOff x="0" y="0"/>
+          <a:chExt cx="0" cy="0"/>
+        </a:xfrm>
+      </p:grpSpPr>
+      <p:sp>
+        <p:nvSpPr>
+          <p:cNvPr id="2" name="Title 1">
+            <a:extLst>
+              <a:ext uri="{FF2B5EF4-FFF2-40B4-BE49-F238E27FC236}">
+                <a16:creationId xmlns:a16="http://schemas.microsoft.com/office/drawing/2014/main" id="{89A6E0D0-E74E-2B45-B640-A1E3517EF8C2}"/>
+              </a:ext>
+            </a:extLst>
+          </p:cNvPr>
+          <p:cNvSpPr>
+            <a:spLocks noGrp="1"/>
+          </p:cNvSpPr>
+          <p:nvPr>
+            <p:ph type="title"/>
+          </p:nvPr>
+        </p:nvSpPr>
+        <p:spPr/>
+        <p:txBody>
+          <a:bodyPr/>
+          <a:lstStyle/>
+          <a:p>
+            <a:r>
+              <a:rPr lang="en-US" dirty="0"/>
+              <a:t>Automata or discrete transition systems</a:t>
+            </a:r>
+          </a:p>
+        </p:txBody>
+      </p:sp>
+      <p:sp>
+        <p:nvSpPr>
+          <p:cNvPr id="3" name="Content Placeholder 2">
+            <a:extLst>
+              <a:ext uri="{FF2B5EF4-FFF2-40B4-BE49-F238E27FC236}">
+                <a16:creationId xmlns:a16="http://schemas.microsoft.com/office/drawing/2014/main" id="{F147AA83-84E3-0342-8A94-AC07EADC2024}"/>
+              </a:ext>
+            </a:extLst>
+          </p:cNvPr>
+          <p:cNvSpPr>
+            <a:spLocks noGrp="1"/>
+          </p:cNvSpPr>
+          <p:nvPr>
+            <p:ph idx="1"/>
+          </p:nvPr>
+        </p:nvSpPr>
+        <p:spPr>
+          <a:xfrm>
+            <a:off x="838200" y="1560576"/>
+            <a:ext cx="10515600" cy="4932299"/>
+          </a:xfrm>
+        </p:spPr>
+        <p:txBody>
+          <a:bodyPr>
+            <a:normAutofit/>
+          </a:bodyPr>
+          <a:lstStyle/>
+          <a:p>
+            <a:pPr>
+              <a:lnSpc>
+                <a:spcPct val="110000"/>
+              </a:lnSpc>
+            </a:pPr>
+            <a:r>
+              <a:rPr lang="en-US" b="0" dirty="0">
+                <a:latin typeface="+mj-lt"/>
+                <a:ea typeface="Cambria Math" panose="02040503050406030204" pitchFamily="18" charset="0"/>
+              </a:rPr>
+              <a:t>The “state” of a system captures </a:t>
+            </a:r>
+            <a:r>
+              <a:rPr lang="en-US" dirty="0">
+                <a:latin typeface="+mj-lt"/>
+                <a:ea typeface="Cambria Math" panose="02040503050406030204" pitchFamily="18" charset="0"/>
+              </a:rPr>
+              <a:t>all the information needed to predict the system’s future behavior</a:t>
+            </a:r>
+          </a:p>
+          <a:p>
+            <a:pPr>
+              <a:lnSpc>
+                <a:spcPct val="110000"/>
+              </a:lnSpc>
+            </a:pPr>
+            <a:r>
+              <a:rPr lang="en-US" dirty="0">
+                <a:latin typeface="+mj-lt"/>
+                <a:ea typeface="Cambria Math" panose="02040503050406030204" pitchFamily="18" charset="0"/>
+              </a:rPr>
+              <a:t>Behavior of a system is a sequence of states</a:t>
+            </a:r>
+          </a:p>
+          <a:p>
+            <a:pPr>
+              <a:lnSpc>
+                <a:spcPct val="110000"/>
+              </a:lnSpc>
+            </a:pPr>
+            <a:r>
+              <a:rPr lang="en-US" i="1" dirty="0">
+                <a:latin typeface="+mj-lt"/>
+                <a:ea typeface="Cambria Math" panose="02040503050406030204" pitchFamily="18" charset="0"/>
+              </a:rPr>
+              <a:t>Our ultimate goal: write programs that prove properties about all behaviors of a system</a:t>
+            </a:r>
+          </a:p>
+          <a:p>
+            <a:pPr>
+              <a:lnSpc>
+                <a:spcPct val="110000"/>
+              </a:lnSpc>
+            </a:pPr>
+            <a:r>
+              <a:rPr lang="en-US" dirty="0">
+                <a:latin typeface="+mj-lt"/>
+                <a:ea typeface="Cambria Math" panose="02040503050406030204" pitchFamily="18" charset="0"/>
+              </a:rPr>
+              <a:t>“Transitions” capture how the state can change</a:t>
+            </a:r>
+          </a:p>
+        </p:txBody>
+      </p:sp>
+    </p:spTree>
+    <p:extLst>
+      <p:ext uri="{BB962C8B-B14F-4D97-AF65-F5344CB8AC3E}">
+        <p14:creationId xmlns:p14="http://schemas.microsoft.com/office/powerpoint/2010/main" val="3978938520"/>
+      </p:ext>
+    </p:extLst>
+  </p:cSld>
+  <p:clrMapOvr>
+    <a:masterClrMapping/>
+  </p:clrMapOvr>
+  <p:timing>
+    <p:tnLst>
+      <p:par>
+        <p:cTn id="1" dur="indefinite" restart="never" nodeType="tmRoot">
+          <p:childTnLst>
+            <p:seq concurrent="1" nextAc="seek">
+              <p:cTn id="2" dur="indefinite" nodeType="mainSeq">
+                <p:childTnLst>
+                  <p:par>
+                    <p:cTn id="3" fill="hold">
+                      <p:stCondLst>
+                        <p:cond delay="indefinite"/>
+                      </p:stCondLst>
+                      <p:childTnLst>
+                        <p:par>
+                          <p:cTn id="4" fill="hold">
+                            <p:stCondLst>
+                              <p:cond delay="0"/>
+                            </p:stCondLst>
+                            <p:childTnLst>
+                              <p:par>
+                                <p:cTn id="5" presetID="1" presetClass="entr" presetSubtype="0" fill="hold" nodeType="clickEffect">
+                                  <p:stCondLst>
+                                    <p:cond delay="0"/>
+                                  </p:stCondLst>
+                                  <p:childTnLst>
+                                    <p:set>
+                                      <p:cBhvr>
+                                        <p:cTn id="6" dur="1" fill="hold">
+                                          <p:stCondLst>
+                                            <p:cond delay="0"/>
+                                          </p:stCondLst>
+                                        </p:cTn>
+                                        <p:tgtEl>
+                                          <p:spTgt spid="3">
+                                            <p:txEl>
+                                              <p:pRg st="2" end="2"/>
+                                            </p:txEl>
+                                          </p:spTgt>
+                                        </p:tgtEl>
+                                        <p:attrNameLst>
+                                          <p:attrName>style.visibility</p:attrName>
+                                        </p:attrNameLst>
+                                      </p:cBhvr>
+                                      <p:to>
+                                        <p:strVal val="visible"/>
+                                      </p:to>
+                                    </p:set>
+                                  </p:childTnLst>
+                                </p:cTn>
+                              </p:par>
+                            </p:childTnLst>
+                          </p:cTn>
+                        </p:par>
+                      </p:childTnLst>
+                    </p:cTn>
+                  </p:par>
+                  <p:par>
+                    <p:cTn id="7" fill="hold">
+                      <p:stCondLst>
+                        <p:cond delay="indefinite"/>
+                      </p:stCondLst>
+                      <p:childTnLst>
+                        <p:par>
+                          <p:cTn id="8" fill="hold">
+                            <p:stCondLst>
+                              <p:cond delay="0"/>
+                            </p:stCondLst>
+                            <p:childTnLst>
+                              <p:par>
+                                <p:cTn id="9" presetID="1" presetClass="entr" presetSubtype="0" fill="hold" nodeType="clickEffect">
+                                  <p:stCondLst>
+                                    <p:cond delay="0"/>
+                                  </p:stCondLst>
+                                  <p:childTnLst>
+                                    <p:set>
+                                      <p:cBhvr>
+                                        <p:cTn id="10" dur="1" fill="hold">
+                                          <p:stCondLst>
+                                            <p:cond delay="0"/>
+                                          </p:stCondLst>
+                                        </p:cTn>
+                                        <p:tgtEl>
+                                          <p:spTgt spid="3">
+                                            <p:txEl>
+                                              <p:pRg st="3" end="3"/>
+                                            </p:txEl>
+                                          </p:spTgt>
+                                        </p:tgtEl>
+                                        <p:attrNameLst>
+                                          <p:attrName>style.visibility</p:attrName>
+                                        </p:attrNameLst>
+                                      </p:cBhvr>
+                                      <p:to>
+                                        <p:strVal val="visible"/>
+                                      </p:to>
+                                    </p:set>
+                                  </p:childTnLst>
+                                </p:cTn>
+                              </p:par>
+                            </p:childTnLst>
+                          </p:cTn>
+                        </p:par>
+                      </p:childTnLst>
+                    </p:cTn>
+                  </p:par>
+                </p:childTnLst>
+              </p:cTn>
+              <p:prevCondLst>
+                <p:cond evt="onPrev" delay="0">
+                  <p:tgtEl>
+                    <p:sldTgt/>
+                  </p:tgtEl>
+                </p:cond>
+              </p:prevCondLst>
+              <p:nextCondLst>
+                <p:cond evt="onNext" delay="0">
+                  <p:tgtEl>
+                    <p:sldTgt/>
+                  </p:tgtEl>
+                </p:cond>
+              </p:nextCondLst>
+            </p:seq>
+          </p:childTnLst>
+        </p:cTn>
+      </p:par>
+    </p:tnLst>
+  </p:timing>
+</p:sld>
+</file>
+
+<file path=ppt/slides/slide30.xml><?xml version="1.0" encoding="utf-8"?>
 <p:sld xmlns:a="http://schemas.openxmlformats.org/drawingml/2006/main" xmlns:r="http://schemas.openxmlformats.org/officeDocument/2006/relationships" xmlns:p="http://schemas.openxmlformats.org/presentationml/2006/main">
   <p:cSld>
     <p:spTree>
@@ -20526,285 +20923,7 @@
 </p:sld>
 </file>
 
-<file path=ppt/slides/slide3.xml><?xml version="1.0" encoding="utf-8"?>
-<p:sld xmlns:a="http://schemas.openxmlformats.org/drawingml/2006/main" xmlns:r="http://schemas.openxmlformats.org/officeDocument/2006/relationships" xmlns:p="http://schemas.openxmlformats.org/presentationml/2006/main">
-  <p:cSld>
-    <p:spTree>
-      <p:nvGrpSpPr>
-        <p:cNvPr id="1" name=""/>
-        <p:cNvGrpSpPr/>
-        <p:nvPr/>
-      </p:nvGrpSpPr>
-      <p:grpSpPr>
-        <a:xfrm>
-          <a:off x="0" y="0"/>
-          <a:ext cx="0" cy="0"/>
-          <a:chOff x="0" y="0"/>
-          <a:chExt cx="0" cy="0"/>
-        </a:xfrm>
-      </p:grpSpPr>
-      <p:sp>
-        <p:nvSpPr>
-          <p:cNvPr id="2" name="Title 1">
-            <a:extLst>
-              <a:ext uri="{FF2B5EF4-FFF2-40B4-BE49-F238E27FC236}">
-                <a16:creationId xmlns:a16="http://schemas.microsoft.com/office/drawing/2014/main" id="{89A6E0D0-E74E-2B45-B640-A1E3517EF8C2}"/>
-              </a:ext>
-            </a:extLst>
-          </p:cNvPr>
-          <p:cNvSpPr>
-            <a:spLocks noGrp="1"/>
-          </p:cNvSpPr>
-          <p:nvPr>
-            <p:ph type="title"/>
-          </p:nvPr>
-        </p:nvSpPr>
-        <p:spPr/>
-        <p:txBody>
-          <a:bodyPr/>
-          <a:lstStyle/>
-          <a:p>
-            <a:r>
-              <a:rPr lang="en-US" dirty="0"/>
-              <a:t>Automata or discrete transition systems</a:t>
-            </a:r>
-          </a:p>
-        </p:txBody>
-      </p:sp>
-      <p:sp>
-        <p:nvSpPr>
-          <p:cNvPr id="3" name="Content Placeholder 2">
-            <a:extLst>
-              <a:ext uri="{FF2B5EF4-FFF2-40B4-BE49-F238E27FC236}">
-                <a16:creationId xmlns:a16="http://schemas.microsoft.com/office/drawing/2014/main" id="{F147AA83-84E3-0342-8A94-AC07EADC2024}"/>
-              </a:ext>
-            </a:extLst>
-          </p:cNvPr>
-          <p:cNvSpPr>
-            <a:spLocks noGrp="1"/>
-          </p:cNvSpPr>
-          <p:nvPr>
-            <p:ph idx="1"/>
-          </p:nvPr>
-        </p:nvSpPr>
-        <p:spPr>
-          <a:xfrm>
-            <a:off x="838200" y="1560576"/>
-            <a:ext cx="10515600" cy="4932299"/>
-          </a:xfrm>
-        </p:spPr>
-        <p:txBody>
-          <a:bodyPr>
-            <a:normAutofit/>
-          </a:bodyPr>
-          <a:lstStyle/>
-          <a:p>
-            <a:pPr>
-              <a:lnSpc>
-                <a:spcPct val="110000"/>
-              </a:lnSpc>
-            </a:pPr>
-            <a:r>
-              <a:rPr lang="en-US" b="0" dirty="0">
-                <a:latin typeface="+mj-lt"/>
-                <a:ea typeface="Cambria Math" panose="02040503050406030204" pitchFamily="18" charset="0"/>
-              </a:rPr>
-              <a:t>The “state” of a system captures </a:t>
-            </a:r>
-            <a:r>
-              <a:rPr lang="en-US" dirty="0">
-                <a:latin typeface="+mj-lt"/>
-                <a:ea typeface="Cambria Math" panose="02040503050406030204" pitchFamily="18" charset="0"/>
-              </a:rPr>
-              <a:t>all the information needed to predict the system’s future behavior</a:t>
-            </a:r>
-          </a:p>
-          <a:p>
-            <a:pPr>
-              <a:lnSpc>
-                <a:spcPct val="110000"/>
-              </a:lnSpc>
-            </a:pPr>
-            <a:r>
-              <a:rPr lang="en-US" dirty="0">
-                <a:latin typeface="+mj-lt"/>
-                <a:ea typeface="Cambria Math" panose="02040503050406030204" pitchFamily="18" charset="0"/>
-              </a:rPr>
-              <a:t>Behavior of a system is a sequence of states</a:t>
-            </a:r>
-          </a:p>
-          <a:p>
-            <a:pPr>
-              <a:lnSpc>
-                <a:spcPct val="110000"/>
-              </a:lnSpc>
-            </a:pPr>
-            <a:r>
-              <a:rPr lang="en-US" i="1" dirty="0">
-                <a:latin typeface="+mj-lt"/>
-                <a:ea typeface="Cambria Math" panose="02040503050406030204" pitchFamily="18" charset="0"/>
-              </a:rPr>
-              <a:t>Our ultimate goal: write programs that prove properties about all behaviors of a system</a:t>
-            </a:r>
-          </a:p>
-          <a:p>
-            <a:pPr>
-              <a:lnSpc>
-                <a:spcPct val="110000"/>
-              </a:lnSpc>
-            </a:pPr>
-            <a:r>
-              <a:rPr lang="en-US" dirty="0">
-                <a:latin typeface="+mj-lt"/>
-                <a:ea typeface="Cambria Math" panose="02040503050406030204" pitchFamily="18" charset="0"/>
-              </a:rPr>
-              <a:t>“Transitions” capture how the state can change</a:t>
-            </a:r>
-          </a:p>
-        </p:txBody>
-      </p:sp>
-    </p:spTree>
-    <p:extLst>
-      <p:ext uri="{BB962C8B-B14F-4D97-AF65-F5344CB8AC3E}">
-        <p14:creationId xmlns:p14="http://schemas.microsoft.com/office/powerpoint/2010/main" val="3978938520"/>
-      </p:ext>
-    </p:extLst>
-  </p:cSld>
-  <p:clrMapOvr>
-    <a:masterClrMapping/>
-  </p:clrMapOvr>
-  <p:timing>
-    <p:tnLst>
-      <p:par>
-        <p:cTn id="1" dur="indefinite" restart="never" nodeType="tmRoot">
-          <p:childTnLst>
-            <p:seq concurrent="1" nextAc="seek">
-              <p:cTn id="2" dur="indefinite" nodeType="mainSeq">
-                <p:childTnLst>
-                  <p:par>
-                    <p:cTn id="3" fill="hold">
-                      <p:stCondLst>
-                        <p:cond delay="indefinite"/>
-                      </p:stCondLst>
-                      <p:childTnLst>
-                        <p:par>
-                          <p:cTn id="4" fill="hold">
-                            <p:stCondLst>
-                              <p:cond delay="0"/>
-                            </p:stCondLst>
-                            <p:childTnLst>
-                              <p:par>
-                                <p:cTn id="5" presetID="1" presetClass="entr" presetSubtype="0" fill="hold" nodeType="clickEffect">
-                                  <p:stCondLst>
-                                    <p:cond delay="0"/>
-                                  </p:stCondLst>
-                                  <p:childTnLst>
-                                    <p:set>
-                                      <p:cBhvr>
-                                        <p:cTn id="6" dur="1" fill="hold">
-                                          <p:stCondLst>
-                                            <p:cond delay="0"/>
-                                          </p:stCondLst>
-                                        </p:cTn>
-                                        <p:tgtEl>
-                                          <p:spTgt spid="3">
-                                            <p:txEl>
-                                              <p:pRg st="2" end="2"/>
-                                            </p:txEl>
-                                          </p:spTgt>
-                                        </p:tgtEl>
-                                        <p:attrNameLst>
-                                          <p:attrName>style.visibility</p:attrName>
-                                        </p:attrNameLst>
-                                      </p:cBhvr>
-                                      <p:to>
-                                        <p:strVal val="visible"/>
-                                      </p:to>
-                                    </p:set>
-                                  </p:childTnLst>
-                                </p:cTn>
-                              </p:par>
-                            </p:childTnLst>
-                          </p:cTn>
-                        </p:par>
-                      </p:childTnLst>
-                    </p:cTn>
-                  </p:par>
-                  <p:par>
-                    <p:cTn id="7" fill="hold">
-                      <p:stCondLst>
-                        <p:cond delay="indefinite"/>
-                      </p:stCondLst>
-                      <p:childTnLst>
-                        <p:par>
-                          <p:cTn id="8" fill="hold">
-                            <p:stCondLst>
-                              <p:cond delay="0"/>
-                            </p:stCondLst>
-                            <p:childTnLst>
-                              <p:par>
-                                <p:cTn id="9" presetID="1" presetClass="entr" presetSubtype="0" fill="hold" nodeType="clickEffect">
-                                  <p:stCondLst>
-                                    <p:cond delay="0"/>
-                                  </p:stCondLst>
-                                  <p:childTnLst>
-                                    <p:set>
-                                      <p:cBhvr>
-                                        <p:cTn id="10" dur="1" fill="hold">
-                                          <p:stCondLst>
-                                            <p:cond delay="0"/>
-                                          </p:stCondLst>
-                                        </p:cTn>
-                                        <p:tgtEl>
-                                          <p:spTgt spid="3">
-                                            <p:txEl>
-                                              <p:pRg st="3" end="3"/>
-                                            </p:txEl>
-                                          </p:spTgt>
-                                        </p:tgtEl>
-                                        <p:attrNameLst>
-                                          <p:attrName>style.visibility</p:attrName>
-                                        </p:attrNameLst>
-                                      </p:cBhvr>
-                                      <p:to>
-                                        <p:strVal val="visible"/>
-                                      </p:to>
-                                    </p:set>
-                                  </p:childTnLst>
-                                </p:cTn>
-                              </p:par>
-                            </p:childTnLst>
-                          </p:cTn>
-                        </p:par>
-                      </p:childTnLst>
-                    </p:cTn>
-                  </p:par>
-                </p:childTnLst>
-              </p:cTn>
-              <p:prevCondLst>
-                <p:cond evt="onPrev" delay="0">
-                  <p:tgtEl>
-                    <p:sldTgt/>
-                  </p:tgtEl>
-                </p:cond>
-              </p:prevCondLst>
-              <p:nextCondLst>
-                <p:cond evt="onNext" delay="0">
-                  <p:tgtEl>
-                    <p:sldTgt/>
-                  </p:tgtEl>
-                </p:cond>
-              </p:nextCondLst>
-            </p:seq>
-          </p:childTnLst>
-        </p:cTn>
-      </p:par>
-    </p:tnLst>
-  </p:timing>
-</p:sld>
-</file>
-
-<file path=ppt/slides/slide30.xml><?xml version="1.0" encoding="utf-8"?>
+<file path=ppt/slides/slide31.xml><?xml version="1.0" encoding="utf-8"?>
 <p:sld xmlns:a="http://schemas.openxmlformats.org/drawingml/2006/main" xmlns:r="http://schemas.openxmlformats.org/officeDocument/2006/relationships" xmlns:p="http://schemas.openxmlformats.org/presentationml/2006/main">
   <p:cSld>
     <p:spTree>
@@ -22540,7 +22659,7 @@
 </p:sld>
 </file>
 
-<file path=ppt/slides/slide31.xml><?xml version="1.0" encoding="utf-8"?>
+<file path=ppt/slides/slide32.xml><?xml version="1.0" encoding="utf-8"?>
 <p:sld xmlns:a="http://schemas.openxmlformats.org/drawingml/2006/main" xmlns:r="http://schemas.openxmlformats.org/officeDocument/2006/relationships" xmlns:p="http://schemas.openxmlformats.org/presentationml/2006/main">
   <p:cSld>
     <p:spTree>
@@ -26524,7 +26643,7 @@
 </p:sld>
 </file>
 
-<file path=ppt/slides/slide32.xml><?xml version="1.0" encoding="utf-8"?>
+<file path=ppt/slides/slide33.xml><?xml version="1.0" encoding="utf-8"?>
 <p:sld xmlns:a="http://schemas.openxmlformats.org/drawingml/2006/main" xmlns:r="http://schemas.openxmlformats.org/officeDocument/2006/relationships" xmlns:p="http://schemas.openxmlformats.org/presentationml/2006/main">
   <p:cSld>
     <p:spTree>
@@ -26631,7 +26750,7 @@
 </p:sld>
 </file>
 
-<file path=ppt/slides/slide33.xml><?xml version="1.0" encoding="utf-8"?>
+<file path=ppt/slides/slide34.xml><?xml version="1.0" encoding="utf-8"?>
 <p:sld xmlns:a="http://schemas.openxmlformats.org/drawingml/2006/main" xmlns:r="http://schemas.openxmlformats.org/officeDocument/2006/relationships" xmlns:p="http://schemas.openxmlformats.org/presentationml/2006/main">
   <p:cSld>
     <p:spTree>
@@ -26702,7 +26821,7 @@
 </p:sld>
 </file>
 
-<file path=ppt/slides/slide34.xml><?xml version="1.0" encoding="utf-8"?>
+<file path=ppt/slides/slide35.xml><?xml version="1.0" encoding="utf-8"?>
 <p:sld xmlns:a="http://schemas.openxmlformats.org/drawingml/2006/main" xmlns:r="http://schemas.openxmlformats.org/officeDocument/2006/relationships" xmlns:p="http://schemas.openxmlformats.org/presentationml/2006/main">
   <p:cSld>
     <p:spTree>

</xml_diff>